<commit_message>
Redraw slide 11 so the day-service relationship is a picture
The collaboration slide carried its key message — that day service and
home bathing complement rather than compete — as two paragraphs of body
text. The lower half is now an ADL timeline: a day-service band on the
left, a home-bathing band running to the right, and a shaded overlap
marked 併用期. The partner cards keep one short phrase each instead of
two, and a single arrow reads from the hub rather than one per card.

Co-Authored-By: Claude Opus 5 <noreply@anthropic.com>
Claude-Session: https://claude.ai/code/session_01EuVvTjbyv3WUxHVeG4YeGS
</commit_message>
<xml_diff>
--- a/houmon-nyuyoku-slides.pptx
+++ b/houmon-nyuyoku-slides.pptx
@@ -3642,153 +3642,765 @@
       </p:sp>
       <p:sp>
         <p:nvSpPr>
-          <p:cNvPr id="6" name="Shape 4"/>
+          <p:cNvPr id="6" name="Rounded Rectangle 5"/>
           <p:cNvSpPr/>
           <p:nvPr/>
         </p:nvSpPr>
         <p:spPr>
           <a:xfrm>
-            <a:off x="566928" y="1700784"/>
-            <a:ext cx="2286000" cy="1481328"/>
+            <a:off x="566928" y="1645920"/>
+            <a:ext cx="2377440" cy="1554480"/>
           </a:xfrm>
           <a:prstGeom prst="roundRect">
             <a:avLst>
-              <a:gd name="adj" fmla="val 4321"/>
+              <a:gd name="adj" fmla="val 5882"/>
             </a:avLst>
           </a:prstGeom>
           <a:solidFill>
             <a:srgbClr val="1D9E75"/>
           </a:solidFill>
-          <a:ln w="12700">
-            <a:solidFill>
-              <a:srgbClr val="1D9E75"/>
-            </a:solidFill>
-            <a:prstDash val="solid"/>
+          <a:ln>
+            <a:noFill/>
           </a:ln>
-        </p:spPr>
-        <p:txBody>
-          <a:bodyPr/>
-          <a:lstStyle/>
-          <a:p>
-            <a:endParaRPr lang="ja-JP" altLang="en-US"/>
-          </a:p>
-        </p:txBody>
-      </p:sp>
-      <p:sp>
-        <p:nvSpPr>
-          <p:cNvPr id="7" name="Text 5"/>
+          <a:effectLst/>
+        </p:spPr>
+        <p:style>
+          <a:lnRef idx="1">
+            <a:schemeClr val="accent1"/>
+          </a:lnRef>
+          <a:fillRef idx="3">
+            <a:schemeClr val="accent1"/>
+          </a:fillRef>
+          <a:effectRef idx="2">
+            <a:schemeClr val="accent1"/>
+          </a:effectRef>
+          <a:fontRef idx="minor">
+            <a:schemeClr val="lt1"/>
+          </a:fontRef>
+        </p:style>
+        <p:txBody>
+          <a:bodyPr rtlCol="0" anchor="ctr"/>
+          <a:lstStyle/>
+          <a:p>
+            <a:pPr algn="ctr"/>
+          </a:p>
+        </p:txBody>
+      </p:sp>
+      <p:sp>
+        <p:nvSpPr>
+          <p:cNvPr id="7" name="TextBox 6"/>
           <p:cNvSpPr txBox="1"/>
           <p:nvPr/>
         </p:nvSpPr>
         <p:spPr>
           <a:xfrm>
-            <a:off x="658368" y="1700784"/>
-            <a:ext cx="2103120" cy="1481328"/>
+            <a:off x="658368" y="1645920"/>
+            <a:ext cx="2194560" cy="1554480"/>
           </a:xfrm>
           <a:prstGeom prst="rect">
             <a:avLst/>
           </a:prstGeom>
           <a:noFill/>
-          <a:ln/>
-        </p:spPr>
-        <p:txBody>
-          <a:bodyPr wrap="square" lIns="0" tIns="0" rIns="0" bIns="0" rtlCol="0" anchor="ctr"/>
-          <a:lstStyle/>
-          <a:p>
-            <a:pPr marL="0" indent="0" algn="ctr">
-              <a:lnSpc>
-                <a:spcPct val="130000"/>
-              </a:lnSpc>
-              <a:buNone/>
+        </p:spPr>
+        <p:txBody>
+          <a:bodyPr wrap="square" anchor="ctr" lIns="0" rIns="0" tIns="0" bIns="0">
+            <a:spAutoFit/>
+          </a:bodyPr>
+          <a:lstStyle/>
+          <a:p>
+            <a:pPr algn="ctr"/>
+            <a:r>
+              <a:rPr sz="1500" b="1">
+                <a:solidFill>
+                  <a:srgbClr val="FFFFFF"/>
+                </a:solidFill>
+                <a:latin typeface="Meiryo"/>
+              </a:rPr>
+              <a:t>訪問入浴介護</a:t>
+            </a:r>
+          </a:p>
+          <a:p>
+            <a:pPr algn="ctr">
+              <a:spcBef>
+                <a:spcPts val="600"/>
+              </a:spcBef>
             </a:pPr>
             <a:r>
-              <a:rPr lang="en-US" sz="1600" b="1" dirty="0">
+              <a:rPr sz="1050" b="0">
                 <a:solidFill>
                   <a:srgbClr val="FFFFFF"/>
                 </a:solidFill>
-                <a:latin typeface="Meiryo" pitchFamily="34" charset="0"/>
-                <a:ea typeface="Meiryo" pitchFamily="34" charset="-122"/>
-                <a:cs typeface="Meiryo" pitchFamily="34" charset="-120"/>
-              </a:rPr>
-              <a:t>訪問入浴介護</a:t>
-            </a:r>
-            <a:endParaRPr lang="en-US" sz="1600" dirty="0"/>
-          </a:p>
-          <a:p>
-            <a:pPr marL="0" indent="0" algn="ctr">
-              <a:lnSpc>
-                <a:spcPct val="130000"/>
-              </a:lnSpc>
-              <a:buNone/>
-            </a:pPr>
-            <a:r>
-              <a:rPr lang="en-US" sz="1050" dirty="0">
-                <a:solidFill>
-                  <a:srgbClr val="D6F3E6"/>
-                </a:solidFill>
-                <a:latin typeface="Meiryo" pitchFamily="34" charset="0"/>
-                <a:ea typeface="Meiryo" pitchFamily="34" charset="-122"/>
-                <a:cs typeface="Meiryo" pitchFamily="34" charset="-120"/>
+                <a:latin typeface="Meiryo"/>
               </a:rPr>
               <a:t>看護師1名＋介護2名</a:t>
             </a:r>
-            <a:endParaRPr lang="en-US" sz="1600" dirty="0"/>
-          </a:p>
-        </p:txBody>
-      </p:sp>
-      <p:sp>
-        <p:nvSpPr>
-          <p:cNvPr id="8" name="Text 6"/>
+          </a:p>
+        </p:txBody>
+      </p:sp>
+      <p:sp>
+        <p:nvSpPr>
+          <p:cNvPr id="8" name="Rounded Rectangle 7"/>
+          <p:cNvSpPr/>
+          <p:nvPr/>
+        </p:nvSpPr>
+        <p:spPr>
+          <a:xfrm>
+            <a:off x="3566160" y="1645920"/>
+            <a:ext cx="3931920" cy="713232"/>
+          </a:xfrm>
+          <a:prstGeom prst="roundRect">
+            <a:avLst>
+              <a:gd name="adj" fmla="val 12820"/>
+            </a:avLst>
+          </a:prstGeom>
+          <a:solidFill>
+            <a:srgbClr val="F4F8FA"/>
+          </a:solidFill>
+          <a:ln>
+            <a:noFill/>
+          </a:ln>
+          <a:effectLst/>
+        </p:spPr>
+        <p:style>
+          <a:lnRef idx="1">
+            <a:schemeClr val="accent1"/>
+          </a:lnRef>
+          <a:fillRef idx="3">
+            <a:schemeClr val="accent1"/>
+          </a:fillRef>
+          <a:effectRef idx="2">
+            <a:schemeClr val="accent1"/>
+          </a:effectRef>
+          <a:fontRef idx="minor">
+            <a:schemeClr val="lt1"/>
+          </a:fontRef>
+        </p:style>
+        <p:txBody>
+          <a:bodyPr rtlCol="0" anchor="ctr"/>
+          <a:lstStyle/>
+          <a:p>
+            <a:pPr algn="ctr"/>
+          </a:p>
+        </p:txBody>
+      </p:sp>
+      <p:sp>
+        <p:nvSpPr>
+          <p:cNvPr id="9" name="TextBox 8"/>
           <p:cNvSpPr txBox="1"/>
           <p:nvPr/>
         </p:nvSpPr>
         <p:spPr>
           <a:xfrm>
-            <a:off x="2907792" y="1700784"/>
-            <a:ext cx="384048" cy="1481328"/>
+            <a:off x="3767328" y="1645920"/>
+            <a:ext cx="2103120" cy="713232"/>
           </a:xfrm>
           <a:prstGeom prst="rect">
             <a:avLst/>
           </a:prstGeom>
           <a:noFill/>
-          <a:ln/>
-        </p:spPr>
-        <p:txBody>
-          <a:bodyPr wrap="square" lIns="0" tIns="0" rIns="0" bIns="0" rtlCol="0" anchor="ctr"/>
-          <a:lstStyle/>
-          <a:p>
-            <a:pPr marL="0" indent="0" algn="ctr">
-              <a:buNone/>
-            </a:pPr>
-            <a:r>
-              <a:rPr lang="en-US" sz="2200" b="1" dirty="0">
+        </p:spPr>
+        <p:txBody>
+          <a:bodyPr wrap="square" anchor="ctr" lIns="0" rIns="0" tIns="0" bIns="0">
+            <a:spAutoFit/>
+          </a:bodyPr>
+          <a:lstStyle/>
+          <a:p>
+            <a:pPr algn="l"/>
+            <a:r>
+              <a:rPr sz="1350" b="1">
+                <a:solidFill>
+                  <a:srgbClr val="1A5276"/>
+                </a:solidFill>
+                <a:latin typeface="Meiryo"/>
+              </a:rPr>
+              <a:t>主治医・在宅医</a:t>
+            </a:r>
+          </a:p>
+        </p:txBody>
+      </p:sp>
+      <p:sp>
+        <p:nvSpPr>
+          <p:cNvPr id="10" name="TextBox 9"/>
+          <p:cNvSpPr txBox="1"/>
+          <p:nvPr/>
+        </p:nvSpPr>
+        <p:spPr>
+          <a:xfrm>
+            <a:off x="5806440" y="1645920"/>
+            <a:ext cx="1554480" cy="713232"/>
+          </a:xfrm>
+          <a:prstGeom prst="rect">
+            <a:avLst/>
+          </a:prstGeom>
+          <a:noFill/>
+        </p:spPr>
+        <p:txBody>
+          <a:bodyPr wrap="square" anchor="ctr" lIns="0" rIns="0" tIns="0" bIns="0">
+            <a:spAutoFit/>
+          </a:bodyPr>
+          <a:lstStyle/>
+          <a:p>
+            <a:pPr algn="r"/>
+            <a:r>
+              <a:rPr sz="1050" b="0">
+                <a:solidFill>
+                  <a:srgbClr val="566573"/>
+                </a:solidFill>
+                <a:latin typeface="Meiryo"/>
+              </a:rPr>
+              <a:t>創部・全身状態の報告</a:t>
+            </a:r>
+          </a:p>
+        </p:txBody>
+      </p:sp>
+      <p:sp>
+        <p:nvSpPr>
+          <p:cNvPr id="11" name="TextBox 10"/>
+          <p:cNvSpPr txBox="1"/>
+          <p:nvPr/>
+        </p:nvSpPr>
+        <p:spPr>
+          <a:xfrm>
+            <a:off x="3090672" y="1645920"/>
+            <a:ext cx="402336" cy="713232"/>
+          </a:xfrm>
+          <a:prstGeom prst="rect">
+            <a:avLst/>
+          </a:prstGeom>
+          <a:noFill/>
+        </p:spPr>
+        <p:txBody>
+          <a:bodyPr wrap="square" anchor="ctr" lIns="0" rIns="0" tIns="0" bIns="0">
+            <a:spAutoFit/>
+          </a:bodyPr>
+          <a:lstStyle/>
+          <a:p>
+            <a:pPr algn="ctr"/>
+            <a:r>
+              <a:rPr sz="1700" b="1">
                 <a:solidFill>
                   <a:srgbClr val="1D9E75"/>
                 </a:solidFill>
-                <a:latin typeface="Meiryo" pitchFamily="34" charset="0"/>
-                <a:ea typeface="Meiryo" pitchFamily="34" charset="-122"/>
-                <a:cs typeface="Meiryo" pitchFamily="34" charset="-120"/>
+                <a:latin typeface="Meiryo"/>
               </a:rPr>
               <a:t>⇄</a:t>
             </a:r>
-            <a:endParaRPr lang="en-US" sz="2200" dirty="0"/>
-          </a:p>
-        </p:txBody>
-      </p:sp>
-      <p:sp>
-        <p:nvSpPr>
-          <p:cNvPr id="9" name="Shape 7"/>
+          </a:p>
+        </p:txBody>
+      </p:sp>
+      <p:sp>
+        <p:nvSpPr>
+          <p:cNvPr id="12" name="Rounded Rectangle 11"/>
           <p:cNvSpPr/>
           <p:nvPr/>
         </p:nvSpPr>
         <p:spPr>
           <a:xfrm>
-            <a:off x="3364992" y="1700784"/>
-            <a:ext cx="4029304" cy="676656"/>
+            <a:off x="7680960" y="1645920"/>
+            <a:ext cx="3931920" cy="713232"/>
           </a:xfrm>
           <a:prstGeom prst="roundRect">
             <a:avLst>
-              <a:gd name="adj" fmla="val 6757"/>
+              <a:gd name="adj" fmla="val 12820"/>
+            </a:avLst>
+          </a:prstGeom>
+          <a:solidFill>
+            <a:srgbClr val="F4F8FA"/>
+          </a:solidFill>
+          <a:ln>
+            <a:noFill/>
+          </a:ln>
+          <a:effectLst/>
+        </p:spPr>
+        <p:style>
+          <a:lnRef idx="1">
+            <a:schemeClr val="accent1"/>
+          </a:lnRef>
+          <a:fillRef idx="3">
+            <a:schemeClr val="accent1"/>
+          </a:fillRef>
+          <a:effectRef idx="2">
+            <a:schemeClr val="accent1"/>
+          </a:effectRef>
+          <a:fontRef idx="minor">
+            <a:schemeClr val="lt1"/>
+          </a:fontRef>
+        </p:style>
+        <p:txBody>
+          <a:bodyPr rtlCol="0" anchor="ctr"/>
+          <a:lstStyle/>
+          <a:p>
+            <a:pPr algn="ctr"/>
+          </a:p>
+        </p:txBody>
+      </p:sp>
+      <p:sp>
+        <p:nvSpPr>
+          <p:cNvPr id="13" name="TextBox 12"/>
+          <p:cNvSpPr txBox="1"/>
+          <p:nvPr/>
+        </p:nvSpPr>
+        <p:spPr>
+          <a:xfrm>
+            <a:off x="7882128" y="1645920"/>
+            <a:ext cx="2103120" cy="713232"/>
+          </a:xfrm>
+          <a:prstGeom prst="rect">
+            <a:avLst/>
+          </a:prstGeom>
+          <a:noFill/>
+        </p:spPr>
+        <p:txBody>
+          <a:bodyPr wrap="square" anchor="ctr" lIns="0" rIns="0" tIns="0" bIns="0">
+            <a:spAutoFit/>
+          </a:bodyPr>
+          <a:lstStyle/>
+          <a:p>
+            <a:pPr algn="l"/>
+            <a:r>
+              <a:rPr sz="1350" b="1">
+                <a:solidFill>
+                  <a:srgbClr val="1A5276"/>
+                </a:solidFill>
+                <a:latin typeface="Meiryo"/>
+              </a:rPr>
+              <a:t>訪問看護ステーション</a:t>
+            </a:r>
+          </a:p>
+        </p:txBody>
+      </p:sp>
+      <p:sp>
+        <p:nvSpPr>
+          <p:cNvPr id="14" name="TextBox 13"/>
+          <p:cNvSpPr txBox="1"/>
+          <p:nvPr/>
+        </p:nvSpPr>
+        <p:spPr>
+          <a:xfrm>
+            <a:off x="9921240" y="1645920"/>
+            <a:ext cx="1554480" cy="713232"/>
+          </a:xfrm>
+          <a:prstGeom prst="rect">
+            <a:avLst/>
+          </a:prstGeom>
+          <a:noFill/>
+        </p:spPr>
+        <p:txBody>
+          <a:bodyPr wrap="square" anchor="ctr" lIns="0" rIns="0" tIns="0" bIns="0">
+            <a:spAutoFit/>
+          </a:bodyPr>
+          <a:lstStyle/>
+          <a:p>
+            <a:pPr algn="r"/>
+            <a:r>
+              <a:rPr sz="1050" b="0">
+                <a:solidFill>
+                  <a:srgbClr val="566573"/>
+                </a:solidFill>
+                <a:latin typeface="Meiryo"/>
+              </a:rPr>
+              <a:t>観察所見の共有</a:t>
+            </a:r>
+          </a:p>
+        </p:txBody>
+      </p:sp>
+      <p:sp>
+        <p:nvSpPr>
+          <p:cNvPr id="15" name="Rounded Rectangle 14"/>
+          <p:cNvSpPr/>
+          <p:nvPr/>
+        </p:nvSpPr>
+        <p:spPr>
+          <a:xfrm>
+            <a:off x="3566160" y="2487168"/>
+            <a:ext cx="3931920" cy="713232"/>
+          </a:xfrm>
+          <a:prstGeom prst="roundRect">
+            <a:avLst>
+              <a:gd name="adj" fmla="val 12820"/>
+            </a:avLst>
+          </a:prstGeom>
+          <a:solidFill>
+            <a:srgbClr val="F4F8FA"/>
+          </a:solidFill>
+          <a:ln>
+            <a:noFill/>
+          </a:ln>
+          <a:effectLst/>
+        </p:spPr>
+        <p:style>
+          <a:lnRef idx="1">
+            <a:schemeClr val="accent1"/>
+          </a:lnRef>
+          <a:fillRef idx="3">
+            <a:schemeClr val="accent1"/>
+          </a:fillRef>
+          <a:effectRef idx="2">
+            <a:schemeClr val="accent1"/>
+          </a:effectRef>
+          <a:fontRef idx="minor">
+            <a:schemeClr val="lt1"/>
+          </a:fontRef>
+        </p:style>
+        <p:txBody>
+          <a:bodyPr rtlCol="0" anchor="ctr"/>
+          <a:lstStyle/>
+          <a:p>
+            <a:pPr algn="ctr"/>
+          </a:p>
+        </p:txBody>
+      </p:sp>
+      <p:sp>
+        <p:nvSpPr>
+          <p:cNvPr id="16" name="TextBox 15"/>
+          <p:cNvSpPr txBox="1"/>
+          <p:nvPr/>
+        </p:nvSpPr>
+        <p:spPr>
+          <a:xfrm>
+            <a:off x="3767328" y="2487168"/>
+            <a:ext cx="2103120" cy="713232"/>
+          </a:xfrm>
+          <a:prstGeom prst="rect">
+            <a:avLst/>
+          </a:prstGeom>
+          <a:noFill/>
+        </p:spPr>
+        <p:txBody>
+          <a:bodyPr wrap="square" anchor="ctr" lIns="0" rIns="0" tIns="0" bIns="0">
+            <a:spAutoFit/>
+          </a:bodyPr>
+          <a:lstStyle/>
+          <a:p>
+            <a:pPr algn="l"/>
+            <a:r>
+              <a:rPr sz="1350" b="1">
+                <a:solidFill>
+                  <a:srgbClr val="1A5276"/>
+                </a:solidFill>
+                <a:latin typeface="Meiryo"/>
+              </a:rPr>
+              <a:t>ケアマネジャー</a:t>
+            </a:r>
+          </a:p>
+        </p:txBody>
+      </p:sp>
+      <p:sp>
+        <p:nvSpPr>
+          <p:cNvPr id="17" name="TextBox 16"/>
+          <p:cNvSpPr txBox="1"/>
+          <p:nvPr/>
+        </p:nvSpPr>
+        <p:spPr>
+          <a:xfrm>
+            <a:off x="5806440" y="2487168"/>
+            <a:ext cx="1554480" cy="713232"/>
+          </a:xfrm>
+          <a:prstGeom prst="rect">
+            <a:avLst/>
+          </a:prstGeom>
+          <a:noFill/>
+        </p:spPr>
+        <p:txBody>
+          <a:bodyPr wrap="square" anchor="ctr" lIns="0" rIns="0" tIns="0" bIns="0">
+            <a:spAutoFit/>
+          </a:bodyPr>
+          <a:lstStyle/>
+          <a:p>
+            <a:pPr algn="r"/>
+            <a:r>
+              <a:rPr sz="1050" b="0">
+                <a:solidFill>
+                  <a:srgbClr val="566573"/>
+                </a:solidFill>
+                <a:latin typeface="Meiryo"/>
+              </a:rPr>
+              <a:t>状態変化の報告</a:t>
+            </a:r>
+          </a:p>
+        </p:txBody>
+      </p:sp>
+      <p:sp>
+        <p:nvSpPr>
+          <p:cNvPr id="18" name="TextBox 17"/>
+          <p:cNvSpPr txBox="1"/>
+          <p:nvPr/>
+        </p:nvSpPr>
+        <p:spPr>
+          <a:xfrm>
+            <a:off x="3090672" y="2487168"/>
+            <a:ext cx="402336" cy="713232"/>
+          </a:xfrm>
+          <a:prstGeom prst="rect">
+            <a:avLst/>
+          </a:prstGeom>
+          <a:noFill/>
+        </p:spPr>
+        <p:txBody>
+          <a:bodyPr wrap="square" anchor="ctr" lIns="0" rIns="0" tIns="0" bIns="0">
+            <a:spAutoFit/>
+          </a:bodyPr>
+          <a:lstStyle/>
+          <a:p>
+            <a:pPr algn="ctr"/>
+            <a:r>
+              <a:rPr sz="1700" b="1">
+                <a:solidFill>
+                  <a:srgbClr val="1D9E75"/>
+                </a:solidFill>
+                <a:latin typeface="Meiryo"/>
+              </a:rPr>
+              <a:t>⇄</a:t>
+            </a:r>
+          </a:p>
+        </p:txBody>
+      </p:sp>
+      <p:sp>
+        <p:nvSpPr>
+          <p:cNvPr id="19" name="Rounded Rectangle 18"/>
+          <p:cNvSpPr/>
+          <p:nvPr/>
+        </p:nvSpPr>
+        <p:spPr>
+          <a:xfrm>
+            <a:off x="7680960" y="2487168"/>
+            <a:ext cx="3931920" cy="713232"/>
+          </a:xfrm>
+          <a:prstGeom prst="roundRect">
+            <a:avLst>
+              <a:gd name="adj" fmla="val 12820"/>
+            </a:avLst>
+          </a:prstGeom>
+          <a:solidFill>
+            <a:srgbClr val="F4F8FA"/>
+          </a:solidFill>
+          <a:ln>
+            <a:noFill/>
+          </a:ln>
+          <a:effectLst/>
+        </p:spPr>
+        <p:style>
+          <a:lnRef idx="1">
+            <a:schemeClr val="accent1"/>
+          </a:lnRef>
+          <a:fillRef idx="3">
+            <a:schemeClr val="accent1"/>
+          </a:fillRef>
+          <a:effectRef idx="2">
+            <a:schemeClr val="accent1"/>
+          </a:effectRef>
+          <a:fontRef idx="minor">
+            <a:schemeClr val="lt1"/>
+          </a:fontRef>
+        </p:style>
+        <p:txBody>
+          <a:bodyPr rtlCol="0" anchor="ctr"/>
+          <a:lstStyle/>
+          <a:p>
+            <a:pPr algn="ctr"/>
+          </a:p>
+        </p:txBody>
+      </p:sp>
+      <p:sp>
+        <p:nvSpPr>
+          <p:cNvPr id="20" name="TextBox 19"/>
+          <p:cNvSpPr txBox="1"/>
+          <p:nvPr/>
+        </p:nvSpPr>
+        <p:spPr>
+          <a:xfrm>
+            <a:off x="7882128" y="2487168"/>
+            <a:ext cx="2103120" cy="713232"/>
+          </a:xfrm>
+          <a:prstGeom prst="rect">
+            <a:avLst/>
+          </a:prstGeom>
+          <a:noFill/>
+        </p:spPr>
+        <p:txBody>
+          <a:bodyPr wrap="square" anchor="ctr" lIns="0" rIns="0" tIns="0" bIns="0">
+            <a:spAutoFit/>
+          </a:bodyPr>
+          <a:lstStyle/>
+          <a:p>
+            <a:pPr algn="l"/>
+            <a:r>
+              <a:rPr sz="1350" b="1">
+                <a:solidFill>
+                  <a:srgbClr val="1A5276"/>
+                </a:solidFill>
+                <a:latin typeface="Meiryo"/>
+              </a:rPr>
+              <a:t>デイサービス・訪問介護</a:t>
+            </a:r>
+          </a:p>
+        </p:txBody>
+      </p:sp>
+      <p:sp>
+        <p:nvSpPr>
+          <p:cNvPr id="21" name="TextBox 20"/>
+          <p:cNvSpPr txBox="1"/>
+          <p:nvPr/>
+        </p:nvSpPr>
+        <p:spPr>
+          <a:xfrm>
+            <a:off x="9921240" y="2487168"/>
+            <a:ext cx="1554480" cy="713232"/>
+          </a:xfrm>
+          <a:prstGeom prst="rect">
+            <a:avLst/>
+          </a:prstGeom>
+          <a:noFill/>
+        </p:spPr>
+        <p:txBody>
+          <a:bodyPr wrap="square" anchor="ctr" lIns="0" rIns="0" tIns="0" bIns="0">
+            <a:spAutoFit/>
+          </a:bodyPr>
+          <a:lstStyle/>
+          <a:p>
+            <a:pPr algn="r"/>
+            <a:r>
+              <a:rPr sz="1050" b="0">
+                <a:solidFill>
+                  <a:srgbClr val="566573"/>
+                </a:solidFill>
+                <a:latin typeface="Meiryo"/>
+              </a:rPr>
+              <a:t>入浴日の分担</a:t>
+            </a:r>
+          </a:p>
+        </p:txBody>
+      </p:sp>
+      <p:sp>
+        <p:nvSpPr>
+          <p:cNvPr id="22" name="TextBox 21"/>
+          <p:cNvSpPr txBox="1"/>
+          <p:nvPr/>
+        </p:nvSpPr>
+        <p:spPr>
+          <a:xfrm>
+            <a:off x="566928" y="3529584"/>
+            <a:ext cx="11045952" cy="310896"/>
+          </a:xfrm>
+          <a:prstGeom prst="rect">
+            <a:avLst/>
+          </a:prstGeom>
+          <a:noFill/>
+        </p:spPr>
+        <p:txBody>
+          <a:bodyPr wrap="square" anchor="t" lIns="0" rIns="0" tIns="0" bIns="0">
+            <a:spAutoFit/>
+          </a:bodyPr>
+          <a:lstStyle/>
+          <a:p>
+            <a:pPr algn="l"/>
+            <a:r>
+              <a:rPr sz="1400" b="1">
+                <a:solidFill>
+                  <a:srgbClr val="1A5276"/>
+                </a:solidFill>
+                <a:latin typeface="Meiryo"/>
+              </a:rPr>
+              <a:t>デイサービスとは「競合」ではなく、引き継ぎと併用です</a:t>
+            </a:r>
+          </a:p>
+        </p:txBody>
+      </p:sp>
+      <p:sp>
+        <p:nvSpPr>
+          <p:cNvPr id="23" name="Rounded Rectangle 22"/>
+          <p:cNvSpPr/>
+          <p:nvPr/>
+        </p:nvSpPr>
+        <p:spPr>
+          <a:xfrm>
+            <a:off x="4846320" y="4078224"/>
+            <a:ext cx="1298448" cy="1408176"/>
+          </a:xfrm>
+          <a:prstGeom prst="roundRect">
+            <a:avLst>
+              <a:gd name="adj" fmla="val 7042"/>
+            </a:avLst>
+          </a:prstGeom>
+          <a:solidFill>
+            <a:srgbClr val="D6F3E6"/>
+          </a:solidFill>
+          <a:ln>
+            <a:noFill/>
+          </a:ln>
+          <a:effectLst/>
+        </p:spPr>
+        <p:style>
+          <a:lnRef idx="1">
+            <a:schemeClr val="accent1"/>
+          </a:lnRef>
+          <a:fillRef idx="3">
+            <a:schemeClr val="accent1"/>
+          </a:fillRef>
+          <a:effectRef idx="2">
+            <a:schemeClr val="accent1"/>
+          </a:effectRef>
+          <a:fontRef idx="minor">
+            <a:schemeClr val="lt1"/>
+          </a:fontRef>
+        </p:style>
+        <p:txBody>
+          <a:bodyPr rtlCol="0" anchor="ctr"/>
+          <a:lstStyle/>
+          <a:p>
+            <a:pPr algn="ctr"/>
+          </a:p>
+        </p:txBody>
+      </p:sp>
+      <p:sp>
+        <p:nvSpPr>
+          <p:cNvPr id="24" name="TextBox 23"/>
+          <p:cNvSpPr txBox="1"/>
+          <p:nvPr/>
+        </p:nvSpPr>
+        <p:spPr>
+          <a:xfrm>
+            <a:off x="4846320" y="3803904"/>
+            <a:ext cx="1298448" cy="256032"/>
+          </a:xfrm>
+          <a:prstGeom prst="rect">
+            <a:avLst/>
+          </a:prstGeom>
+          <a:noFill/>
+        </p:spPr>
+        <p:txBody>
+          <a:bodyPr wrap="square" anchor="t" lIns="0" rIns="0" tIns="0" bIns="0">
+            <a:spAutoFit/>
+          </a:bodyPr>
+          <a:lstStyle/>
+          <a:p>
+            <a:pPr algn="ctr"/>
+            <a:r>
+              <a:rPr sz="1050" b="1">
+                <a:solidFill>
+                  <a:srgbClr val="1D9E75"/>
+                </a:solidFill>
+                <a:latin typeface="Meiryo"/>
+              </a:rPr>
+              <a:t>併用期</a:t>
+            </a:r>
+          </a:p>
+        </p:txBody>
+      </p:sp>
+      <p:sp>
+        <p:nvSpPr>
+          <p:cNvPr id="25" name="Rounded Rectangle 24"/>
+          <p:cNvSpPr/>
+          <p:nvPr/>
+        </p:nvSpPr>
+        <p:spPr>
+          <a:xfrm>
+            <a:off x="566928" y="4206240"/>
+            <a:ext cx="5577840" cy="566928"/>
+          </a:xfrm>
+          <a:prstGeom prst="roundRect">
+            <a:avLst>
+              <a:gd name="adj" fmla="val 16129"/>
             </a:avLst>
           </a:prstGeom>
           <a:solidFill>
@@ -3796,629 +4408,295 @@
           </a:solidFill>
           <a:ln w="12700">
             <a:solidFill>
-              <a:srgbClr val="F4F8FA"/>
+              <a:srgbClr val="1A5276"/>
             </a:solidFill>
-            <a:prstDash val="solid"/>
           </a:ln>
-        </p:spPr>
-        <p:txBody>
-          <a:bodyPr/>
-          <a:lstStyle/>
-          <a:p>
-            <a:endParaRPr lang="ja-JP" altLang="en-US"/>
-          </a:p>
-        </p:txBody>
-      </p:sp>
-      <p:sp>
-        <p:nvSpPr>
-          <p:cNvPr id="10" name="Text 8"/>
+          <a:effectLst/>
+        </p:spPr>
+        <p:style>
+          <a:lnRef idx="1">
+            <a:schemeClr val="accent1"/>
+          </a:lnRef>
+          <a:fillRef idx="3">
+            <a:schemeClr val="accent1"/>
+          </a:fillRef>
+          <a:effectRef idx="2">
+            <a:schemeClr val="accent1"/>
+          </a:effectRef>
+          <a:fontRef idx="minor">
+            <a:schemeClr val="lt1"/>
+          </a:fontRef>
+        </p:style>
+        <p:txBody>
+          <a:bodyPr rtlCol="0" anchor="ctr"/>
+          <a:lstStyle/>
+          <a:p>
+            <a:pPr algn="ctr"/>
+          </a:p>
+        </p:txBody>
+      </p:sp>
+      <p:sp>
+        <p:nvSpPr>
+          <p:cNvPr id="26" name="TextBox 25"/>
           <p:cNvSpPr txBox="1"/>
           <p:nvPr/>
         </p:nvSpPr>
         <p:spPr>
           <a:xfrm>
-            <a:off x="3566160" y="1700784"/>
-            <a:ext cx="3626968" cy="676656"/>
+            <a:off x="841248" y="4206240"/>
+            <a:ext cx="5029200" cy="566928"/>
           </a:xfrm>
           <a:prstGeom prst="rect">
             <a:avLst/>
           </a:prstGeom>
           <a:noFill/>
-          <a:ln/>
-        </p:spPr>
-        <p:txBody>
-          <a:bodyPr wrap="square" lIns="0" tIns="0" rIns="0" bIns="0" rtlCol="0" anchor="ctr"/>
-          <a:lstStyle/>
-          <a:p>
-            <a:pPr marL="0" indent="0">
-              <a:lnSpc>
-                <a:spcPct val="115000"/>
-              </a:lnSpc>
-              <a:buNone/>
-            </a:pPr>
-            <a:r>
-              <a:rPr lang="en-US" sz="1350" b="1" dirty="0">
+        </p:spPr>
+        <p:txBody>
+          <a:bodyPr wrap="square" anchor="ctr" lIns="0" rIns="0" tIns="0" bIns="0">
+            <a:spAutoFit/>
+          </a:bodyPr>
+          <a:lstStyle/>
+          <a:p>
+            <a:pPr algn="l"/>
+            <a:r>
+              <a:rPr sz="1300" b="1">
                 <a:solidFill>
                   <a:srgbClr val="1A5276"/>
                 </a:solidFill>
-                <a:latin typeface="Meiryo" pitchFamily="34" charset="0"/>
-                <a:ea typeface="Meiryo" pitchFamily="34" charset="-122"/>
-                <a:cs typeface="Meiryo" pitchFamily="34" charset="-120"/>
-              </a:rPr>
-              <a:t>主治医・在宅医</a:t>
-            </a:r>
-            <a:endParaRPr lang="en-US" sz="1350" dirty="0"/>
-          </a:p>
-          <a:p>
-            <a:pPr marL="0" indent="0">
-              <a:lnSpc>
-                <a:spcPct val="115000"/>
-              </a:lnSpc>
-              <a:buNone/>
-            </a:pPr>
-            <a:r>
-              <a:rPr lang="en-US" sz="1000" dirty="0">
-                <a:solidFill>
-                  <a:srgbClr val="566573"/>
-                </a:solidFill>
-                <a:latin typeface="Meiryo" pitchFamily="34" charset="0"/>
-                <a:ea typeface="Meiryo" pitchFamily="34" charset="-122"/>
-                <a:cs typeface="Meiryo" pitchFamily="34" charset="-120"/>
-              </a:rPr>
-              <a:t>創部・全身状態の報告／指示の確認</a:t>
-            </a:r>
-            <a:endParaRPr lang="en-US" sz="1350" dirty="0"/>
-          </a:p>
-        </p:txBody>
-      </p:sp>
-      <p:sp>
-        <p:nvSpPr>
-          <p:cNvPr id="11" name="Shape 9"/>
+                <a:latin typeface="Meiryo"/>
+              </a:rPr>
+              <a:t>デイサービス（通所）での入浴</a:t>
+            </a:r>
+          </a:p>
+        </p:txBody>
+      </p:sp>
+      <p:sp>
+        <p:nvSpPr>
+          <p:cNvPr id="27" name="Rounded Rectangle 26"/>
           <p:cNvSpPr/>
           <p:nvPr/>
         </p:nvSpPr>
         <p:spPr>
           <a:xfrm>
-            <a:off x="7595464" y="1700784"/>
-            <a:ext cx="4029304" cy="676656"/>
+            <a:off x="4846320" y="4919472"/>
+            <a:ext cx="6766560" cy="566928"/>
           </a:xfrm>
           <a:prstGeom prst="roundRect">
             <a:avLst>
-              <a:gd name="adj" fmla="val 6757"/>
+              <a:gd name="adj" fmla="val 16129"/>
             </a:avLst>
           </a:prstGeom>
           <a:solidFill>
-            <a:srgbClr val="F4F8FA"/>
+            <a:srgbClr val="1D9E75"/>
           </a:solidFill>
-          <a:ln w="12700">
-            <a:solidFill>
-              <a:srgbClr val="F4F8FA"/>
-            </a:solidFill>
-            <a:prstDash val="solid"/>
+          <a:ln>
+            <a:noFill/>
           </a:ln>
-        </p:spPr>
-        <p:txBody>
-          <a:bodyPr/>
-          <a:lstStyle/>
-          <a:p>
-            <a:endParaRPr lang="ja-JP" altLang="en-US"/>
-          </a:p>
-        </p:txBody>
-      </p:sp>
-      <p:sp>
-        <p:nvSpPr>
-          <p:cNvPr id="12" name="Text 10"/>
+          <a:effectLst/>
+        </p:spPr>
+        <p:style>
+          <a:lnRef idx="1">
+            <a:schemeClr val="accent1"/>
+          </a:lnRef>
+          <a:fillRef idx="3">
+            <a:schemeClr val="accent1"/>
+          </a:fillRef>
+          <a:effectRef idx="2">
+            <a:schemeClr val="accent1"/>
+          </a:effectRef>
+          <a:fontRef idx="minor">
+            <a:schemeClr val="lt1"/>
+          </a:fontRef>
+        </p:style>
+        <p:txBody>
+          <a:bodyPr rtlCol="0" anchor="ctr"/>
+          <a:lstStyle/>
+          <a:p>
+            <a:pPr algn="ctr"/>
+          </a:p>
+        </p:txBody>
+      </p:sp>
+      <p:sp>
+        <p:nvSpPr>
+          <p:cNvPr id="28" name="TextBox 27"/>
           <p:cNvSpPr txBox="1"/>
           <p:nvPr/>
         </p:nvSpPr>
         <p:spPr>
           <a:xfrm>
-            <a:off x="7796632" y="1700784"/>
-            <a:ext cx="3626968" cy="676656"/>
+            <a:off x="5120640" y="4919472"/>
+            <a:ext cx="6217920" cy="566928"/>
           </a:xfrm>
           <a:prstGeom prst="rect">
             <a:avLst/>
           </a:prstGeom>
           <a:noFill/>
-          <a:ln/>
-        </p:spPr>
-        <p:txBody>
-          <a:bodyPr wrap="square" lIns="0" tIns="0" rIns="0" bIns="0" rtlCol="0" anchor="ctr"/>
-          <a:lstStyle/>
-          <a:p>
-            <a:pPr marL="0" indent="0">
-              <a:lnSpc>
-                <a:spcPct val="115000"/>
-              </a:lnSpc>
-              <a:buNone/>
-            </a:pPr>
-            <a:r>
-              <a:rPr lang="en-US" sz="1350" b="1" dirty="0">
-                <a:solidFill>
-                  <a:srgbClr val="1A5276"/>
-                </a:solidFill>
-                <a:latin typeface="Meiryo" pitchFamily="34" charset="0"/>
-                <a:ea typeface="Meiryo" pitchFamily="34" charset="-122"/>
-                <a:cs typeface="Meiryo" pitchFamily="34" charset="-120"/>
-              </a:rPr>
-              <a:t>訪問看護ステーション</a:t>
-            </a:r>
-            <a:endParaRPr lang="en-US" sz="1350" dirty="0"/>
-          </a:p>
-          <a:p>
-            <a:pPr marL="0" indent="0">
-              <a:lnSpc>
-                <a:spcPct val="115000"/>
-              </a:lnSpc>
-              <a:buNone/>
-            </a:pPr>
-            <a:r>
-              <a:rPr lang="en-US" sz="1000" dirty="0">
-                <a:solidFill>
-                  <a:srgbClr val="566573"/>
-                </a:solidFill>
-                <a:latin typeface="Meiryo" pitchFamily="34" charset="0"/>
-                <a:ea typeface="Meiryo" pitchFamily="34" charset="-122"/>
-                <a:cs typeface="Meiryo" pitchFamily="34" charset="-120"/>
-              </a:rPr>
-              <a:t>観察所見の共有／医療処置の依頼</a:t>
-            </a:r>
-            <a:endParaRPr lang="en-US" sz="1350" dirty="0"/>
-          </a:p>
-        </p:txBody>
-      </p:sp>
-      <p:sp>
-        <p:nvSpPr>
-          <p:cNvPr id="13" name="Shape 11"/>
+        </p:spPr>
+        <p:txBody>
+          <a:bodyPr wrap="square" anchor="ctr" lIns="0" rIns="0" tIns="0" bIns="0">
+            <a:spAutoFit/>
+          </a:bodyPr>
+          <a:lstStyle/>
+          <a:p>
+            <a:pPr algn="l"/>
+            <a:r>
+              <a:rPr sz="1300" b="1">
+                <a:solidFill>
+                  <a:srgbClr val="FFFFFF"/>
+                </a:solidFill>
+                <a:latin typeface="Meiryo"/>
+              </a:rPr>
+              <a:t>訪問入浴（自宅での全身浴）</a:t>
+            </a:r>
+          </a:p>
+        </p:txBody>
+      </p:sp>
+      <p:sp>
+        <p:nvSpPr>
+          <p:cNvPr id="29" name="Right Arrow 28"/>
           <p:cNvSpPr/>
           <p:nvPr/>
         </p:nvSpPr>
         <p:spPr>
           <a:xfrm>
-            <a:off x="3364992" y="2487168"/>
-            <a:ext cx="4029304" cy="676656"/>
-          </a:xfrm>
-          <a:prstGeom prst="roundRect">
-            <a:avLst>
-              <a:gd name="adj" fmla="val 6757"/>
-            </a:avLst>
+            <a:off x="566928" y="5632704"/>
+            <a:ext cx="11045952" cy="128016"/>
+          </a:xfrm>
+          <a:prstGeom prst="rightArrow">
+            <a:avLst/>
           </a:prstGeom>
           <a:solidFill>
-            <a:srgbClr val="F4F8FA"/>
+            <a:srgbClr val="C7D2DA"/>
           </a:solidFill>
-          <a:ln w="12700">
-            <a:solidFill>
-              <a:srgbClr val="F4F8FA"/>
-            </a:solidFill>
-            <a:prstDash val="solid"/>
+          <a:ln>
+            <a:noFill/>
           </a:ln>
-        </p:spPr>
-        <p:txBody>
-          <a:bodyPr/>
-          <a:lstStyle/>
-          <a:p>
-            <a:endParaRPr lang="ja-JP" altLang="en-US"/>
-          </a:p>
-        </p:txBody>
-      </p:sp>
-      <p:sp>
-        <p:nvSpPr>
-          <p:cNvPr id="14" name="Text 12"/>
+          <a:effectLst/>
+        </p:spPr>
+        <p:style>
+          <a:lnRef idx="1">
+            <a:schemeClr val="accent1"/>
+          </a:lnRef>
+          <a:fillRef idx="3">
+            <a:schemeClr val="accent1"/>
+          </a:fillRef>
+          <a:effectRef idx="2">
+            <a:schemeClr val="accent1"/>
+          </a:effectRef>
+          <a:fontRef idx="minor">
+            <a:schemeClr val="lt1"/>
+          </a:fontRef>
+        </p:style>
+        <p:txBody>
+          <a:bodyPr rtlCol="0" anchor="ctr"/>
+          <a:lstStyle/>
+          <a:p>
+            <a:pPr algn="ctr"/>
+          </a:p>
+        </p:txBody>
+      </p:sp>
+      <p:sp>
+        <p:nvSpPr>
+          <p:cNvPr id="30" name="TextBox 29"/>
           <p:cNvSpPr txBox="1"/>
           <p:nvPr/>
         </p:nvSpPr>
         <p:spPr>
           <a:xfrm>
-            <a:off x="3566160" y="2487168"/>
-            <a:ext cx="3626968" cy="676656"/>
+            <a:off x="566928" y="5852160"/>
+            <a:ext cx="4572000" cy="274320"/>
           </a:xfrm>
           <a:prstGeom prst="rect">
             <a:avLst/>
           </a:prstGeom>
           <a:noFill/>
-          <a:ln/>
-        </p:spPr>
-        <p:txBody>
-          <a:bodyPr wrap="square" lIns="0" tIns="0" rIns="0" bIns="0" rtlCol="0" anchor="ctr"/>
-          <a:lstStyle/>
-          <a:p>
-            <a:pPr marL="0" indent="0">
-              <a:lnSpc>
-                <a:spcPct val="115000"/>
-              </a:lnSpc>
-              <a:buNone/>
-            </a:pPr>
-            <a:r>
-              <a:rPr lang="en-US" sz="1350" b="1" dirty="0">
-                <a:solidFill>
-                  <a:srgbClr val="1A5276"/>
-                </a:solidFill>
-                <a:latin typeface="Meiryo" pitchFamily="34" charset="0"/>
-                <a:ea typeface="Meiryo" pitchFamily="34" charset="-122"/>
-                <a:cs typeface="Meiryo" pitchFamily="34" charset="-120"/>
-              </a:rPr>
-              <a:t>ケアマネジャー</a:t>
-            </a:r>
-            <a:endParaRPr lang="en-US" sz="1350" dirty="0"/>
-          </a:p>
-          <a:p>
-            <a:pPr marL="0" indent="0">
-              <a:lnSpc>
-                <a:spcPct val="115000"/>
-              </a:lnSpc>
-              <a:buNone/>
-            </a:pPr>
-            <a:r>
-              <a:rPr lang="en-US" sz="1000" dirty="0">
+        </p:spPr>
+        <p:txBody>
+          <a:bodyPr wrap="square" anchor="t" lIns="0" rIns="0" tIns="0" bIns="0">
+            <a:spAutoFit/>
+          </a:bodyPr>
+          <a:lstStyle/>
+          <a:p>
+            <a:pPr algn="l"/>
+            <a:r>
+              <a:rPr sz="1050" b="0">
                 <a:solidFill>
                   <a:srgbClr val="566573"/>
                 </a:solidFill>
-                <a:latin typeface="Meiryo" pitchFamily="34" charset="0"/>
-                <a:ea typeface="Meiryo" pitchFamily="34" charset="-122"/>
-                <a:cs typeface="Meiryo" pitchFamily="34" charset="-120"/>
-              </a:rPr>
-              <a:t>状態変化・生活課題のフィードバック</a:t>
-            </a:r>
-            <a:endParaRPr lang="en-US" sz="1350" dirty="0"/>
-          </a:p>
-        </p:txBody>
-      </p:sp>
-      <p:sp>
-        <p:nvSpPr>
-          <p:cNvPr id="15" name="Shape 13"/>
-          <p:cNvSpPr/>
-          <p:nvPr/>
-        </p:nvSpPr>
-        <p:spPr>
-          <a:xfrm>
-            <a:off x="7595464" y="2487168"/>
-            <a:ext cx="4029304" cy="676656"/>
-          </a:xfrm>
-          <a:prstGeom prst="roundRect">
-            <a:avLst>
-              <a:gd name="adj" fmla="val 6757"/>
-            </a:avLst>
-          </a:prstGeom>
-          <a:solidFill>
-            <a:srgbClr val="F4F8FA"/>
-          </a:solidFill>
-          <a:ln w="12700">
-            <a:solidFill>
-              <a:srgbClr val="F4F8FA"/>
-            </a:solidFill>
-            <a:prstDash val="solid"/>
-          </a:ln>
-        </p:spPr>
-        <p:txBody>
-          <a:bodyPr/>
-          <a:lstStyle/>
-          <a:p>
-            <a:endParaRPr lang="ja-JP" altLang="en-US"/>
-          </a:p>
-        </p:txBody>
-      </p:sp>
-      <p:sp>
-        <p:nvSpPr>
-          <p:cNvPr id="16" name="Text 14"/>
+                <a:latin typeface="Meiryo"/>
+              </a:rPr>
+              <a:t>ADLが保たれ、通所できる時期</a:t>
+            </a:r>
+          </a:p>
+        </p:txBody>
+      </p:sp>
+      <p:sp>
+        <p:nvSpPr>
+          <p:cNvPr id="31" name="TextBox 30"/>
           <p:cNvSpPr txBox="1"/>
           <p:nvPr/>
         </p:nvSpPr>
         <p:spPr>
           <a:xfrm>
-            <a:off x="7796632" y="2487168"/>
-            <a:ext cx="3626968" cy="676656"/>
+            <a:off x="7040880" y="5852160"/>
+            <a:ext cx="4572000" cy="274320"/>
           </a:xfrm>
           <a:prstGeom prst="rect">
             <a:avLst/>
           </a:prstGeom>
           <a:noFill/>
-          <a:ln/>
-        </p:spPr>
-        <p:txBody>
-          <a:bodyPr wrap="square" lIns="0" tIns="0" rIns="0" bIns="0" rtlCol="0" anchor="ctr"/>
-          <a:lstStyle/>
-          <a:p>
-            <a:pPr marL="0" indent="0">
-              <a:lnSpc>
-                <a:spcPct val="115000"/>
-              </a:lnSpc>
-              <a:buNone/>
-            </a:pPr>
-            <a:r>
-              <a:rPr lang="en-US" sz="1350" b="1" dirty="0">
-                <a:solidFill>
-                  <a:srgbClr val="1A5276"/>
-                </a:solidFill>
-                <a:latin typeface="Meiryo" pitchFamily="34" charset="0"/>
-                <a:ea typeface="Meiryo" pitchFamily="34" charset="-122"/>
-                <a:cs typeface="Meiryo" pitchFamily="34" charset="-120"/>
-              </a:rPr>
-              <a:t>デイサービス・訪問介護</a:t>
-            </a:r>
-            <a:endParaRPr lang="en-US" sz="1350" dirty="0"/>
-          </a:p>
-          <a:p>
-            <a:pPr marL="0" indent="0">
-              <a:lnSpc>
-                <a:spcPct val="115000"/>
-              </a:lnSpc>
-              <a:buNone/>
-            </a:pPr>
-            <a:r>
-              <a:rPr lang="en-US" sz="1000" dirty="0">
+        </p:spPr>
+        <p:txBody>
+          <a:bodyPr wrap="square" anchor="t" lIns="0" rIns="0" tIns="0" bIns="0">
+            <a:spAutoFit/>
+          </a:bodyPr>
+          <a:lstStyle/>
+          <a:p>
+            <a:pPr algn="r"/>
+            <a:r>
+              <a:rPr sz="1050" b="0">
                 <a:solidFill>
                   <a:srgbClr val="566573"/>
                 </a:solidFill>
-                <a:latin typeface="Meiryo" pitchFamily="34" charset="0"/>
-                <a:ea typeface="Meiryo" pitchFamily="34" charset="-122"/>
-                <a:cs typeface="Meiryo" pitchFamily="34" charset="-120"/>
-              </a:rPr>
-              <a:t>入浴日の分担／スキンケアの継続</a:t>
-            </a:r>
-            <a:endParaRPr lang="en-US" sz="1350" dirty="0"/>
-          </a:p>
-        </p:txBody>
-      </p:sp>
-      <p:sp>
-        <p:nvSpPr>
-          <p:cNvPr id="17" name="Shape 15"/>
-          <p:cNvSpPr/>
-          <p:nvPr/>
-        </p:nvSpPr>
-        <p:spPr>
-          <a:xfrm>
-            <a:off x="566928" y="3419856"/>
-            <a:ext cx="5382616" cy="1517904"/>
-          </a:xfrm>
-          <a:prstGeom prst="roundRect">
-            <a:avLst>
-              <a:gd name="adj" fmla="val 3614"/>
-            </a:avLst>
-          </a:prstGeom>
-          <a:solidFill>
-            <a:srgbClr val="F4F8FA"/>
-          </a:solidFill>
-          <a:ln w="12700">
-            <a:solidFill>
-              <a:srgbClr val="F4F8FA"/>
-            </a:solidFill>
-            <a:prstDash val="solid"/>
-          </a:ln>
-        </p:spPr>
-        <p:txBody>
-          <a:bodyPr/>
-          <a:lstStyle/>
-          <a:p>
-            <a:endParaRPr lang="ja-JP" altLang="en-US"/>
-          </a:p>
-        </p:txBody>
-      </p:sp>
-      <p:sp>
-        <p:nvSpPr>
-          <p:cNvPr id="18" name="Text 16"/>
+                <a:latin typeface="Meiryo"/>
+              </a:rPr>
+              <a:t>ADLが低下し、通所が難しくなる時期</a:t>
+            </a:r>
+          </a:p>
+        </p:txBody>
+      </p:sp>
+      <p:sp>
+        <p:nvSpPr>
+          <p:cNvPr id="32" name="TextBox 31"/>
           <p:cNvSpPr txBox="1"/>
           <p:nvPr/>
         </p:nvSpPr>
         <p:spPr>
           <a:xfrm>
-            <a:off x="786384" y="3602736"/>
-            <a:ext cx="4943704" cy="310896"/>
+            <a:off x="566928" y="6236208"/>
+            <a:ext cx="11045952" cy="365760"/>
           </a:xfrm>
           <a:prstGeom prst="rect">
             <a:avLst/>
           </a:prstGeom>
           <a:noFill/>
-          <a:ln/>
-        </p:spPr>
-        <p:txBody>
-          <a:bodyPr wrap="square" lIns="0" tIns="0" rIns="0" bIns="0" rtlCol="0" anchor="ctr"/>
-          <a:lstStyle/>
-          <a:p>
-            <a:pPr marL="0" indent="0">
-              <a:buNone/>
-            </a:pPr>
-            <a:r>
-              <a:rPr lang="en-US" sz="1600" b="1" dirty="0">
-                <a:solidFill>
-                  <a:srgbClr val="1A5276"/>
-                </a:solidFill>
-                <a:latin typeface="Meiryo" pitchFamily="34" charset="0"/>
-                <a:ea typeface="Meiryo" pitchFamily="34" charset="-122"/>
-                <a:cs typeface="Meiryo" pitchFamily="34" charset="-120"/>
-              </a:rPr>
-              <a:t>「競合」ではありません</a:t>
-            </a:r>
-            <a:endParaRPr lang="en-US" sz="1600" dirty="0"/>
-          </a:p>
-        </p:txBody>
-      </p:sp>
-      <p:sp>
-        <p:nvSpPr>
-          <p:cNvPr id="19" name="Text 17"/>
-          <p:cNvSpPr txBox="1"/>
-          <p:nvPr/>
-        </p:nvSpPr>
-        <p:spPr>
-          <a:xfrm>
-            <a:off x="786384" y="4005072"/>
-            <a:ext cx="4943704" cy="786384"/>
-          </a:xfrm>
-          <a:prstGeom prst="rect">
-            <a:avLst/>
-          </a:prstGeom>
-          <a:noFill/>
-          <a:ln/>
-        </p:spPr>
-        <p:txBody>
-          <a:bodyPr wrap="square" lIns="0" tIns="0" rIns="0" bIns="0" rtlCol="0" anchor="t"/>
-          <a:lstStyle/>
-          <a:p>
-            <a:pPr marL="0" indent="0">
-              <a:lnSpc>
-                <a:spcPct val="125000"/>
-              </a:lnSpc>
-              <a:buNone/>
-            </a:pPr>
-            <a:r>
-              <a:rPr lang="en-US" sz="1400" dirty="0">
-                <a:solidFill>
-                  <a:srgbClr val="1C2833"/>
-                </a:solidFill>
-                <a:latin typeface="Meiryo" pitchFamily="34" charset="0"/>
-                <a:ea typeface="Meiryo" pitchFamily="34" charset="-122"/>
-                <a:cs typeface="Meiryo" pitchFamily="34" charset="-120"/>
-              </a:rPr>
-              <a:t>デイサービスに通えている間はデイでの入浴を。</a:t>
-            </a:r>
-            <a:r>
-              <a:rPr lang="en-US" sz="1400" b="1" dirty="0">
+        </p:spPr>
+        <p:txBody>
+          <a:bodyPr wrap="square" anchor="t" lIns="0" rIns="0" tIns="0" bIns="0">
+            <a:spAutoFit/>
+          </a:bodyPr>
+          <a:lstStyle/>
+          <a:p>
+            <a:pPr algn="l"/>
+            <a:r>
+              <a:rPr sz="1350" b="1">
                 <a:solidFill>
                   <a:srgbClr val="1D9E75"/>
                 </a:solidFill>
-                <a:latin typeface="Meiryo" pitchFamily="34" charset="0"/>
-                <a:ea typeface="Meiryo" pitchFamily="34" charset="-122"/>
-                <a:cs typeface="Meiryo" pitchFamily="34" charset="-120"/>
-              </a:rPr>
-              <a:t>体調やADLの低下で通所が難しくなった時期</a:t>
-            </a:r>
-            <a:r>
-              <a:rPr lang="en-US" sz="1400" dirty="0">
-                <a:solidFill>
-                  <a:srgbClr val="1C2833"/>
-                </a:solidFill>
-                <a:latin typeface="Meiryo" pitchFamily="34" charset="0"/>
-                <a:ea typeface="Meiryo" pitchFamily="34" charset="-122"/>
-                <a:cs typeface="Meiryo" pitchFamily="34" charset="-120"/>
-              </a:rPr>
-              <a:t>に訪問入浴が引き継ぐ、という補完関係です。</a:t>
-            </a:r>
-            <a:endParaRPr lang="en-US" sz="1400" dirty="0"/>
-          </a:p>
-        </p:txBody>
-      </p:sp>
-      <p:sp>
-        <p:nvSpPr>
-          <p:cNvPr id="20" name="Shape 18"/>
-          <p:cNvSpPr/>
-          <p:nvPr/>
-        </p:nvSpPr>
-        <p:spPr>
-          <a:xfrm>
-            <a:off x="6242152" y="3419856"/>
-            <a:ext cx="5382616" cy="1517904"/>
-          </a:xfrm>
-          <a:prstGeom prst="roundRect">
-            <a:avLst>
-              <a:gd name="adj" fmla="val 3614"/>
-            </a:avLst>
-          </a:prstGeom>
-          <a:solidFill>
-            <a:srgbClr val="EAF7F1"/>
-          </a:solidFill>
-          <a:ln w="12700">
-            <a:solidFill>
-              <a:srgbClr val="EAF7F1"/>
-            </a:solidFill>
-            <a:prstDash val="solid"/>
-          </a:ln>
-        </p:spPr>
-        <p:txBody>
-          <a:bodyPr/>
-          <a:lstStyle/>
-          <a:p>
-            <a:endParaRPr lang="ja-JP" altLang="en-US"/>
-          </a:p>
-        </p:txBody>
-      </p:sp>
-      <p:sp>
-        <p:nvSpPr>
-          <p:cNvPr id="21" name="Text 19"/>
-          <p:cNvSpPr txBox="1"/>
-          <p:nvPr/>
-        </p:nvSpPr>
-        <p:spPr>
-          <a:xfrm>
-            <a:off x="6461608" y="3602736"/>
-            <a:ext cx="4943704" cy="310896"/>
-          </a:xfrm>
-          <a:prstGeom prst="rect">
-            <a:avLst/>
-          </a:prstGeom>
-          <a:noFill/>
-          <a:ln/>
-        </p:spPr>
-        <p:txBody>
-          <a:bodyPr wrap="square" lIns="0" tIns="0" rIns="0" bIns="0" rtlCol="0" anchor="ctr"/>
-          <a:lstStyle/>
-          <a:p>
-            <a:pPr marL="0" indent="0">
-              <a:buNone/>
-            </a:pPr>
-            <a:r>
-              <a:rPr lang="en-US" sz="1600" b="1" dirty="0">
-                <a:solidFill>
-                  <a:srgbClr val="1D9E75"/>
-                </a:solidFill>
-                <a:latin typeface="Meiryo" pitchFamily="34" charset="0"/>
-                <a:ea typeface="Meiryo" pitchFamily="34" charset="-122"/>
-                <a:cs typeface="Meiryo" pitchFamily="34" charset="-120"/>
-              </a:rPr>
-              <a:t>併用が最も現実的</a:t>
-            </a:r>
-            <a:endParaRPr lang="en-US" sz="1600" dirty="0"/>
-          </a:p>
-        </p:txBody>
-      </p:sp>
-      <p:sp>
-        <p:nvSpPr>
-          <p:cNvPr id="22" name="Text 20"/>
-          <p:cNvSpPr txBox="1"/>
-          <p:nvPr/>
-        </p:nvSpPr>
-        <p:spPr>
-          <a:xfrm>
-            <a:off x="6461608" y="4005072"/>
-            <a:ext cx="4943704" cy="786384"/>
-          </a:xfrm>
-          <a:prstGeom prst="rect">
-            <a:avLst/>
-          </a:prstGeom>
-          <a:noFill/>
-          <a:ln/>
-        </p:spPr>
-        <p:txBody>
-          <a:bodyPr wrap="square" lIns="0" tIns="0" rIns="0" bIns="0" rtlCol="0" anchor="t"/>
-          <a:lstStyle/>
-          <a:p>
-            <a:pPr marL="0" indent="0">
-              <a:lnSpc>
-                <a:spcPct val="125000"/>
-              </a:lnSpc>
-              <a:buNone/>
-            </a:pPr>
-            <a:r>
-              <a:rPr lang="en-US" sz="1400" dirty="0">
-                <a:solidFill>
-                  <a:srgbClr val="1C2833"/>
-                </a:solidFill>
-                <a:latin typeface="Meiryo" pitchFamily="34" charset="0"/>
-                <a:ea typeface="Meiryo" pitchFamily="34" charset="-122"/>
-                <a:cs typeface="Meiryo" pitchFamily="34" charset="-120"/>
-              </a:rPr>
-              <a:t>「デイ入浴＋訪問入浴」「訪問入浴の観察＋訪問看護の処置」。</a:t>
-            </a:r>
-            <a:r>
-              <a:rPr lang="en-US" sz="1400" b="1" dirty="0">
-                <a:solidFill>
-                  <a:srgbClr val="1D9E75"/>
-                </a:solidFill>
-                <a:latin typeface="Meiryo" pitchFamily="34" charset="0"/>
-                <a:ea typeface="Meiryo" pitchFamily="34" charset="-122"/>
-                <a:cs typeface="Meiryo" pitchFamily="34" charset="-120"/>
-              </a:rPr>
-              <a:t>役割を分け合うことで在宅の限界点が延びます。</a:t>
-            </a:r>
-            <a:endParaRPr lang="en-US" sz="1400" dirty="0"/>
+                <a:latin typeface="Meiryo"/>
+              </a:rPr>
+              <a:t>役割を分け合うことで、ご自宅で過ごせる期間が延びます。</a:t>
+            </a:r>
           </a:p>
         </p:txBody>
       </p:sp>

</xml_diff>

<commit_message>
Write the 60-minute presentation script and embed speaker notes
プレゼン台本.txt is the full lectern script: a minute-by-minute plan
(2 min opening, the 7:06 video, 40 min of slides, 10 min Q&A), what to
say on each slide, where to pause, nine anticipated questions with
answers, and the order in which to cut material if the talk runs long.
The same content is condensed into each slide's notes pane so it shows
in PowerPoint's presenter view.

Co-Authored-By: Claude Opus 5 <noreply@anthropic.com>
Claude-Session: https://claude.ai/code/session_01EuVvTjbyv3WUxHVeG4YeGS
</commit_message>
<xml_diff>
--- a/houmon-nyuyoku-slides.pptx
+++ b/houmon-nyuyoku-slides.pptx
@@ -856,8 +856,42 @@
           <a:lstStyle/>
           <a:p>
             <a:r>
-              <a:rPr lang="en-US" dirty="0"/>
-              <a:t>本日は訪問入浴介護についてお話しします。テーマは「自宅でお風呂に入る権利」。在宅で入浴が困難な方に、どう関わり、どう連携できるかをお伝えします。</a:t>
+              <a:t>［0:00〜2:00／2分］表紙</a:t>
+            </a:r>
+          </a:p>
+          <a:p>
+            <a:r>
+              <a:t>・あいさつ／看護師・管理者として地域で訪問入浴に携わっている</a:t>
+            </a:r>
+          </a:p>
+          <a:p>
+            <a:r>
+              <a:t>・「何か月もお風呂に入っていない方が実際にいる」→ ひと呼吸おく</a:t>
+            </a:r>
+          </a:p>
+          <a:p>
+            <a:r>
+              <a:t>・本日の流れ：動画7分 → スライド40分 → 質疑10分</a:t>
+            </a:r>
+          </a:p>
+          <a:p>
+            <a:r>
+              <a:t>・「それでは、まず動画をご覧ください」</a:t>
+            </a:r>
+          </a:p>
+          <a:p>
+            <a:r>
+              <a:t>【動画の前ふり】ご本人・ご家族の同意を得て撮影。浴槽の搬入からお帰りまで。</a:t>
+            </a:r>
+          </a:p>
+          <a:p>
+            <a:r>
+              <a:t>【再生中】スクリーンの脇に寄る。補足を入れない。</a:t>
+            </a:r>
+          </a:p>
+          <a:p>
+            <a:r>
+              <a:t>【再生後】「45分以内。その間ずっと看護師が全身を見ています」</a:t>
             </a:r>
           </a:p>
         </p:txBody>
@@ -950,8 +984,47 @@
           <a:lstStyle/>
           <a:p>
             <a:r>
-              <a:rPr lang="en-US" dirty="0"/>
-              <a:t>本日いちばんお願いしたい点です。特に訪問看護ステーションの方に向けて、同日訪問と事前相談をお願いしてください。</a:t>
+              <a:t>［35:00〜38:30／3分半］連携のお願い　★山場・今日の本題</a:t>
+            </a:r>
+          </a:p>
+          <a:p>
+            <a:r>
+              <a:t>・訪問看護の皆さまへ3つ（指を立てて数える）</a:t>
+            </a:r>
+          </a:p>
+          <a:p>
+            <a:r>
+              <a:t> ①訪問日を合わせてほしい＝入浴直後は皮膚が清潔で処置に最適</a:t>
+            </a:r>
+          </a:p>
+          <a:p>
+            <a:r>
+              <a:t>   「私たちにとってではなく、ご本人にとって一番いい形」</a:t>
+            </a:r>
+          </a:p>
+          <a:p>
+            <a:r>
+              <a:t> ②見てほしい部位を教えてほしい＝重点観察し、当日中にノート・電話・写真で返す</a:t>
+            </a:r>
+          </a:p>
+          <a:p>
+            <a:r>
+              <a:t> ③医療的ケアは事前相談＝気切・経管・在宅酸素も条件を整えれば入れる</a:t>
+            </a:r>
+          </a:p>
+          <a:p>
+            <a:r>
+              <a:t>・締め「この状態で入浴させてよいか──迷った時点でご連絡ください。</a:t>
+            </a:r>
+          </a:p>
+          <a:p>
+            <a:r>
+              <a:t>  一緒に判断させてください」← ここで一度止まる</a:t>
+            </a:r>
+          </a:p>
+          <a:p>
+            <a:r>
+              <a:t>・「できませんと答えるために伺うのではありません」</a:t>
             </a:r>
           </a:p>
         </p:txBody>
@@ -1044,8 +1117,47 @@
           <a:lstStyle/>
           <a:p>
             <a:r>
-              <a:rPr lang="en-US" dirty="0"/>
-              <a:t>デイサービスの方に特にお伝えしたい点です。奪い合いではなく、通所が難しくなった段階での受け皿としてお考えください。</a:t>
+              <a:t>［38:30〜41:30／3分］在宅チームの一員として</a:t>
+            </a:r>
+          </a:p>
+          <a:p>
+            <a:r>
+              <a:t>・上の図：主治医＝創部・全身状態／訪看＝観察所見／ケアマネ＝状態変化／</a:t>
+            </a:r>
+          </a:p>
+          <a:p>
+            <a:r>
+              <a:t>  デイ・訪問介護＝入浴日の分担</a:t>
+            </a:r>
+          </a:p>
+          <a:p>
+            <a:r>
+              <a:t>・下の図（手で示す）：左→右へADLが低下</a:t>
+            </a:r>
+          </a:p>
+          <a:p>
+            <a:r>
+              <a:t>  通所できる時期はデイが第一選択（社会参加の意味がある）</a:t>
+            </a:r>
+          </a:p>
+          <a:p>
+            <a:r>
+              <a:t>  通所が難しくなったら訪問入浴が引き継ぐ</a:t>
+            </a:r>
+          </a:p>
+          <a:p>
+            <a:r>
+              <a:t>  ★重なり＝併用期。「デイに週2回行けるが、体調の波で行けない週もある」</a:t>
+            </a:r>
+          </a:p>
+          <a:p>
+            <a:r>
+              <a:t>・「役割を分け合うことで、ご自宅で過ごせる期間が延びます」</a:t>
+            </a:r>
+          </a:p>
+          <a:p>
+            <a:r>
+              <a:t>・デイ職員へ：「そろそろ通所がきつい」と感じた時点で声をかけてほしい</a:t>
             </a:r>
           </a:p>
         </p:txBody>
@@ -1138,8 +1250,52 @@
           <a:lstStyle/>
           <a:p>
             <a:r>
-              <a:rPr lang="en-US" dirty="0"/>
-              <a:t>単位数が高いという指摘は当然あります。何が含まれているかを分解して説明できるようにしておきます。</a:t>
+              <a:t>［41:30〜44:30／3分］単位数</a:t>
+            </a:r>
+          </a:p>
+          <a:p>
+            <a:r>
+              <a:t>・訪問入浴介護費 1回1,266単位／清拭・部分浴 1,139単位</a:t>
+            </a:r>
+          </a:p>
+          <a:p>
+            <a:r>
+              <a:t>・初回加算200（月1回）／看取り連携体制加算64（2024新設）／</a:t>
+            </a:r>
+          </a:p>
+          <a:p>
+            <a:r>
+              <a:t>  認知症専門ケアⅠ3・Ⅱ4／処遇改善 加算Ⅱ（ロ）12.7%</a:t>
+            </a:r>
+          </a:p>
+          <a:p>
+            <a:r>
+              <a:t>・「正直に申し上げて、安くありません」← 自分から言う</a:t>
+            </a:r>
+          </a:p>
+          <a:p>
+            <a:r>
+              <a:t>・中身：省令の3名同時訪問／浴槽・給湯の持込みと設置撤収／</a:t>
+            </a:r>
+          </a:p>
+          <a:p>
+            <a:r>
+              <a:t>  清拭では届かない全身浴と洗髪／毎回のバイタルと全身観察／情報共有</a:t>
+            </a:r>
+          </a:p>
+          <a:p>
+            <a:r>
+              <a:t>・「入浴だけの報酬ではなく、看護アセスメントを含んだケアの対価」</a:t>
+            </a:r>
+          </a:p>
+          <a:p>
+            <a:r>
+              <a:t>・看取り連携体制加算の新設＝国の方向性</a:t>
+            </a:r>
+          </a:p>
+          <a:p>
+            <a:r>
+              <a:t>【注意】金額はその場で計算しない。「地域区分で変わるので個別にお出しします」</a:t>
             </a:r>
           </a:p>
         </p:txBody>
@@ -1232,8 +1388,37 @@
           <a:lstStyle/>
           <a:p>
             <a:r>
-              <a:rPr lang="en-US" dirty="0"/>
-              <a:t>数字では伝わらない部分です。ご家族の負担軽減という側面も強調してください。</a:t>
+              <a:t>［44:30〜46:30／2分］利用者・ご家族の声</a:t>
+            </a:r>
+          </a:p>
+          <a:p>
+            <a:r>
+              <a:t>・80代要介護5のご本人「毎週のお風呂が楽しみで、それだけで前向きに」</a:t>
+            </a:r>
+          </a:p>
+          <a:p>
+            <a:r>
+              <a:t>  →「"それだけで"とおっしゃった」</a:t>
+            </a:r>
+          </a:p>
+          <a:p>
+            <a:r>
+              <a:t>・70代ご家族「一人では絶対に無理でした。プロに任せることで安心して</a:t>
+            </a:r>
+          </a:p>
+          <a:p>
+            <a:r>
+              <a:t>  介護できるようになりました」</a:t>
+            </a:r>
+          </a:p>
+          <a:p>
+            <a:r>
+              <a:t>・ご本人のためだけでなく、ご家族のためのサービスでもある</a:t>
+            </a:r>
+          </a:p>
+          <a:p>
+            <a:r>
+              <a:t>【押していたら】このスライドを丸ごと飛ばす。−2分</a:t>
             </a:r>
           </a:p>
         </p:txBody>
@@ -1326,8 +1511,32 @@
           <a:lstStyle/>
           <a:p>
             <a:r>
-              <a:rPr lang="en-US" dirty="0"/>
-              <a:t>4点に整理しました。最後のメッセージ——迷った段階でご相談いただきたい、を強調して締めます。</a:t>
+              <a:t>［46:30〜48:30／2分］まとめ</a:t>
+            </a:r>
+          </a:p>
+          <a:p>
+            <a:r>
+              <a:t>・①空白地帯の受け皿　②4条件を同時に満たす唯一　</a:t>
+            </a:r>
+          </a:p>
+          <a:p>
+            <a:r>
+              <a:t>  ③週1〜2回の全身アセスメント　④見つけて、つなぐ</a:t>
+            </a:r>
+          </a:p>
+          <a:p>
+            <a:r>
+              <a:t>・「もう入浴は難しいかもしれない」と感じた時が検討のタイミング</a:t>
+            </a:r>
+          </a:p>
+          <a:p>
+            <a:r>
+              <a:t>・「もう無理だろう」と思われていた方が入れることは多い</a:t>
+            </a:r>
+          </a:p>
+          <a:p>
+            <a:r>
+              <a:t>・導入の可否のご相談だけでも構いません</a:t>
             </a:r>
           </a:p>
         </p:txBody>
@@ -1420,8 +1629,37 @@
           <a:lstStyle/>
           <a:p>
             <a:r>
-              <a:rPr lang="en-US" dirty="0"/>
-              <a:t>ご相談は電話が最も早いです。初回アセスメントは無料である点をお伝えください。</a:t>
+              <a:t>［48:30〜50:00／1分半］連絡先</a:t>
+            </a:r>
+          </a:p>
+          <a:p>
+            <a:r>
+              <a:t>・冨永／093-695-7766 ← ゆっくり、2回言う（スライドを見ずに）</a:t>
+            </a:r>
+          </a:p>
+          <a:p>
+            <a:r>
+              <a:t>・初回アセスメント無料。「この方、入れますか」だけで結構です</a:t>
+            </a:r>
+          </a:p>
+          <a:p>
+            <a:r>
+              <a:t>・他サービスとの組み合わせも含めて提案します</a:t>
+            </a:r>
+          </a:p>
+          <a:p>
+            <a:r>
+              <a:t>・一礼してから質疑へ</a:t>
+            </a:r>
+          </a:p>
+          <a:p>
+            <a:r>
+              <a:t>【質疑の構え】分からないことは即答しない。</a:t>
+            </a:r>
+          </a:p>
+          <a:p>
+            <a:r>
+              <a:t>「確認してご連絡します。お名刺をいただけますか」で十分。</a:t>
             </a:r>
           </a:p>
         </p:txBody>
@@ -1514,8 +1752,32 @@
           <a:lstStyle/>
           <a:p>
             <a:r>
-              <a:rPr lang="en-US" dirty="0"/>
-              <a:t>入浴困難は「できない理由」が複数重なって起こります。清拭だけでは代替できない意義があることを押さえてください。</a:t>
+              <a:t>［9:30〜13:00／3分半］在宅で入浴できない現実</a:t>
+            </a:r>
+          </a:p>
+          <a:p>
+            <a:r>
+              <a:t>・左＝入浴を阻む5つの壁。「思い当たる顔が浮かぶのでは」で会場を見渡す</a:t>
+            </a:r>
+          </a:p>
+          <a:p>
+            <a:r>
+              <a:t>・右＝入浴の意義。いちばん下「生きる意欲」を自分の言葉で</a:t>
+            </a:r>
+          </a:p>
+          <a:p>
+            <a:r>
+              <a:t>  （お湯に浸かって表情が戻る瞬間の話）</a:t>
+            </a:r>
+          </a:p>
+          <a:p>
+            <a:r>
+              <a:t>・結論「入浴は贅沢ではなく、在宅療養を支えるインフラ」</a:t>
+            </a:r>
+          </a:p>
+          <a:p>
+            <a:r>
+              <a:t>【押していたら】右の5つは読まず、結論だけ。−1分</a:t>
             </a:r>
           </a:p>
         </p:txBody>
@@ -1608,8 +1870,37 @@
           <a:lstStyle/>
           <a:p>
             <a:r>
-              <a:rPr lang="en-US" dirty="0"/>
-              <a:t>3つの選択肢それぞれに限界があること、そしてその間に空白地帯があることが今日の出発点です。</a:t>
+              <a:t>［13:00〜16:30／3分半］選択肢と限界</a:t>
+            </a:r>
+          </a:p>
+          <a:p>
+            <a:r>
+              <a:t>・①訪問介護・看護＝浴室環境に左右され1名対応</a:t>
+            </a:r>
+          </a:p>
+          <a:p>
+            <a:r>
+              <a:t>・②デイ入浴＝通所が前提。重度・医療的ケアで受け入れ困難</a:t>
+            </a:r>
+          </a:p>
+          <a:p>
+            <a:r>
+              <a:t>・③訪問入浴＝浴槽持込み、看護師同行、移動負担ゼロ</a:t>
+            </a:r>
+          </a:p>
+          <a:p>
+            <a:r>
+              <a:t>・「③が優れているという話ではありません」← はっきり言う</a:t>
+            </a:r>
+          </a:p>
+          <a:p>
+            <a:r>
+              <a:t>・結論＝空白地帯「デイには行けない、でも清拭では足りない」</a:t>
+            </a:r>
+          </a:p>
+          <a:p>
+            <a:r>
+              <a:t>  この谷間の方は自分から声を上げられない</a:t>
             </a:r>
           </a:p>
         </p:txBody>
@@ -1702,8 +1993,47 @@
           <a:lstStyle/>
           <a:p>
             <a:r>
-              <a:rPr lang="en-US" dirty="0"/>
-              <a:t>この表が本日の中心です。訪問看護・訪問介護の入浴介助も比較に入れました。訪問入浴の違いは、専用浴槽を持参するため浴室環境に左右されない点と、3名体制で移乗できる点です。</a:t>
+              <a:t>［16:30〜20:30／4分］比較表　★山場</a:t>
+            </a:r>
+          </a:p>
+          <a:p>
+            <a:r>
+              <a:t>・全部読まない。訪問入浴の「列」を見せる</a:t>
+            </a:r>
+          </a:p>
+          <a:p>
+            <a:r>
+              <a:t>・拾う行は3つだけ</a:t>
+            </a:r>
+          </a:p>
+          <a:p>
+            <a:r>
+              <a:t>  ①浴室環境に左右されない（浴槽ごと持参。二階でも寝室でも）</a:t>
+            </a:r>
+          </a:p>
+          <a:p>
+            <a:r>
+              <a:t>  ②複数名での移乗（3名＝転倒・皮膚剥離を防ぐ）</a:t>
+            </a:r>
+          </a:p>
+          <a:p>
+            <a:r>
+              <a:t>  ③看護師が同行（後で詳しく）</a:t>
+            </a:r>
+          </a:p>
+          <a:p>
+            <a:r>
+              <a:t>・下の注記：要介護5が48.2%、要介護4が25.1% ← ゆっくり</a:t>
+            </a:r>
+          </a:p>
+          <a:p>
+            <a:r>
+              <a:t>・「重度化した在宅療養者の、最後の入浴手段」</a:t>
+            </a:r>
+          </a:p>
+          <a:p>
+            <a:r>
+              <a:t>【ツッコミ対策】デイを低く見ていない。通所できる方はデイが第一選択</a:t>
             </a:r>
           </a:p>
         </p:txBody>
@@ -1796,8 +2126,32 @@
           <a:lstStyle/>
           <a:p>
             <a:r>
-              <a:rPr lang="en-US" dirty="0"/>
-              <a:t>4条件のうち3つまでなら他サービスでも満たせます。4つ同時、という点が訪問入浴の存在理由です。</a:t>
+              <a:t>［20:30〜23:00／2分半］4つの条件</a:t>
+            </a:r>
+          </a:p>
+          <a:p>
+            <a:r>
+              <a:t>・「自宅で」「全身浴を」「看護師付きで」「重度でも」</a:t>
+            </a:r>
+          </a:p>
+          <a:p>
+            <a:r>
+              <a:t>・どれか1つなら他でも代替できる。同時に満たすのが訪問入浴だけ</a:t>
+            </a:r>
+          </a:p>
+          <a:p>
+            <a:r>
+              <a:t>・「重度化しても、自宅のまま、湯船に浸かり続ける」</a:t>
+            </a:r>
+          </a:p>
+          <a:p>
+            <a:r>
+              <a:t>・入浴が決め手で施設入所を選ぶご家族を何度も見てきた</a:t>
+            </a:r>
+          </a:p>
+          <a:p>
+            <a:r>
+              <a:t>【押していたら】4語＋結論だけ。−1分半</a:t>
             </a:r>
           </a:p>
         </p:txBody>
@@ -1890,8 +2244,37 @@
           <a:lstStyle/>
           <a:p>
             <a:r>
-              <a:rPr lang="en-US" dirty="0"/>
-              <a:t>準備・入浴・片付けの3区分、各15分で計45分以内です。入浴可否の判断と記録・連絡が看護師の関わる部分になります。</a:t>
+              <a:t>［23:00〜25:30／2分半］訪問の流れ</a:t>
+            </a:r>
+          </a:p>
+          <a:p>
+            <a:r>
+              <a:t>・15分＋15分＋15分＝45分以内</a:t>
+            </a:r>
+          </a:p>
+          <a:p>
+            <a:r>
+              <a:t>・★左下：発熱・血圧変動時は清拭や部分浴に切替、中止も</a:t>
+            </a:r>
+          </a:p>
+          <a:p>
+            <a:r>
+              <a:t>  「無理に入れないことも私たちの仕事」中止理由も必ず報告</a:t>
+            </a:r>
+          </a:p>
+          <a:p>
+            <a:r>
+              <a:t>・右下：2畳あれば設置可。給湯は車両でも自宅設備でも。養生あり</a:t>
+            </a:r>
+          </a:p>
+          <a:p>
+            <a:r>
+              <a:t>・「うちは狭いから無理」と言われたお宅もほとんど入れる</a:t>
+            </a:r>
+          </a:p>
+          <a:p>
+            <a:r>
+              <a:t>【押していたら】左下と右下だけ。−1分</a:t>
             </a:r>
           </a:p>
         </p:txBody>
@@ -1984,8 +2367,37 @@
           <a:lstStyle/>
           <a:p>
             <a:r>
-              <a:rPr lang="en-US" dirty="0"/>
-              <a:t>なぜ3名なのか、という質問をよく受けます。安全確保と、看護師が観察に専念できる体制のためです。</a:t>
+              <a:t>［25:30〜28:00／2分半］3名体制</a:t>
+            </a:r>
+          </a:p>
+          <a:p>
+            <a:r>
+              <a:t>・看護師1＋介護2。事業所の方針ではなく厚生労働省令の要件</a:t>
+            </a:r>
+          </a:p>
+          <a:p>
+            <a:r>
+              <a:t>・訪問入浴を使えば必ず看護職員が来る</a:t>
+            </a:r>
+          </a:p>
+          <a:p>
+            <a:r>
+              <a:t>・看護師＝バイタル／可否判断／褥瘡の観察と記録／急変時連絡／情報提供</a:t>
+            </a:r>
+          </a:p>
+          <a:p>
+            <a:r>
+              <a:t>・「観察と記録はするが処置はしない」← 次の次で詳述</a:t>
+            </a:r>
+          </a:p>
+          <a:p>
+            <a:r>
+              <a:t>・介護2名が移乗を担うので、看護師は観察と判断に専念できる</a:t>
+            </a:r>
+          </a:p>
+          <a:p>
+            <a:r>
+              <a:t>【押していたら】省令の3名体制＋専念できる、の2点。−1分半</a:t>
             </a:r>
           </a:p>
         </p:txBody>
@@ -2078,8 +2490,42 @@
           <a:lstStyle/>
           <a:p>
             <a:r>
-              <a:rPr lang="en-US" dirty="0"/>
-              <a:t>ここが訪問入浴の医療的価値です。褥瘡の初期発赤を最初に見つけるのは、入浴の場面が非常に多いです。</a:t>
+              <a:t>［28:00〜31:30／3分半］入浴は全身をみる場　※今日の中心</a:t>
+            </a:r>
+          </a:p>
+          <a:p>
+            <a:r>
+              <a:t>・衣服を脱いだ全身を、明るい場所で、毎回</a:t>
+            </a:r>
+          </a:p>
+          <a:p>
+            <a:r>
+              <a:t>・訪問診療・訪問看護は必要部位を見る。入浴は全身が、湯で伸びた皮膚で見える</a:t>
+            </a:r>
+          </a:p>
+          <a:p>
+            <a:r>
+              <a:t>・左＝仙骨部・踵部の発赤／下腿・足背の浮腫／白癬・湿疹・スキンテア／</a:t>
+            </a:r>
+          </a:p>
+          <a:p>
+            <a:r>
+              <a:t>  内出血・打撲痕（転倒の兆候。家族が言い出せないことも）</a:t>
+            </a:r>
+          </a:p>
+          <a:p>
+            <a:r>
+              <a:t>・中＝体型変化・筋肉量・骨突出（褥瘡リスク上昇）</a:t>
+            </a:r>
+          </a:p>
+          <a:p>
+            <a:r>
+              <a:t>・右＝その日のうちに主治医・訪看・ケアマネへ。必要なら写真</a:t>
+            </a:r>
+          </a:p>
+          <a:p>
+            <a:r>
+              <a:t>・「週1〜2回の入浴は、週1〜2回の全身アセスメント」← 言い切って間</a:t>
             </a:r>
           </a:p>
         </p:txBody>
@@ -2172,8 +2618,42 @@
           <a:lstStyle/>
           <a:p>
             <a:r>
-              <a:rPr lang="en-US" dirty="0"/>
-              <a:t>訪問入浴は介護保険サービスなので医療行為はできません。だから訪問看護との連携が前提になります。この線引きを明確にお伝えしてください。</a:t>
+              <a:t>［31:30〜35:00／3分半］役割分担</a:t>
+            </a:r>
+          </a:p>
+          <a:p>
+            <a:r>
+              <a:t>・「訪問入浴は介護保険サービス。医療行為は行えません」← ごまかさない</a:t>
+            </a:r>
+          </a:p>
+          <a:p>
+            <a:r>
+              <a:t>・左＝私たち：バイタル／全身観察／洗身洗髪・保湿／記録と当日報告</a:t>
+            </a:r>
+          </a:p>
+          <a:p>
+            <a:r>
+              <a:t>・右＝訪問看護へ：創傷処置・薬剤／点滴注射採血／カテーテル・ストーマ／</a:t>
+            </a:r>
+          </a:p>
+          <a:p>
+            <a:r>
+              <a:t>  喀痰吸引・経管栄養／医師の指示による医療的ケア全般</a:t>
+            </a:r>
+          </a:p>
+          <a:p>
+            <a:r>
+              <a:t>・例：仙骨部の発赤を見つけても、軟膏は塗らない。記録して当日中に伝える</a:t>
+            </a:r>
+          </a:p>
+          <a:p>
+            <a:r>
+              <a:t>・「私も看護師なので手を出したくなる。でも線引きが安全につながる」</a:t>
+            </a:r>
+          </a:p>
+          <a:p>
+            <a:r>
+              <a:t>・「見つけて、つなぐ」</a:t>
             </a:r>
           </a:p>
         </p:txBody>

</xml_diff>

<commit_message>
Work the presenter's three script changes into the talk
- introduce the two care workers on slide 1, and set up the demo there
- rewrite slide 9: the service does not do continuing medical treatment,
  but the nurse does apply prescribed ointment (outside pressure-ulcer
  care, per the 2005 MHLW notice), gives first aid and suctions in an
  emergency — "the roles differ" rather than "we cannot"
- add the participatory transfer demonstration (8 min) after slide 13,
  with a running order, safety rules and what to bring
Timings across the talk are re-cut to fund the demo (Q&A 10 to 6 min),
the fee answer matches the corrected handout, and the speaker notes for
slides 1, 7, 9 and 13 follow.

Co-Authored-By: Claude Opus 5 <noreply@anthropic.com>
Claude-Session: https://claude.ai/code/session_01EuVvTjbyv3WUxHVeG4YeGS
</commit_message>
<xml_diff>
--- a/houmon-nyuyoku-slides.pptx
+++ b/houmon-nyuyoku-slides.pptx
@@ -866,12 +866,22 @@
           </a:p>
           <a:p>
             <a:r>
+              <a:t>・★スタッフ紹介「介護職員の高崎と、武末です」→ 2名が一礼</a:t>
+            </a:r>
+          </a:p>
+          <a:p>
+            <a:r>
+              <a:t>  「のちほど移乗を、この3人で実際にお見せします」</a:t>
+            </a:r>
+          </a:p>
+          <a:p>
+            <a:r>
               <a:t>・「何か月もお風呂に入っていない方が実際にいる」→ ひと呼吸おく</a:t>
             </a:r>
           </a:p>
           <a:p>
             <a:r>
-              <a:t>・本日の流れ：動画7分 → スライド40分 → 質疑10分</a:t>
+              <a:t>・流れ：動画7分 → スライド → 移乗の実演 → 質疑5分</a:t>
             </a:r>
           </a:p>
           <a:p>
@@ -984,7 +994,7 @@
           <a:lstStyle/>
           <a:p>
             <a:r>
-              <a:t>［35:00〜38:30／3分半］連携のお願い　★山場・今日の本題</a:t>
+              <a:t>［32:30〜36:00／3分半］連携のお願い　★山場・今日の本題</a:t>
             </a:r>
           </a:p>
           <a:p>
@@ -1117,7 +1127,7 @@
           <a:lstStyle/>
           <a:p>
             <a:r>
-              <a:t>［38:30〜41:30／3分］在宅チームの一員として</a:t>
+              <a:t>［36:00〜38:30／2分半］在宅チームの一員として</a:t>
             </a:r>
           </a:p>
           <a:p>
@@ -1250,7 +1260,7 @@
           <a:lstStyle/>
           <a:p>
             <a:r>
-              <a:t>［41:30〜44:30／3分］単位数</a:t>
+              <a:t>［38:30〜41:00／2分半］単位数</a:t>
             </a:r>
           </a:p>
           <a:p>
@@ -1388,27 +1398,17 @@
           <a:lstStyle/>
           <a:p>
             <a:r>
-              <a:t>［44:30〜46:30／2分］利用者・ご家族の声</a:t>
-            </a:r>
-          </a:p>
-          <a:p>
-            <a:r>
-              <a:t>・80代要介護5のご本人「毎週のお風呂が楽しみで、それだけで前向きに」</a:t>
-            </a:r>
-          </a:p>
-          <a:p>
-            <a:r>
-              <a:t>  →「"それだけで"とおっしゃった」</a:t>
-            </a:r>
-          </a:p>
-          <a:p>
-            <a:r>
-              <a:t>・70代ご家族「一人では絶対に無理でした。プロに任せることで安心して</a:t>
-            </a:r>
-          </a:p>
-          <a:p>
-            <a:r>
-              <a:t>  介護できるようになりました」</a:t>
+              <a:t>［41:00〜42:30／1分半］利用者・ご家族の声</a:t>
+            </a:r>
+          </a:p>
+          <a:p>
+            <a:r>
+              <a:t>・80代要介護5「毎週のお風呂が楽しみで、それだけで前向きに」</a:t>
+            </a:r>
+          </a:p>
+          <a:p>
+            <a:r>
+              <a:t>・70代ご家族「一人では絶対に無理でした。安心して介護できるように」</a:t>
             </a:r>
           </a:p>
           <a:p>
@@ -1418,7 +1418,32 @@
           </a:p>
           <a:p>
             <a:r>
-              <a:t>【押していたら】このスライドを丸ごと飛ばす。−2分</a:t>
+              <a:t>【この直後に★移乗デモ（8分）】</a:t>
+            </a:r>
+          </a:p>
+          <a:p>
+            <a:r>
+              <a:t>  冨永＝説明／高崎・武末＝実演</a:t>
+            </a:r>
+          </a:p>
+          <a:p>
+            <a:r>
+              <a:t>  抱き上げ／担架／上下移動／座位回転 … それぞれ「どんな方に使うか」を1文</a:t>
+            </a:r>
+          </a:p>
+          <a:p>
+            <a:r>
+              <a:t>  体験は挙手を待つ。指名しない。腰・首の既往を確認。1人だけ</a:t>
+            </a:r>
+          </a:p>
+          <a:p>
+            <a:r>
+              <a:t>  手が挙がらなければ、スタッフだけでお見せするに切り替える</a:t>
+            </a:r>
+          </a:p>
+          <a:p>
+            <a:r>
+              <a:t>【押していたら】このスライドを丸ごと飛ばす。−1分半</a:t>
             </a:r>
           </a:p>
         </p:txBody>
@@ -1511,7 +1536,7 @@
           <a:lstStyle/>
           <a:p>
             <a:r>
-              <a:t>［46:30〜48:30／2分］まとめ</a:t>
+              <a:t>［50:30〜52:30／2分］まとめ</a:t>
             </a:r>
           </a:p>
           <a:p>
@@ -1629,7 +1654,7 @@
           <a:lstStyle/>
           <a:p>
             <a:r>
-              <a:t>［48:30〜50:00／1分半］連絡先</a:t>
+              <a:t>［52:30〜54:00／1分半］連絡先</a:t>
             </a:r>
           </a:p>
           <a:p>
@@ -1752,7 +1777,7 @@
           <a:lstStyle/>
           <a:p>
             <a:r>
-              <a:t>［9:30〜13:00／3分半］在宅で入浴できない現実</a:t>
+              <a:t>［9:30〜12:30／3分］在宅で入浴できない現実</a:t>
             </a:r>
           </a:p>
           <a:p>
@@ -1870,7 +1895,7 @@
           <a:lstStyle/>
           <a:p>
             <a:r>
-              <a:t>［13:00〜16:30／3分半］選択肢と限界</a:t>
+              <a:t>［12:30〜15:30／3分］選択肢と限界</a:t>
             </a:r>
           </a:p>
           <a:p>
@@ -1993,7 +2018,7 @@
           <a:lstStyle/>
           <a:p>
             <a:r>
-              <a:t>［16:30〜20:30／4分］比較表　★山場</a:t>
+              <a:t>［15:30〜19:30／4分］比較表　★山場</a:t>
             </a:r>
           </a:p>
           <a:p>
@@ -2126,7 +2151,7 @@
           <a:lstStyle/>
           <a:p>
             <a:r>
-              <a:t>［20:30〜23:00／2分半］4つの条件</a:t>
+              <a:t>［19:30〜21:30／2分］4つの条件</a:t>
             </a:r>
           </a:p>
           <a:p>
@@ -2244,7 +2269,7 @@
           <a:lstStyle/>
           <a:p>
             <a:r>
-              <a:t>［23:00〜25:30／2分半］訪問の流れ</a:t>
+              <a:t>［21:30〜23:30／2分］訪問の流れ</a:t>
             </a:r>
           </a:p>
           <a:p>
@@ -2367,7 +2392,7 @@
           <a:lstStyle/>
           <a:p>
             <a:r>
-              <a:t>［25:30〜28:00／2分半］3名体制</a:t>
+              <a:t>［23:30〜25:30／2分］3名体制</a:t>
             </a:r>
           </a:p>
           <a:p>
@@ -2387,17 +2412,17 @@
           </a:p>
           <a:p>
             <a:r>
-              <a:t>・「観察と記録はするが処置はしない」← 次の次で詳述</a:t>
-            </a:r>
-          </a:p>
-          <a:p>
-            <a:r>
               <a:t>・介護2名が移乗を担うので、看護師は観察と判断に専念できる</a:t>
             </a:r>
           </a:p>
           <a:p>
             <a:r>
-              <a:t>【押していたら】省令の3名体制＋専念できる、の2点。−1分半</a:t>
+              <a:t>・★締めに予告「この移乗は、のちほど実際にお見せします」</a:t>
+            </a:r>
+          </a:p>
+          <a:p>
+            <a:r>
+              <a:t>【押していたら】省令の3名体制＋専念できる＋予告、の3点。−1分</a:t>
             </a:r>
           </a:p>
         </p:txBody>
@@ -2490,7 +2515,7 @@
           <a:lstStyle/>
           <a:p>
             <a:r>
-              <a:t>［28:00〜31:30／3分半］入浴は全身をみる場　※今日の中心</a:t>
+              <a:t>［25:30〜29:00／3分半］入浴は全身をみる場　※今日の中心</a:t>
             </a:r>
           </a:p>
           <a:p>
@@ -2618,12 +2643,17 @@
           <a:lstStyle/>
           <a:p>
             <a:r>
-              <a:t>［31:30〜35:00／3分半］役割分担</a:t>
-            </a:r>
-          </a:p>
-          <a:p>
-            <a:r>
-              <a:t>・「訪問入浴は介護保険サービス。医療行為は行えません」← ごまかさない</a:t>
+              <a:t>［29:00〜32:30／3分半］役割分担　※言い方を変更</a:t>
+            </a:r>
+          </a:p>
+          <a:p>
+            <a:r>
+              <a:t>・「医療行為は行えません」とは言わない。「役割が違う」で通す</a:t>
+            </a:r>
+          </a:p>
+          <a:p>
+            <a:r>
+              <a:t>・訪問入浴＝介護保険、訪問看護＝医療保険。担う範囲が違う</a:t>
             </a:r>
           </a:p>
           <a:p>
@@ -2633,27 +2663,47 @@
           </a:p>
           <a:p>
             <a:r>
-              <a:t>・右＝訪問看護へ：創傷処置・薬剤／点滴注射採血／カテーテル・ストーマ／</a:t>
-            </a:r>
-          </a:p>
-          <a:p>
-            <a:r>
-              <a:t>  喀痰吸引・経管栄養／医師の指示による医療的ケア全般</a:t>
-            </a:r>
-          </a:p>
-          <a:p>
-            <a:r>
-              <a:t>・例：仙骨部の発赤を見つけても、軟膏は塗らない。記録して当日中に伝える</a:t>
-            </a:r>
-          </a:p>
-          <a:p>
-            <a:r>
-              <a:t>・「私も看護師なので手を出したくなる。でも線引きが安全につながる」</a:t>
-            </a:r>
-          </a:p>
-          <a:p>
-            <a:r>
-              <a:t>・「見つけて、つなぐ」</a:t>
+              <a:t>・★その場でできることはしている</a:t>
+            </a:r>
+          </a:p>
+          <a:p>
+            <a:r>
+              <a:t>  - 保湿剤・処方された軟膏の塗布（褥瘡の処置を除く）＝医行為に当たらない</a:t>
+            </a:r>
+          </a:p>
+          <a:p>
+            <a:r>
+              <a:t>  - 急変時の応急対応、吸引にも対応する</a:t>
+            </a:r>
+          </a:p>
+          <a:p>
+            <a:r>
+              <a:t>  - 「できないのではなく、継続的に担うのが役割ではない」</a:t>
+            </a:r>
+          </a:p>
+          <a:p>
+            <a:r>
+              <a:t>・右＝訪問看護へ：創傷の継続的処置／点滴注射採血／カテーテル・ストーマ／</a:t>
+            </a:r>
+          </a:p>
+          <a:p>
+            <a:r>
+              <a:t>  経管栄養／医師の指示による計画的な医療的ケア</a:t>
+            </a:r>
+          </a:p>
+          <a:p>
+            <a:r>
+              <a:t>・例：仙骨部の発赤 → 当日中に訪看と主治医へ。処置の継続は訪看の役割</a:t>
+            </a:r>
+          </a:p>
+          <a:p>
+            <a:r>
+              <a:t>・「見つけて、つなぐ。そのうえで、その場でできることはする」</a:t>
+            </a:r>
+          </a:p>
+          <a:p>
+            <a:r>
+              <a:t>【注意】ふだん実際にやっていることだけを話す。根拠は平成17年の厚労省通知</a:t>
             </a:r>
           </a:p>
         </p:txBody>

</xml_diff>

<commit_message>
Add a slide for the four transfer methods
The demonstration needs something on screen for the audience to follow,
so a new slide 14 lists 抱き上げ/担架/上下/座位回転 as four cards, each
with who it suits and what it is best at, under the line that the method
is chosen per person. まとめ and 連絡先 shift to 15 and 16, and the
script's numbering follows. tools/add_demo_slide.py builds the slide.

Co-Authored-By: Claude Opus 5 <noreply@anthropic.com>
Claude-Session: https://claude.ai/code/session_01EuVvTjbyv3WUxHVeG4YeGS
</commit_message>
<xml_diff>
--- a/houmon-nyuyoku-slides.pptx
+++ b/houmon-nyuyoku-slides.pptx
@@ -21,6 +21,7 @@
     <p:sldId id="266" r:id="rId12"/>
     <p:sldId id="267" r:id="rId13"/>
     <p:sldId id="268" r:id="rId14"/>
+    <p:sldId id="271" r:id="rId24"/>
     <p:sldId id="269" r:id="rId15"/>
     <p:sldId id="270" r:id="rId16"/>
   </p:sldIdLst>
@@ -1725,6 +1726,102 @@
 </p:notes>
 </file>
 
+<file path=ppt/notesSlides/notesSlide16.xml><?xml version="1.0" encoding="utf-8"?>
+<p:notes xmlns:a="http://schemas.openxmlformats.org/drawingml/2006/main" xmlns:p="http://schemas.openxmlformats.org/presentationml/2006/main" xmlns:r="http://schemas.openxmlformats.org/officeDocument/2006/relationships">
+  <p:cSld>
+    <p:spTree>
+      <p:nvGrpSpPr>
+        <p:cNvPr id="1" name=""/>
+        <p:cNvGrpSpPr/>
+        <p:nvPr/>
+      </p:nvGrpSpPr>
+      <p:grpSpPr>
+        <a:xfrm>
+          <a:off x="0" y="0"/>
+          <a:ext cx="0" cy="0"/>
+          <a:chOff x="0" y="0"/>
+          <a:chExt cx="0" cy="0"/>
+        </a:xfrm>
+      </p:grpSpPr>
+      <p:sp>
+        <p:nvSpPr>
+          <p:cNvPr id="3" name="Notes Placeholder 2"/>
+          <p:cNvSpPr>
+            <a:spLocks noGrp="1"/>
+          </p:cNvSpPr>
+          <p:nvPr>
+            <p:ph type="body" idx="1"/>
+          </p:nvPr>
+        </p:nvSpPr>
+        <p:spPr/>
+        <p:txBody>
+          <a:bodyPr/>
+          <a:lstStyle/>
+          <a:p>
+            <a:r>
+              <a:t>［42:30〜50:30／8分］★移乗デモンストレーション</a:t>
+            </a:r>
+          </a:p>
+          <a:p>
+            <a:r>
+              <a:t>・冨永＝説明と進行／高崎・武末＝実演</a:t>
+            </a:r>
+          </a:p>
+          <a:p>
+            <a:r>
+              <a:t>・導入「ここで少し、体を動かしていただきます」</a:t>
+            </a:r>
+          </a:p>
+          <a:p>
+            <a:r>
+              <a:t>・4つを実演しながら説明。名前だけでなく「どんな方に使うか」を必ず添える</a:t>
+            </a:r>
+          </a:p>
+          <a:p>
+            <a:r>
+              <a:t>  抱き上げ＝小柄・拘縮少ない／担架＝大柄・全介助／</a:t>
+            </a:r>
+          </a:p>
+          <a:p>
+            <a:r>
+              <a:t>  上下＝高さを合わせ水平に／座位回転＝座位が保てる方</a:t>
+            </a:r>
+          </a:p>
+          <a:p>
+            <a:r>
+              <a:t>・体験（3分）「どなたか、お体を預けてみていただけませんか」</a:t>
+            </a:r>
+          </a:p>
+          <a:p>
+            <a:r>
+              <a:t>  → 挙手を待つ。指名しない。腰・首の既往を確認。1人だけ。担架がおすすめ</a:t>
+            </a:r>
+          </a:p>
+          <a:p>
+            <a:r>
+              <a:t>  → 手が挙がらなければ「ではスタッフでお見せします」に即切り替え</a:t>
+            </a:r>
+          </a:p>
+          <a:p>
+            <a:r>
+              <a:t>・締め「持ち上げられる側は、怖いものです。だからその方ごとに決めています」</a:t>
+            </a:r>
+          </a:p>
+          <a:p>
+            <a:r>
+              <a:t>【押していたら】体験を省いて実演だけ −3分／2方法に絞る さらに−2分</a:t>
+            </a:r>
+          </a:p>
+        </p:txBody>
+      </p:sp>
+    </p:spTree>
+  </p:cSld>
+  <p:clrMapOvr>
+    <a:masterClrMapping/>
+  </p:clrMapOvr>
+</p:notes>
+</file>
+
 <file path=ppt/notesSlides/notesSlide2.xml><?xml version="1.0" encoding="utf-8"?>
 <p:notes xmlns:a="http://schemas.openxmlformats.org/drawingml/2006/main" xmlns:r="http://schemas.openxmlformats.org/officeDocument/2006/relationships" xmlns:p="http://schemas.openxmlformats.org/presentationml/2006/main">
   <p:cSld>
@@ -8612,6 +8709,1451 @@
               <a:t>初回アセスメントは無料でお伺いします。導入の可否判断からお手伝いします。</a:t>
             </a:r>
             <a:endParaRPr lang="en-US" sz="1200" dirty="0"/>
+          </a:p>
+        </p:txBody>
+      </p:sp>
+    </p:spTree>
+  </p:cSld>
+  <p:clrMapOvr>
+    <a:masterClrMapping/>
+  </p:clrMapOvr>
+</p:sld>
+</file>
+
+<file path=ppt/slides/slide16.xml><?xml version="1.0" encoding="utf-8"?>
+<p:sld xmlns:a="http://schemas.openxmlformats.org/drawingml/2006/main" xmlns:p="http://schemas.openxmlformats.org/presentationml/2006/main" xmlns:r="http://schemas.openxmlformats.org/officeDocument/2006/relationships">
+  <p:cSld>
+    <p:spTree>
+      <p:nvGrpSpPr>
+        <p:cNvPr id="1" name=""/>
+        <p:cNvGrpSpPr/>
+        <p:nvPr/>
+      </p:nvGrpSpPr>
+      <p:grpSpPr/>
+      <p:sp>
+        <p:nvSpPr>
+          <p:cNvPr id="2" name="Rounded Rectangle 1"/>
+          <p:cNvSpPr/>
+          <p:nvPr/>
+        </p:nvSpPr>
+        <p:spPr>
+          <a:xfrm>
+            <a:off x="566928" y="329184"/>
+            <a:ext cx="1481328" cy="310896"/>
+          </a:xfrm>
+          <a:prstGeom prst="roundRect">
+            <a:avLst>
+              <a:gd name="adj" fmla="val 14705"/>
+            </a:avLst>
+          </a:prstGeom>
+          <a:solidFill>
+            <a:srgbClr val="1D9E75"/>
+          </a:solidFill>
+          <a:ln>
+            <a:noFill/>
+          </a:ln>
+          <a:effectLst/>
+        </p:spPr>
+        <p:style>
+          <a:lnRef idx="1">
+            <a:schemeClr val="accent1"/>
+          </a:lnRef>
+          <a:fillRef idx="3">
+            <a:schemeClr val="accent1"/>
+          </a:fillRef>
+          <a:effectRef idx="2">
+            <a:schemeClr val="accent1"/>
+          </a:effectRef>
+          <a:fontRef idx="minor">
+            <a:schemeClr val="lt1"/>
+          </a:fontRef>
+        </p:style>
+        <p:txBody>
+          <a:bodyPr rtlCol="0" anchor="ctr"/>
+          <a:lstStyle/>
+          <a:p>
+            <a:pPr algn="ctr"/>
+          </a:p>
+        </p:txBody>
+      </p:sp>
+      <p:sp>
+        <p:nvSpPr>
+          <p:cNvPr id="3" name="TextBox 2"/>
+          <p:cNvSpPr txBox="1"/>
+          <p:nvPr/>
+        </p:nvSpPr>
+        <p:spPr>
+          <a:xfrm>
+            <a:off x="566928" y="329184"/>
+            <a:ext cx="1481328" cy="310896"/>
+          </a:xfrm>
+          <a:prstGeom prst="rect">
+            <a:avLst/>
+          </a:prstGeom>
+          <a:noFill/>
+        </p:spPr>
+        <p:txBody>
+          <a:bodyPr wrap="square" anchor="ctr" lIns="0" rIns="0" tIns="0" bIns="0">
+            <a:spAutoFit/>
+          </a:bodyPr>
+          <a:lstStyle/>
+          <a:p>
+            <a:pPr algn="ctr"/>
+            <a:r>
+              <a:rPr sz="1200" b="1">
+                <a:solidFill>
+                  <a:srgbClr val="FFFFFF"/>
+                </a:solidFill>
+                <a:latin typeface="Meiryo"/>
+              </a:rPr>
+              <a:t>DEMO</a:t>
+            </a:r>
+          </a:p>
+        </p:txBody>
+      </p:sp>
+      <p:sp>
+        <p:nvSpPr>
+          <p:cNvPr id="4" name="TextBox 3"/>
+          <p:cNvSpPr txBox="1"/>
+          <p:nvPr/>
+        </p:nvSpPr>
+        <p:spPr>
+          <a:xfrm>
+            <a:off x="2194560" y="329184"/>
+            <a:ext cx="5486400" cy="310896"/>
+          </a:xfrm>
+          <a:prstGeom prst="rect">
+            <a:avLst/>
+          </a:prstGeom>
+          <a:noFill/>
+        </p:spPr>
+        <p:txBody>
+          <a:bodyPr wrap="square" anchor="ctr" lIns="0" rIns="0" tIns="0" bIns="0">
+            <a:spAutoFit/>
+          </a:bodyPr>
+          <a:lstStyle/>
+          <a:p>
+            <a:pPr algn="l"/>
+            <a:r>
+              <a:rPr sz="1300" b="0">
+                <a:solidFill>
+                  <a:srgbClr val="566573"/>
+                </a:solidFill>
+                <a:latin typeface="Meiryo"/>
+              </a:rPr>
+              <a:t>移乗の実演</a:t>
+            </a:r>
+          </a:p>
+        </p:txBody>
+      </p:sp>
+      <p:sp>
+        <p:nvSpPr>
+          <p:cNvPr id="5" name="TextBox 4"/>
+          <p:cNvSpPr txBox="1"/>
+          <p:nvPr/>
+        </p:nvSpPr>
+        <p:spPr>
+          <a:xfrm>
+            <a:off x="566928" y="749808"/>
+            <a:ext cx="11055096" cy="566928"/>
+          </a:xfrm>
+          <a:prstGeom prst="rect">
+            <a:avLst/>
+          </a:prstGeom>
+          <a:noFill/>
+        </p:spPr>
+        <p:txBody>
+          <a:bodyPr wrap="square" anchor="t" lIns="0" rIns="0" tIns="0" bIns="0">
+            <a:spAutoFit/>
+          </a:bodyPr>
+          <a:lstStyle/>
+          <a:p>
+            <a:pPr algn="l"/>
+            <a:r>
+              <a:rPr sz="3400" b="1">
+                <a:solidFill>
+                  <a:srgbClr val="1A5276"/>
+                </a:solidFill>
+                <a:latin typeface="Meiryo"/>
+              </a:rPr>
+              <a:t>お体を、どうお運びするか</a:t>
+            </a:r>
+          </a:p>
+        </p:txBody>
+      </p:sp>
+      <p:sp>
+        <p:nvSpPr>
+          <p:cNvPr id="6" name="TextBox 5"/>
+          <p:cNvSpPr txBox="1"/>
+          <p:nvPr/>
+        </p:nvSpPr>
+        <p:spPr>
+          <a:xfrm>
+            <a:off x="566928" y="1463040"/>
+            <a:ext cx="11055096" cy="310896"/>
+          </a:xfrm>
+          <a:prstGeom prst="rect">
+            <a:avLst/>
+          </a:prstGeom>
+          <a:noFill/>
+        </p:spPr>
+        <p:txBody>
+          <a:bodyPr wrap="square" anchor="t" lIns="0" rIns="0" tIns="0" bIns="0">
+            <a:spAutoFit/>
+          </a:bodyPr>
+          <a:lstStyle/>
+          <a:p>
+            <a:pPr algn="l"/>
+            <a:r>
+              <a:rPr sz="1400" b="0">
+                <a:solidFill>
+                  <a:srgbClr val="566573"/>
+                </a:solidFill>
+                <a:latin typeface="Meiryo"/>
+              </a:rPr>
+              <a:t>浴槽へお移しする方法は4つ。その方の状態に合わせて選びます。</a:t>
+            </a:r>
+          </a:p>
+        </p:txBody>
+      </p:sp>
+      <p:sp>
+        <p:nvSpPr>
+          <p:cNvPr id="7" name="Rounded Rectangle 6"/>
+          <p:cNvSpPr/>
+          <p:nvPr/>
+        </p:nvSpPr>
+        <p:spPr>
+          <a:xfrm>
+            <a:off x="566928" y="2011680"/>
+            <a:ext cx="2697480" cy="2788920"/>
+          </a:xfrm>
+          <a:prstGeom prst="roundRect">
+            <a:avLst>
+              <a:gd name="adj" fmla="val 3389"/>
+            </a:avLst>
+          </a:prstGeom>
+          <a:solidFill>
+            <a:srgbClr val="F4F8FA"/>
+          </a:solidFill>
+          <a:ln>
+            <a:noFill/>
+          </a:ln>
+          <a:effectLst/>
+        </p:spPr>
+        <p:style>
+          <a:lnRef idx="1">
+            <a:schemeClr val="accent1"/>
+          </a:lnRef>
+          <a:fillRef idx="3">
+            <a:schemeClr val="accent1"/>
+          </a:fillRef>
+          <a:effectRef idx="2">
+            <a:schemeClr val="accent1"/>
+          </a:effectRef>
+          <a:fontRef idx="minor">
+            <a:schemeClr val="lt1"/>
+          </a:fontRef>
+        </p:style>
+        <p:txBody>
+          <a:bodyPr rtlCol="0" anchor="ctr"/>
+          <a:lstStyle/>
+          <a:p>
+            <a:pPr algn="ctr"/>
+          </a:p>
+        </p:txBody>
+      </p:sp>
+      <p:sp>
+        <p:nvSpPr>
+          <p:cNvPr id="8" name="Rounded Rectangle 7"/>
+          <p:cNvSpPr/>
+          <p:nvPr/>
+        </p:nvSpPr>
+        <p:spPr>
+          <a:xfrm>
+            <a:off x="566928" y="2011680"/>
+            <a:ext cx="2697480" cy="566928"/>
+          </a:xfrm>
+          <a:prstGeom prst="roundRect">
+            <a:avLst>
+              <a:gd name="adj" fmla="val 16129"/>
+            </a:avLst>
+          </a:prstGeom>
+          <a:solidFill>
+            <a:srgbClr val="1A5276"/>
+          </a:solidFill>
+          <a:ln>
+            <a:noFill/>
+          </a:ln>
+          <a:effectLst/>
+        </p:spPr>
+        <p:style>
+          <a:lnRef idx="1">
+            <a:schemeClr val="accent1"/>
+          </a:lnRef>
+          <a:fillRef idx="3">
+            <a:schemeClr val="accent1"/>
+          </a:fillRef>
+          <a:effectRef idx="2">
+            <a:schemeClr val="accent1"/>
+          </a:effectRef>
+          <a:fontRef idx="minor">
+            <a:schemeClr val="lt1"/>
+          </a:fontRef>
+        </p:style>
+        <p:txBody>
+          <a:bodyPr rtlCol="0" anchor="ctr"/>
+          <a:lstStyle/>
+          <a:p>
+            <a:pPr algn="ctr"/>
+          </a:p>
+        </p:txBody>
+      </p:sp>
+      <p:sp>
+        <p:nvSpPr>
+          <p:cNvPr id="9" name="TextBox 8"/>
+          <p:cNvSpPr txBox="1"/>
+          <p:nvPr/>
+        </p:nvSpPr>
+        <p:spPr>
+          <a:xfrm>
+            <a:off x="566928" y="2011680"/>
+            <a:ext cx="2697480" cy="566928"/>
+          </a:xfrm>
+          <a:prstGeom prst="rect">
+            <a:avLst/>
+          </a:prstGeom>
+          <a:noFill/>
+        </p:spPr>
+        <p:txBody>
+          <a:bodyPr wrap="square" anchor="ctr" lIns="0" rIns="0" tIns="0" bIns="0">
+            <a:spAutoFit/>
+          </a:bodyPr>
+          <a:lstStyle/>
+          <a:p>
+            <a:pPr algn="ctr"/>
+            <a:r>
+              <a:rPr sz="1700" b="1">
+                <a:solidFill>
+                  <a:srgbClr val="FFFFFF"/>
+                </a:solidFill>
+                <a:latin typeface="Meiryo"/>
+              </a:rPr>
+              <a:t>抱き上げ移動</a:t>
+            </a:r>
+          </a:p>
+        </p:txBody>
+      </p:sp>
+      <p:sp>
+        <p:nvSpPr>
+          <p:cNvPr id="10" name="TextBox 9"/>
+          <p:cNvSpPr txBox="1"/>
+          <p:nvPr/>
+        </p:nvSpPr>
+        <p:spPr>
+          <a:xfrm>
+            <a:off x="768096" y="2743200"/>
+            <a:ext cx="2295144" cy="237744"/>
+          </a:xfrm>
+          <a:prstGeom prst="rect">
+            <a:avLst/>
+          </a:prstGeom>
+          <a:noFill/>
+        </p:spPr>
+        <p:txBody>
+          <a:bodyPr wrap="square" anchor="t" lIns="0" rIns="0" tIns="0" bIns="0">
+            <a:spAutoFit/>
+          </a:bodyPr>
+          <a:lstStyle/>
+          <a:p>
+            <a:pPr algn="l"/>
+            <a:r>
+              <a:rPr sz="1100" b="1">
+                <a:solidFill>
+                  <a:srgbClr val="1D9E75"/>
+                </a:solidFill>
+                <a:latin typeface="Meiryo"/>
+              </a:rPr>
+              <a:t>こんな方に</a:t>
+            </a:r>
+          </a:p>
+        </p:txBody>
+      </p:sp>
+      <p:sp>
+        <p:nvSpPr>
+          <p:cNvPr id="11" name="TextBox 10"/>
+          <p:cNvSpPr txBox="1"/>
+          <p:nvPr/>
+        </p:nvSpPr>
+        <p:spPr>
+          <a:xfrm>
+            <a:off x="768096" y="3035808"/>
+            <a:ext cx="2295144" cy="1005840"/>
+          </a:xfrm>
+          <a:prstGeom prst="rect">
+            <a:avLst/>
+          </a:prstGeom>
+          <a:noFill/>
+        </p:spPr>
+        <p:txBody>
+          <a:bodyPr wrap="square" anchor="t" lIns="0" rIns="0" tIns="0" bIns="0">
+            <a:spAutoFit/>
+          </a:bodyPr>
+          <a:lstStyle/>
+          <a:p>
+            <a:pPr algn="l"/>
+            <a:r>
+              <a:rPr sz="1350" b="0">
+                <a:solidFill>
+                  <a:srgbClr val="1C2833"/>
+                </a:solidFill>
+                <a:latin typeface="Meiryo"/>
+              </a:rPr>
+              <a:t>体格が小さく、拘縮の</a:t>
+            </a:r>
+          </a:p>
+          <a:p>
+            <a:pPr algn="l">
+              <a:spcBef>
+                <a:spcPts val="400"/>
+              </a:spcBef>
+            </a:pPr>
+            <a:r>
+              <a:rPr sz="1350" b="0">
+                <a:solidFill>
+                  <a:srgbClr val="1C2833"/>
+                </a:solidFill>
+                <a:latin typeface="Meiryo"/>
+              </a:rPr>
+              <a:t>少ない方</a:t>
+            </a:r>
+          </a:p>
+        </p:txBody>
+      </p:sp>
+      <p:sp>
+        <p:nvSpPr>
+          <p:cNvPr id="12" name="Rounded Rectangle 11"/>
+          <p:cNvSpPr/>
+          <p:nvPr/>
+        </p:nvSpPr>
+        <p:spPr>
+          <a:xfrm>
+            <a:off x="768096" y="4096512"/>
+            <a:ext cx="2295144" cy="457200"/>
+          </a:xfrm>
+          <a:prstGeom prst="roundRect">
+            <a:avLst>
+              <a:gd name="adj" fmla="val 20000"/>
+            </a:avLst>
+          </a:prstGeom>
+          <a:solidFill>
+            <a:srgbClr val="EAF7F1"/>
+          </a:solidFill>
+          <a:ln>
+            <a:noFill/>
+          </a:ln>
+          <a:effectLst/>
+        </p:spPr>
+        <p:style>
+          <a:lnRef idx="1">
+            <a:schemeClr val="accent1"/>
+          </a:lnRef>
+          <a:fillRef idx="3">
+            <a:schemeClr val="accent1"/>
+          </a:fillRef>
+          <a:effectRef idx="2">
+            <a:schemeClr val="accent1"/>
+          </a:effectRef>
+          <a:fontRef idx="minor">
+            <a:schemeClr val="lt1"/>
+          </a:fontRef>
+        </p:style>
+        <p:txBody>
+          <a:bodyPr rtlCol="0" anchor="ctr"/>
+          <a:lstStyle/>
+          <a:p>
+            <a:pPr algn="ctr"/>
+          </a:p>
+        </p:txBody>
+      </p:sp>
+      <p:sp>
+        <p:nvSpPr>
+          <p:cNvPr id="13" name="TextBox 12"/>
+          <p:cNvSpPr txBox="1"/>
+          <p:nvPr/>
+        </p:nvSpPr>
+        <p:spPr>
+          <a:xfrm>
+            <a:off x="768096" y="4096512"/>
+            <a:ext cx="2295144" cy="457200"/>
+          </a:xfrm>
+          <a:prstGeom prst="rect">
+            <a:avLst/>
+          </a:prstGeom>
+          <a:noFill/>
+        </p:spPr>
+        <p:txBody>
+          <a:bodyPr wrap="square" anchor="ctr" lIns="0" rIns="0" tIns="0" bIns="0">
+            <a:spAutoFit/>
+          </a:bodyPr>
+          <a:lstStyle/>
+          <a:p>
+            <a:pPr algn="ctr"/>
+            <a:r>
+              <a:rPr sz="1300" b="1">
+                <a:solidFill>
+                  <a:srgbClr val="1D9E75"/>
+                </a:solidFill>
+                <a:latin typeface="Meiryo"/>
+              </a:rPr>
+              <a:t>いちばん短時間</a:t>
+            </a:r>
+          </a:p>
+        </p:txBody>
+      </p:sp>
+      <p:sp>
+        <p:nvSpPr>
+          <p:cNvPr id="14" name="Rounded Rectangle 13"/>
+          <p:cNvSpPr/>
+          <p:nvPr/>
+        </p:nvSpPr>
+        <p:spPr>
+          <a:xfrm>
+            <a:off x="3355848" y="2011680"/>
+            <a:ext cx="2697480" cy="2788920"/>
+          </a:xfrm>
+          <a:prstGeom prst="roundRect">
+            <a:avLst>
+              <a:gd name="adj" fmla="val 3389"/>
+            </a:avLst>
+          </a:prstGeom>
+          <a:solidFill>
+            <a:srgbClr val="F4F8FA"/>
+          </a:solidFill>
+          <a:ln>
+            <a:noFill/>
+          </a:ln>
+          <a:effectLst/>
+        </p:spPr>
+        <p:style>
+          <a:lnRef idx="1">
+            <a:schemeClr val="accent1"/>
+          </a:lnRef>
+          <a:fillRef idx="3">
+            <a:schemeClr val="accent1"/>
+          </a:fillRef>
+          <a:effectRef idx="2">
+            <a:schemeClr val="accent1"/>
+          </a:effectRef>
+          <a:fontRef idx="minor">
+            <a:schemeClr val="lt1"/>
+          </a:fontRef>
+        </p:style>
+        <p:txBody>
+          <a:bodyPr rtlCol="0" anchor="ctr"/>
+          <a:lstStyle/>
+          <a:p>
+            <a:pPr algn="ctr"/>
+          </a:p>
+        </p:txBody>
+      </p:sp>
+      <p:sp>
+        <p:nvSpPr>
+          <p:cNvPr id="15" name="Rounded Rectangle 14"/>
+          <p:cNvSpPr/>
+          <p:nvPr/>
+        </p:nvSpPr>
+        <p:spPr>
+          <a:xfrm>
+            <a:off x="3355848" y="2011680"/>
+            <a:ext cx="2697480" cy="566928"/>
+          </a:xfrm>
+          <a:prstGeom prst="roundRect">
+            <a:avLst>
+              <a:gd name="adj" fmla="val 16129"/>
+            </a:avLst>
+          </a:prstGeom>
+          <a:solidFill>
+            <a:srgbClr val="1A5276"/>
+          </a:solidFill>
+          <a:ln>
+            <a:noFill/>
+          </a:ln>
+          <a:effectLst/>
+        </p:spPr>
+        <p:style>
+          <a:lnRef idx="1">
+            <a:schemeClr val="accent1"/>
+          </a:lnRef>
+          <a:fillRef idx="3">
+            <a:schemeClr val="accent1"/>
+          </a:fillRef>
+          <a:effectRef idx="2">
+            <a:schemeClr val="accent1"/>
+          </a:effectRef>
+          <a:fontRef idx="minor">
+            <a:schemeClr val="lt1"/>
+          </a:fontRef>
+        </p:style>
+        <p:txBody>
+          <a:bodyPr rtlCol="0" anchor="ctr"/>
+          <a:lstStyle/>
+          <a:p>
+            <a:pPr algn="ctr"/>
+          </a:p>
+        </p:txBody>
+      </p:sp>
+      <p:sp>
+        <p:nvSpPr>
+          <p:cNvPr id="16" name="TextBox 15"/>
+          <p:cNvSpPr txBox="1"/>
+          <p:nvPr/>
+        </p:nvSpPr>
+        <p:spPr>
+          <a:xfrm>
+            <a:off x="3355848" y="2011680"/>
+            <a:ext cx="2697480" cy="566928"/>
+          </a:xfrm>
+          <a:prstGeom prst="rect">
+            <a:avLst/>
+          </a:prstGeom>
+          <a:noFill/>
+        </p:spPr>
+        <p:txBody>
+          <a:bodyPr wrap="square" anchor="ctr" lIns="0" rIns="0" tIns="0" bIns="0">
+            <a:spAutoFit/>
+          </a:bodyPr>
+          <a:lstStyle/>
+          <a:p>
+            <a:pPr algn="ctr"/>
+            <a:r>
+              <a:rPr sz="1700" b="1">
+                <a:solidFill>
+                  <a:srgbClr val="FFFFFF"/>
+                </a:solidFill>
+                <a:latin typeface="Meiryo"/>
+              </a:rPr>
+              <a:t>担架移動</a:t>
+            </a:r>
+          </a:p>
+        </p:txBody>
+      </p:sp>
+      <p:sp>
+        <p:nvSpPr>
+          <p:cNvPr id="17" name="TextBox 16"/>
+          <p:cNvSpPr txBox="1"/>
+          <p:nvPr/>
+        </p:nvSpPr>
+        <p:spPr>
+          <a:xfrm>
+            <a:off x="3557016" y="2743200"/>
+            <a:ext cx="2295144" cy="237744"/>
+          </a:xfrm>
+          <a:prstGeom prst="rect">
+            <a:avLst/>
+          </a:prstGeom>
+          <a:noFill/>
+        </p:spPr>
+        <p:txBody>
+          <a:bodyPr wrap="square" anchor="t" lIns="0" rIns="0" tIns="0" bIns="0">
+            <a:spAutoFit/>
+          </a:bodyPr>
+          <a:lstStyle/>
+          <a:p>
+            <a:pPr algn="l"/>
+            <a:r>
+              <a:rPr sz="1100" b="1">
+                <a:solidFill>
+                  <a:srgbClr val="1D9E75"/>
+                </a:solidFill>
+                <a:latin typeface="Meiryo"/>
+              </a:rPr>
+              <a:t>こんな方に</a:t>
+            </a:r>
+          </a:p>
+        </p:txBody>
+      </p:sp>
+      <p:sp>
+        <p:nvSpPr>
+          <p:cNvPr id="18" name="TextBox 17"/>
+          <p:cNvSpPr txBox="1"/>
+          <p:nvPr/>
+        </p:nvSpPr>
+        <p:spPr>
+          <a:xfrm>
+            <a:off x="3557016" y="3035808"/>
+            <a:ext cx="2295144" cy="1005840"/>
+          </a:xfrm>
+          <a:prstGeom prst="rect">
+            <a:avLst/>
+          </a:prstGeom>
+          <a:noFill/>
+        </p:spPr>
+        <p:txBody>
+          <a:bodyPr wrap="square" anchor="t" lIns="0" rIns="0" tIns="0" bIns="0">
+            <a:spAutoFit/>
+          </a:bodyPr>
+          <a:lstStyle/>
+          <a:p>
+            <a:pPr algn="l"/>
+            <a:r>
+              <a:rPr sz="1350" b="0">
+                <a:solidFill>
+                  <a:srgbClr val="1C2833"/>
+                </a:solidFill>
+                <a:latin typeface="Meiryo"/>
+              </a:rPr>
+              <a:t>体の大きい方、</a:t>
+            </a:r>
+          </a:p>
+          <a:p>
+            <a:pPr algn="l">
+              <a:spcBef>
+                <a:spcPts val="400"/>
+              </a:spcBef>
+            </a:pPr>
+            <a:r>
+              <a:rPr sz="1350" b="0">
+                <a:solidFill>
+                  <a:srgbClr val="1C2833"/>
+                </a:solidFill>
+                <a:latin typeface="Meiryo"/>
+              </a:rPr>
+              <a:t>全介助の方</a:t>
+            </a:r>
+          </a:p>
+        </p:txBody>
+      </p:sp>
+      <p:sp>
+        <p:nvSpPr>
+          <p:cNvPr id="19" name="Rounded Rectangle 18"/>
+          <p:cNvSpPr/>
+          <p:nvPr/>
+        </p:nvSpPr>
+        <p:spPr>
+          <a:xfrm>
+            <a:off x="3557016" y="4096512"/>
+            <a:ext cx="2295144" cy="457200"/>
+          </a:xfrm>
+          <a:prstGeom prst="roundRect">
+            <a:avLst>
+              <a:gd name="adj" fmla="val 20000"/>
+            </a:avLst>
+          </a:prstGeom>
+          <a:solidFill>
+            <a:srgbClr val="EAF7F1"/>
+          </a:solidFill>
+          <a:ln>
+            <a:noFill/>
+          </a:ln>
+          <a:effectLst/>
+        </p:spPr>
+        <p:style>
+          <a:lnRef idx="1">
+            <a:schemeClr val="accent1"/>
+          </a:lnRef>
+          <a:fillRef idx="3">
+            <a:schemeClr val="accent1"/>
+          </a:fillRef>
+          <a:effectRef idx="2">
+            <a:schemeClr val="accent1"/>
+          </a:effectRef>
+          <a:fontRef idx="minor">
+            <a:schemeClr val="lt1"/>
+          </a:fontRef>
+        </p:style>
+        <p:txBody>
+          <a:bodyPr rtlCol="0" anchor="ctr"/>
+          <a:lstStyle/>
+          <a:p>
+            <a:pPr algn="ctr"/>
+          </a:p>
+        </p:txBody>
+      </p:sp>
+      <p:sp>
+        <p:nvSpPr>
+          <p:cNvPr id="20" name="TextBox 19"/>
+          <p:cNvSpPr txBox="1"/>
+          <p:nvPr/>
+        </p:nvSpPr>
+        <p:spPr>
+          <a:xfrm>
+            <a:off x="3557016" y="4096512"/>
+            <a:ext cx="2295144" cy="457200"/>
+          </a:xfrm>
+          <a:prstGeom prst="rect">
+            <a:avLst/>
+          </a:prstGeom>
+          <a:noFill/>
+        </p:spPr>
+        <p:txBody>
+          <a:bodyPr wrap="square" anchor="ctr" lIns="0" rIns="0" tIns="0" bIns="0">
+            <a:spAutoFit/>
+          </a:bodyPr>
+          <a:lstStyle/>
+          <a:p>
+            <a:pPr algn="ctr"/>
+            <a:r>
+              <a:rPr sz="1300" b="1">
+                <a:solidFill>
+                  <a:srgbClr val="1D9E75"/>
+                </a:solidFill>
+                <a:latin typeface="Meiryo"/>
+              </a:rPr>
+              <a:t>いちばん安全</a:t>
+            </a:r>
+          </a:p>
+        </p:txBody>
+      </p:sp>
+      <p:sp>
+        <p:nvSpPr>
+          <p:cNvPr id="21" name="Rounded Rectangle 20"/>
+          <p:cNvSpPr/>
+          <p:nvPr/>
+        </p:nvSpPr>
+        <p:spPr>
+          <a:xfrm>
+            <a:off x="6144768" y="2011680"/>
+            <a:ext cx="2697480" cy="2788920"/>
+          </a:xfrm>
+          <a:prstGeom prst="roundRect">
+            <a:avLst>
+              <a:gd name="adj" fmla="val 3389"/>
+            </a:avLst>
+          </a:prstGeom>
+          <a:solidFill>
+            <a:srgbClr val="F4F8FA"/>
+          </a:solidFill>
+          <a:ln>
+            <a:noFill/>
+          </a:ln>
+          <a:effectLst/>
+        </p:spPr>
+        <p:style>
+          <a:lnRef idx="1">
+            <a:schemeClr val="accent1"/>
+          </a:lnRef>
+          <a:fillRef idx="3">
+            <a:schemeClr val="accent1"/>
+          </a:fillRef>
+          <a:effectRef idx="2">
+            <a:schemeClr val="accent1"/>
+          </a:effectRef>
+          <a:fontRef idx="minor">
+            <a:schemeClr val="lt1"/>
+          </a:fontRef>
+        </p:style>
+        <p:txBody>
+          <a:bodyPr rtlCol="0" anchor="ctr"/>
+          <a:lstStyle/>
+          <a:p>
+            <a:pPr algn="ctr"/>
+          </a:p>
+        </p:txBody>
+      </p:sp>
+      <p:sp>
+        <p:nvSpPr>
+          <p:cNvPr id="22" name="Rounded Rectangle 21"/>
+          <p:cNvSpPr/>
+          <p:nvPr/>
+        </p:nvSpPr>
+        <p:spPr>
+          <a:xfrm>
+            <a:off x="6144768" y="2011680"/>
+            <a:ext cx="2697480" cy="566928"/>
+          </a:xfrm>
+          <a:prstGeom prst="roundRect">
+            <a:avLst>
+              <a:gd name="adj" fmla="val 16129"/>
+            </a:avLst>
+          </a:prstGeom>
+          <a:solidFill>
+            <a:srgbClr val="1A5276"/>
+          </a:solidFill>
+          <a:ln>
+            <a:noFill/>
+          </a:ln>
+          <a:effectLst/>
+        </p:spPr>
+        <p:style>
+          <a:lnRef idx="1">
+            <a:schemeClr val="accent1"/>
+          </a:lnRef>
+          <a:fillRef idx="3">
+            <a:schemeClr val="accent1"/>
+          </a:fillRef>
+          <a:effectRef idx="2">
+            <a:schemeClr val="accent1"/>
+          </a:effectRef>
+          <a:fontRef idx="minor">
+            <a:schemeClr val="lt1"/>
+          </a:fontRef>
+        </p:style>
+        <p:txBody>
+          <a:bodyPr rtlCol="0" anchor="ctr"/>
+          <a:lstStyle/>
+          <a:p>
+            <a:pPr algn="ctr"/>
+          </a:p>
+        </p:txBody>
+      </p:sp>
+      <p:sp>
+        <p:nvSpPr>
+          <p:cNvPr id="23" name="TextBox 22"/>
+          <p:cNvSpPr txBox="1"/>
+          <p:nvPr/>
+        </p:nvSpPr>
+        <p:spPr>
+          <a:xfrm>
+            <a:off x="6144768" y="2011680"/>
+            <a:ext cx="2697480" cy="566928"/>
+          </a:xfrm>
+          <a:prstGeom prst="rect">
+            <a:avLst/>
+          </a:prstGeom>
+          <a:noFill/>
+        </p:spPr>
+        <p:txBody>
+          <a:bodyPr wrap="square" anchor="ctr" lIns="0" rIns="0" tIns="0" bIns="0">
+            <a:spAutoFit/>
+          </a:bodyPr>
+          <a:lstStyle/>
+          <a:p>
+            <a:pPr algn="ctr"/>
+            <a:r>
+              <a:rPr sz="1700" b="1">
+                <a:solidFill>
+                  <a:srgbClr val="FFFFFF"/>
+                </a:solidFill>
+                <a:latin typeface="Meiryo"/>
+              </a:rPr>
+              <a:t>上下移動</a:t>
+            </a:r>
+          </a:p>
+        </p:txBody>
+      </p:sp>
+      <p:sp>
+        <p:nvSpPr>
+          <p:cNvPr id="24" name="TextBox 23"/>
+          <p:cNvSpPr txBox="1"/>
+          <p:nvPr/>
+        </p:nvSpPr>
+        <p:spPr>
+          <a:xfrm>
+            <a:off x="6345936" y="2743200"/>
+            <a:ext cx="2295144" cy="237744"/>
+          </a:xfrm>
+          <a:prstGeom prst="rect">
+            <a:avLst/>
+          </a:prstGeom>
+          <a:noFill/>
+        </p:spPr>
+        <p:txBody>
+          <a:bodyPr wrap="square" anchor="t" lIns="0" rIns="0" tIns="0" bIns="0">
+            <a:spAutoFit/>
+          </a:bodyPr>
+          <a:lstStyle/>
+          <a:p>
+            <a:pPr algn="l"/>
+            <a:r>
+              <a:rPr sz="1100" b="1">
+                <a:solidFill>
+                  <a:srgbClr val="1D9E75"/>
+                </a:solidFill>
+                <a:latin typeface="Meiryo"/>
+              </a:rPr>
+              <a:t>こんな方に</a:t>
+            </a:r>
+          </a:p>
+        </p:txBody>
+      </p:sp>
+      <p:sp>
+        <p:nvSpPr>
+          <p:cNvPr id="25" name="TextBox 24"/>
+          <p:cNvSpPr txBox="1"/>
+          <p:nvPr/>
+        </p:nvSpPr>
+        <p:spPr>
+          <a:xfrm>
+            <a:off x="6345936" y="3035808"/>
+            <a:ext cx="2295144" cy="1005840"/>
+          </a:xfrm>
+          <a:prstGeom prst="rect">
+            <a:avLst/>
+          </a:prstGeom>
+          <a:noFill/>
+        </p:spPr>
+        <p:txBody>
+          <a:bodyPr wrap="square" anchor="t" lIns="0" rIns="0" tIns="0" bIns="0">
+            <a:spAutoFit/>
+          </a:bodyPr>
+          <a:lstStyle/>
+          <a:p>
+            <a:pPr algn="l"/>
+            <a:r>
+              <a:rPr sz="1350" b="0">
+                <a:solidFill>
+                  <a:srgbClr val="1C2833"/>
+                </a:solidFill>
+                <a:latin typeface="Meiryo"/>
+              </a:rPr>
+              <a:t>ベッドと浴槽の高さを</a:t>
+            </a:r>
+          </a:p>
+          <a:p>
+            <a:pPr algn="l">
+              <a:spcBef>
+                <a:spcPts val="400"/>
+              </a:spcBef>
+            </a:pPr>
+            <a:r>
+              <a:rPr sz="1350" b="0">
+                <a:solidFill>
+                  <a:srgbClr val="1C2833"/>
+                </a:solidFill>
+                <a:latin typeface="Meiryo"/>
+              </a:rPr>
+              <a:t>合わせ、水平に</a:t>
+            </a:r>
+          </a:p>
+        </p:txBody>
+      </p:sp>
+      <p:sp>
+        <p:nvSpPr>
+          <p:cNvPr id="26" name="Rounded Rectangle 25"/>
+          <p:cNvSpPr/>
+          <p:nvPr/>
+        </p:nvSpPr>
+        <p:spPr>
+          <a:xfrm>
+            <a:off x="6345936" y="4096512"/>
+            <a:ext cx="2295144" cy="457200"/>
+          </a:xfrm>
+          <a:prstGeom prst="roundRect">
+            <a:avLst>
+              <a:gd name="adj" fmla="val 20000"/>
+            </a:avLst>
+          </a:prstGeom>
+          <a:solidFill>
+            <a:srgbClr val="EAF7F1"/>
+          </a:solidFill>
+          <a:ln>
+            <a:noFill/>
+          </a:ln>
+          <a:effectLst/>
+        </p:spPr>
+        <p:style>
+          <a:lnRef idx="1">
+            <a:schemeClr val="accent1"/>
+          </a:lnRef>
+          <a:fillRef idx="3">
+            <a:schemeClr val="accent1"/>
+          </a:fillRef>
+          <a:effectRef idx="2">
+            <a:schemeClr val="accent1"/>
+          </a:effectRef>
+          <a:fontRef idx="minor">
+            <a:schemeClr val="lt1"/>
+          </a:fontRef>
+        </p:style>
+        <p:txBody>
+          <a:bodyPr rtlCol="0" anchor="ctr"/>
+          <a:lstStyle/>
+          <a:p>
+            <a:pPr algn="ctr"/>
+          </a:p>
+        </p:txBody>
+      </p:sp>
+      <p:sp>
+        <p:nvSpPr>
+          <p:cNvPr id="27" name="TextBox 26"/>
+          <p:cNvSpPr txBox="1"/>
+          <p:nvPr/>
+        </p:nvSpPr>
+        <p:spPr>
+          <a:xfrm>
+            <a:off x="6345936" y="4096512"/>
+            <a:ext cx="2295144" cy="457200"/>
+          </a:xfrm>
+          <a:prstGeom prst="rect">
+            <a:avLst/>
+          </a:prstGeom>
+          <a:noFill/>
+        </p:spPr>
+        <p:txBody>
+          <a:bodyPr wrap="square" anchor="ctr" lIns="0" rIns="0" tIns="0" bIns="0">
+            <a:spAutoFit/>
+          </a:bodyPr>
+          <a:lstStyle/>
+          <a:p>
+            <a:pPr algn="ctr"/>
+            <a:r>
+              <a:rPr sz="1300" b="1">
+                <a:solidFill>
+                  <a:srgbClr val="1D9E75"/>
+                </a:solidFill>
+                <a:latin typeface="Meiryo"/>
+              </a:rPr>
+              <a:t>体への負担が少ない</a:t>
+            </a:r>
+          </a:p>
+        </p:txBody>
+      </p:sp>
+      <p:sp>
+        <p:nvSpPr>
+          <p:cNvPr id="28" name="Rounded Rectangle 27"/>
+          <p:cNvSpPr/>
+          <p:nvPr/>
+        </p:nvSpPr>
+        <p:spPr>
+          <a:xfrm>
+            <a:off x="8933688" y="2011680"/>
+            <a:ext cx="2697480" cy="2788920"/>
+          </a:xfrm>
+          <a:prstGeom prst="roundRect">
+            <a:avLst>
+              <a:gd name="adj" fmla="val 3389"/>
+            </a:avLst>
+          </a:prstGeom>
+          <a:solidFill>
+            <a:srgbClr val="F4F8FA"/>
+          </a:solidFill>
+          <a:ln>
+            <a:noFill/>
+          </a:ln>
+          <a:effectLst/>
+        </p:spPr>
+        <p:style>
+          <a:lnRef idx="1">
+            <a:schemeClr val="accent1"/>
+          </a:lnRef>
+          <a:fillRef idx="3">
+            <a:schemeClr val="accent1"/>
+          </a:fillRef>
+          <a:effectRef idx="2">
+            <a:schemeClr val="accent1"/>
+          </a:effectRef>
+          <a:fontRef idx="minor">
+            <a:schemeClr val="lt1"/>
+          </a:fontRef>
+        </p:style>
+        <p:txBody>
+          <a:bodyPr rtlCol="0" anchor="ctr"/>
+          <a:lstStyle/>
+          <a:p>
+            <a:pPr algn="ctr"/>
+          </a:p>
+        </p:txBody>
+      </p:sp>
+      <p:sp>
+        <p:nvSpPr>
+          <p:cNvPr id="29" name="Rounded Rectangle 28"/>
+          <p:cNvSpPr/>
+          <p:nvPr/>
+        </p:nvSpPr>
+        <p:spPr>
+          <a:xfrm>
+            <a:off x="8933688" y="2011680"/>
+            <a:ext cx="2697480" cy="566928"/>
+          </a:xfrm>
+          <a:prstGeom prst="roundRect">
+            <a:avLst>
+              <a:gd name="adj" fmla="val 16129"/>
+            </a:avLst>
+          </a:prstGeom>
+          <a:solidFill>
+            <a:srgbClr val="1A5276"/>
+          </a:solidFill>
+          <a:ln>
+            <a:noFill/>
+          </a:ln>
+          <a:effectLst/>
+        </p:spPr>
+        <p:style>
+          <a:lnRef idx="1">
+            <a:schemeClr val="accent1"/>
+          </a:lnRef>
+          <a:fillRef idx="3">
+            <a:schemeClr val="accent1"/>
+          </a:fillRef>
+          <a:effectRef idx="2">
+            <a:schemeClr val="accent1"/>
+          </a:effectRef>
+          <a:fontRef idx="minor">
+            <a:schemeClr val="lt1"/>
+          </a:fontRef>
+        </p:style>
+        <p:txBody>
+          <a:bodyPr rtlCol="0" anchor="ctr"/>
+          <a:lstStyle/>
+          <a:p>
+            <a:pPr algn="ctr"/>
+          </a:p>
+        </p:txBody>
+      </p:sp>
+      <p:sp>
+        <p:nvSpPr>
+          <p:cNvPr id="30" name="TextBox 29"/>
+          <p:cNvSpPr txBox="1"/>
+          <p:nvPr/>
+        </p:nvSpPr>
+        <p:spPr>
+          <a:xfrm>
+            <a:off x="8933688" y="2011680"/>
+            <a:ext cx="2697480" cy="566928"/>
+          </a:xfrm>
+          <a:prstGeom prst="rect">
+            <a:avLst/>
+          </a:prstGeom>
+          <a:noFill/>
+        </p:spPr>
+        <p:txBody>
+          <a:bodyPr wrap="square" anchor="ctr" lIns="0" rIns="0" tIns="0" bIns="0">
+            <a:spAutoFit/>
+          </a:bodyPr>
+          <a:lstStyle/>
+          <a:p>
+            <a:pPr algn="ctr"/>
+            <a:r>
+              <a:rPr sz="1700" b="1">
+                <a:solidFill>
+                  <a:srgbClr val="FFFFFF"/>
+                </a:solidFill>
+                <a:latin typeface="Meiryo"/>
+              </a:rPr>
+              <a:t>座位回転</a:t>
+            </a:r>
+          </a:p>
+        </p:txBody>
+      </p:sp>
+      <p:sp>
+        <p:nvSpPr>
+          <p:cNvPr id="31" name="TextBox 30"/>
+          <p:cNvSpPr txBox="1"/>
+          <p:nvPr/>
+        </p:nvSpPr>
+        <p:spPr>
+          <a:xfrm>
+            <a:off x="9134856" y="2743200"/>
+            <a:ext cx="2295144" cy="237744"/>
+          </a:xfrm>
+          <a:prstGeom prst="rect">
+            <a:avLst/>
+          </a:prstGeom>
+          <a:noFill/>
+        </p:spPr>
+        <p:txBody>
+          <a:bodyPr wrap="square" anchor="t" lIns="0" rIns="0" tIns="0" bIns="0">
+            <a:spAutoFit/>
+          </a:bodyPr>
+          <a:lstStyle/>
+          <a:p>
+            <a:pPr algn="l"/>
+            <a:r>
+              <a:rPr sz="1100" b="1">
+                <a:solidFill>
+                  <a:srgbClr val="1D9E75"/>
+                </a:solidFill>
+                <a:latin typeface="Meiryo"/>
+              </a:rPr>
+              <a:t>こんな方に</a:t>
+            </a:r>
+          </a:p>
+        </p:txBody>
+      </p:sp>
+      <p:sp>
+        <p:nvSpPr>
+          <p:cNvPr id="32" name="TextBox 31"/>
+          <p:cNvSpPr txBox="1"/>
+          <p:nvPr/>
+        </p:nvSpPr>
+        <p:spPr>
+          <a:xfrm>
+            <a:off x="9134856" y="3035808"/>
+            <a:ext cx="2295144" cy="1005840"/>
+          </a:xfrm>
+          <a:prstGeom prst="rect">
+            <a:avLst/>
+          </a:prstGeom>
+          <a:noFill/>
+        </p:spPr>
+        <p:txBody>
+          <a:bodyPr wrap="square" anchor="t" lIns="0" rIns="0" tIns="0" bIns="0">
+            <a:spAutoFit/>
+          </a:bodyPr>
+          <a:lstStyle/>
+          <a:p>
+            <a:pPr algn="l"/>
+            <a:r>
+              <a:rPr sz="1350" b="0">
+                <a:solidFill>
+                  <a:srgbClr val="1C2833"/>
+                </a:solidFill>
+                <a:latin typeface="Meiryo"/>
+              </a:rPr>
+              <a:t>座位が保てる方</a:t>
+            </a:r>
+          </a:p>
+        </p:txBody>
+      </p:sp>
+      <p:sp>
+        <p:nvSpPr>
+          <p:cNvPr id="33" name="Rounded Rectangle 32"/>
+          <p:cNvSpPr/>
+          <p:nvPr/>
+        </p:nvSpPr>
+        <p:spPr>
+          <a:xfrm>
+            <a:off x="9134856" y="4096512"/>
+            <a:ext cx="2295144" cy="457200"/>
+          </a:xfrm>
+          <a:prstGeom prst="roundRect">
+            <a:avLst>
+              <a:gd name="adj" fmla="val 20000"/>
+            </a:avLst>
+          </a:prstGeom>
+          <a:solidFill>
+            <a:srgbClr val="EAF7F1"/>
+          </a:solidFill>
+          <a:ln>
+            <a:noFill/>
+          </a:ln>
+          <a:effectLst/>
+        </p:spPr>
+        <p:style>
+          <a:lnRef idx="1">
+            <a:schemeClr val="accent1"/>
+          </a:lnRef>
+          <a:fillRef idx="3">
+            <a:schemeClr val="accent1"/>
+          </a:fillRef>
+          <a:effectRef idx="2">
+            <a:schemeClr val="accent1"/>
+          </a:effectRef>
+          <a:fontRef idx="minor">
+            <a:schemeClr val="lt1"/>
+          </a:fontRef>
+        </p:style>
+        <p:txBody>
+          <a:bodyPr rtlCol="0" anchor="ctr"/>
+          <a:lstStyle/>
+          <a:p>
+            <a:pPr algn="ctr"/>
+          </a:p>
+        </p:txBody>
+      </p:sp>
+      <p:sp>
+        <p:nvSpPr>
+          <p:cNvPr id="34" name="TextBox 33"/>
+          <p:cNvSpPr txBox="1"/>
+          <p:nvPr/>
+        </p:nvSpPr>
+        <p:spPr>
+          <a:xfrm>
+            <a:off x="9134856" y="4096512"/>
+            <a:ext cx="2295144" cy="457200"/>
+          </a:xfrm>
+          <a:prstGeom prst="rect">
+            <a:avLst/>
+          </a:prstGeom>
+          <a:noFill/>
+        </p:spPr>
+        <p:txBody>
+          <a:bodyPr wrap="square" anchor="ctr" lIns="0" rIns="0" tIns="0" bIns="0">
+            <a:spAutoFit/>
+          </a:bodyPr>
+          <a:lstStyle/>
+          <a:p>
+            <a:pPr algn="ctr"/>
+            <a:r>
+              <a:rPr sz="1300" b="1">
+                <a:solidFill>
+                  <a:srgbClr val="1D9E75"/>
+                </a:solidFill>
+                <a:latin typeface="Meiryo"/>
+              </a:rPr>
+              <a:t>ご本人の力を残す</a:t>
+            </a:r>
+          </a:p>
+        </p:txBody>
+      </p:sp>
+      <p:sp>
+        <p:nvSpPr>
+          <p:cNvPr id="35" name="Rounded Rectangle 34"/>
+          <p:cNvSpPr/>
+          <p:nvPr/>
+        </p:nvSpPr>
+        <p:spPr>
+          <a:xfrm>
+            <a:off x="566928" y="5120640"/>
+            <a:ext cx="11055096" cy="658368"/>
+          </a:xfrm>
+          <a:prstGeom prst="roundRect">
+            <a:avLst>
+              <a:gd name="adj" fmla="val 13888"/>
+            </a:avLst>
+          </a:prstGeom>
+          <a:solidFill>
+            <a:srgbClr val="1D9E75"/>
+          </a:solidFill>
+          <a:ln>
+            <a:noFill/>
+          </a:ln>
+          <a:effectLst/>
+        </p:spPr>
+        <p:style>
+          <a:lnRef idx="1">
+            <a:schemeClr val="accent1"/>
+          </a:lnRef>
+          <a:fillRef idx="3">
+            <a:schemeClr val="accent1"/>
+          </a:fillRef>
+          <a:effectRef idx="2">
+            <a:schemeClr val="accent1"/>
+          </a:effectRef>
+          <a:fontRef idx="minor">
+            <a:schemeClr val="lt1"/>
+          </a:fontRef>
+        </p:style>
+        <p:txBody>
+          <a:bodyPr rtlCol="0" anchor="ctr"/>
+          <a:lstStyle/>
+          <a:p>
+            <a:pPr algn="ctr"/>
+          </a:p>
+        </p:txBody>
+      </p:sp>
+      <p:sp>
+        <p:nvSpPr>
+          <p:cNvPr id="36" name="TextBox 35"/>
+          <p:cNvSpPr txBox="1"/>
+          <p:nvPr/>
+        </p:nvSpPr>
+        <p:spPr>
+          <a:xfrm>
+            <a:off x="566928" y="5120640"/>
+            <a:ext cx="11055096" cy="658368"/>
+          </a:xfrm>
+          <a:prstGeom prst="rect">
+            <a:avLst/>
+          </a:prstGeom>
+          <a:noFill/>
+        </p:spPr>
+        <p:txBody>
+          <a:bodyPr wrap="square" anchor="ctr" lIns="0" rIns="0" tIns="0" bIns="0">
+            <a:spAutoFit/>
+          </a:bodyPr>
+          <a:lstStyle/>
+          <a:p>
+            <a:pPr algn="ctr"/>
+            <a:r>
+              <a:rPr sz="1800" b="1">
+                <a:solidFill>
+                  <a:srgbClr val="FFFFFF"/>
+                </a:solidFill>
+                <a:latin typeface="Meiryo"/>
+              </a:rPr>
+              <a:t>どの方法でお運びするかを、お一人おひとり決めています。安全に、楽に。</a:t>
+            </a:r>
           </a:p>
         </p:txBody>
       </p:sp>

</xml_diff>

<commit_message>
Deepen the transfer slide with the presenter's clinical detail
Each card now carries what the method is for and what rules it out, the
stretcher card states that a patient who cannot come off the ventilator
is always moved this way because the circuit can be pulled free, and the
banner carries the point that matters most: the method is not fixed —
it is reassessed and changed with the person and family's agreement.
The script narrows the live demonstration to three methods and keeps the
audience volunteer to the stretcher only.

Co-Authored-By: Claude Opus 5 <noreply@anthropic.com>
Claude-Session: https://claude.ai/code/session_01EuVvTjbyv3WUxHVeG4YeGS
</commit_message>
<xml_diff>
--- a/houmon-nyuyoku-slides.pptx
+++ b/houmon-nyuyoku-slides.pptx
@@ -1764,52 +1764,96 @@
           </a:p>
           <a:p>
             <a:r>
-              <a:t>・冨永＝説明と進行／高崎・武末＝実演</a:t>
-            </a:r>
-          </a:p>
-          <a:p>
-            <a:r>
-              <a:t>・導入「ここで少し、体を動かしていただきます」</a:t>
-            </a:r>
-          </a:p>
-          <a:p>
-            <a:r>
-              <a:t>・4つを実演しながら説明。名前だけでなく「どんな方に使うか」を必ず添える</a:t>
-            </a:r>
-          </a:p>
-          <a:p>
-            <a:r>
-              <a:t>  抱き上げ＝小柄・拘縮少ない／担架＝大柄・全介助／</a:t>
-            </a:r>
-          </a:p>
-          <a:p>
-            <a:r>
-              <a:t>  上下＝高さを合わせ水平に／座位回転＝座位が保てる方</a:t>
-            </a:r>
-          </a:p>
-          <a:p>
-            <a:r>
-              <a:t>・体験（3分）「どなたか、お体を預けてみていただけませんか」</a:t>
-            </a:r>
-          </a:p>
-          <a:p>
-            <a:r>
-              <a:t>  → 挙手を待つ。指名しない。腰・首の既往を確認。1人だけ。担架がおすすめ</a:t>
-            </a:r>
-          </a:p>
-          <a:p>
-            <a:r>
-              <a:t>  → 手が挙がらなければ「ではスタッフでお見せします」に即切り替え</a:t>
-            </a:r>
-          </a:p>
-          <a:p>
-            <a:r>
-              <a:t>・締め「持ち上げられる側は、怖いものです。だからその方ごとに決めています」</a:t>
-            </a:r>
-          </a:p>
-          <a:p>
-            <a:r>
-              <a:t>【押していたら】体験を省いて実演だけ −3分／2方法に絞る さらに−2分</a:t>
+              <a:t>・冨永＝説明と進行／高崎・武末＝実演　※いずれも3名で行うことを先に言う</a:t>
+            </a:r>
+          </a:p>
+          <a:p/>
+          <a:p>
+            <a:r>
+              <a:t>【実演するのは3つ】</a:t>
+            </a:r>
+          </a:p>
+          <a:p>
+            <a:r>
+              <a:t> 1 抱き上げ　… スタッフ同士で見せる（会場の方は持ち上げない）</a:t>
+            </a:r>
+          </a:p>
+          <a:p>
+            <a:r>
+              <a:t> 2 担架　　　… ★ここだけ会場の方に体験していただく</a:t>
+            </a:r>
+          </a:p>
+          <a:p>
+            <a:r>
+              <a:t> 3 上下移動　… スタッフ同士で見せる（車椅子を用意）</a:t>
+            </a:r>
+          </a:p>
+          <a:p>
+            <a:r>
+              <a:t> ※座位回転はスライドと口頭だけ。「立てる方にはこちら」で足ります</a:t>
+            </a:r>
+          </a:p>
+          <a:p/>
+          <a:p>
+            <a:r>
+              <a:t>【担架のときに必ず言う】</a:t>
+            </a:r>
+          </a:p>
+          <a:p>
+            <a:r>
+              <a:t> 人工呼吸器を外せない方は、必ず担架です。</a:t>
+            </a:r>
+          </a:p>
+          <a:p>
+            <a:r>
+              <a:t> ほかの方法だと回路が引っ張られて、外れる恐れがあるので。</a:t>
+            </a:r>
+          </a:p>
+          <a:p>
+            <a:r>
+              <a:t> 気管切開の方も、頸部を安定させたいので担架を選びます。</a:t>
+            </a:r>
+          </a:p>
+          <a:p/>
+          <a:p>
+            <a:r>
+              <a:t>【締め＝今日いちばん伝えたいこと】</a:t>
+            </a:r>
+          </a:p>
+          <a:p>
+            <a:r>
+              <a:t> 方法は固定ではありません。事前訪問で決めて、やってみて</a:t>
+            </a:r>
+          </a:p>
+          <a:p>
+            <a:r>
+              <a:t> より安全・安楽な方へ変えます。ADLが上がれば座位回転へ。</a:t>
+            </a:r>
+          </a:p>
+          <a:p>
+            <a:r>
+              <a:t> 変更のつど、ご本人とご家族に確認しています。</a:t>
+            </a:r>
+          </a:p>
+          <a:p/>
+          <a:p>
+            <a:r>
+              <a:t>【体験の進め方】</a:t>
+            </a:r>
+          </a:p>
+          <a:p>
+            <a:r>
+              <a:t> 挙手を待つ。指名しない。腰・首の既往を確認。1人だけ。</a:t>
+            </a:r>
+          </a:p>
+          <a:p>
+            <a:r>
+              <a:t> 手が挙がらなければ「ではスタッフでお見せします」に即切り替え。</a:t>
+            </a:r>
+          </a:p>
+          <a:p>
+            <a:r>
+              <a:t>【押していたら】体験を省いて実演だけ −3分／抱き上げと担架の2つに絞る さらに−2分</a:t>
             </a:r>
           </a:p>
         </p:txBody>
@@ -7764,6 +7808,1818 @@
 </file>
 
 <file path=ppt/slides/slide14.xml><?xml version="1.0" encoding="utf-8"?>
+<p:sld xmlns:a="http://schemas.openxmlformats.org/drawingml/2006/main" xmlns:p="http://schemas.openxmlformats.org/presentationml/2006/main" xmlns:r="http://schemas.openxmlformats.org/officeDocument/2006/relationships">
+  <p:cSld>
+    <p:spTree>
+      <p:nvGrpSpPr>
+        <p:cNvPr id="1" name=""/>
+        <p:cNvGrpSpPr/>
+        <p:nvPr/>
+      </p:nvGrpSpPr>
+      <p:grpSpPr/>
+      <p:sp>
+        <p:nvSpPr>
+          <p:cNvPr id="2" name="Rounded Rectangle 1"/>
+          <p:cNvSpPr/>
+          <p:nvPr/>
+        </p:nvSpPr>
+        <p:spPr>
+          <a:xfrm>
+            <a:off x="566928" y="329184"/>
+            <a:ext cx="1481328" cy="310896"/>
+          </a:xfrm>
+          <a:prstGeom prst="roundRect">
+            <a:avLst>
+              <a:gd name="adj" fmla="val 14705"/>
+            </a:avLst>
+          </a:prstGeom>
+          <a:solidFill>
+            <a:srgbClr val="1D9E75"/>
+          </a:solidFill>
+          <a:ln>
+            <a:noFill/>
+          </a:ln>
+          <a:effectLst/>
+        </p:spPr>
+        <p:style>
+          <a:lnRef idx="1">
+            <a:schemeClr val="accent1"/>
+          </a:lnRef>
+          <a:fillRef idx="3">
+            <a:schemeClr val="accent1"/>
+          </a:fillRef>
+          <a:effectRef idx="2">
+            <a:schemeClr val="accent1"/>
+          </a:effectRef>
+          <a:fontRef idx="minor">
+            <a:schemeClr val="lt1"/>
+          </a:fontRef>
+        </p:style>
+        <p:txBody>
+          <a:bodyPr rtlCol="0" anchor="ctr"/>
+          <a:lstStyle/>
+          <a:p>
+            <a:pPr algn="ctr"/>
+          </a:p>
+        </p:txBody>
+      </p:sp>
+      <p:sp>
+        <p:nvSpPr>
+          <p:cNvPr id="3" name="TextBox 2"/>
+          <p:cNvSpPr txBox="1"/>
+          <p:nvPr/>
+        </p:nvSpPr>
+        <p:spPr>
+          <a:xfrm>
+            <a:off x="566928" y="329184"/>
+            <a:ext cx="1481328" cy="310896"/>
+          </a:xfrm>
+          <a:prstGeom prst="rect">
+            <a:avLst/>
+          </a:prstGeom>
+          <a:noFill/>
+        </p:spPr>
+        <p:txBody>
+          <a:bodyPr wrap="square" anchor="ctr" lIns="0" rIns="0" tIns="0" bIns="0">
+            <a:spAutoFit/>
+          </a:bodyPr>
+          <a:lstStyle/>
+          <a:p>
+            <a:pPr algn="ctr">
+              <a:lnSpc>
+                <a:spcPct val="115000"/>
+              </a:lnSpc>
+            </a:pPr>
+            <a:r>
+              <a:rPr sz="1200" b="1">
+                <a:solidFill>
+                  <a:srgbClr val="FFFFFF"/>
+                </a:solidFill>
+                <a:latin typeface="Meiryo"/>
+              </a:rPr>
+              <a:t>DEMO</a:t>
+            </a:r>
+          </a:p>
+        </p:txBody>
+      </p:sp>
+      <p:sp>
+        <p:nvSpPr>
+          <p:cNvPr id="4" name="TextBox 3"/>
+          <p:cNvSpPr txBox="1"/>
+          <p:nvPr/>
+        </p:nvSpPr>
+        <p:spPr>
+          <a:xfrm>
+            <a:off x="2194560" y="329184"/>
+            <a:ext cx="5486400" cy="310896"/>
+          </a:xfrm>
+          <a:prstGeom prst="rect">
+            <a:avLst/>
+          </a:prstGeom>
+          <a:noFill/>
+        </p:spPr>
+        <p:txBody>
+          <a:bodyPr wrap="square" anchor="ctr" lIns="0" rIns="0" tIns="0" bIns="0">
+            <a:spAutoFit/>
+          </a:bodyPr>
+          <a:lstStyle/>
+          <a:p>
+            <a:pPr algn="l">
+              <a:lnSpc>
+                <a:spcPct val="115000"/>
+              </a:lnSpc>
+            </a:pPr>
+            <a:r>
+              <a:rPr sz="1300" b="0">
+                <a:solidFill>
+                  <a:srgbClr val="566573"/>
+                </a:solidFill>
+                <a:latin typeface="Meiryo"/>
+              </a:rPr>
+              <a:t>移乗の実演</a:t>
+            </a:r>
+          </a:p>
+        </p:txBody>
+      </p:sp>
+      <p:sp>
+        <p:nvSpPr>
+          <p:cNvPr id="5" name="TextBox 4"/>
+          <p:cNvSpPr txBox="1"/>
+          <p:nvPr/>
+        </p:nvSpPr>
+        <p:spPr>
+          <a:xfrm>
+            <a:off x="566928" y="713232"/>
+            <a:ext cx="11055096" cy="548640"/>
+          </a:xfrm>
+          <a:prstGeom prst="rect">
+            <a:avLst/>
+          </a:prstGeom>
+          <a:noFill/>
+        </p:spPr>
+        <p:txBody>
+          <a:bodyPr wrap="square" anchor="t" lIns="0" rIns="0" tIns="0" bIns="0">
+            <a:spAutoFit/>
+          </a:bodyPr>
+          <a:lstStyle/>
+          <a:p>
+            <a:pPr algn="l">
+              <a:lnSpc>
+                <a:spcPct val="115000"/>
+              </a:lnSpc>
+            </a:pPr>
+            <a:r>
+              <a:rPr sz="3200" b="1">
+                <a:solidFill>
+                  <a:srgbClr val="1A5276"/>
+                </a:solidFill>
+                <a:latin typeface="Meiryo"/>
+              </a:rPr>
+              <a:t>お体を、どうお運びするか</a:t>
+            </a:r>
+          </a:p>
+        </p:txBody>
+      </p:sp>
+      <p:sp>
+        <p:nvSpPr>
+          <p:cNvPr id="6" name="TextBox 5"/>
+          <p:cNvSpPr txBox="1"/>
+          <p:nvPr/>
+        </p:nvSpPr>
+        <p:spPr>
+          <a:xfrm>
+            <a:off x="566928" y="1389888"/>
+            <a:ext cx="11055096" cy="292608"/>
+          </a:xfrm>
+          <a:prstGeom prst="rect">
+            <a:avLst/>
+          </a:prstGeom>
+          <a:noFill/>
+        </p:spPr>
+        <p:txBody>
+          <a:bodyPr wrap="square" anchor="t" lIns="0" rIns="0" tIns="0" bIns="0">
+            <a:spAutoFit/>
+          </a:bodyPr>
+          <a:lstStyle/>
+          <a:p>
+            <a:pPr algn="l">
+              <a:lnSpc>
+                <a:spcPct val="115000"/>
+              </a:lnSpc>
+            </a:pPr>
+            <a:r>
+              <a:rPr sz="1350" b="0">
+                <a:solidFill>
+                  <a:srgbClr val="566573"/>
+                </a:solidFill>
+                <a:latin typeface="Meiryo"/>
+              </a:rPr>
+              <a:t>浴槽へお移しする方法は4つ。いずれも3名で行い、その方の状態に合わせて選びます。</a:t>
+            </a:r>
+          </a:p>
+        </p:txBody>
+      </p:sp>
+      <p:sp>
+        <p:nvSpPr>
+          <p:cNvPr id="7" name="Rounded Rectangle 6"/>
+          <p:cNvSpPr/>
+          <p:nvPr/>
+        </p:nvSpPr>
+        <p:spPr>
+          <a:xfrm>
+            <a:off x="566928" y="1874519"/>
+            <a:ext cx="2697480" cy="3154680"/>
+          </a:xfrm>
+          <a:prstGeom prst="roundRect">
+            <a:avLst>
+              <a:gd name="adj" fmla="val 3389"/>
+            </a:avLst>
+          </a:prstGeom>
+          <a:solidFill>
+            <a:srgbClr val="F4F8FA"/>
+          </a:solidFill>
+          <a:ln>
+            <a:noFill/>
+          </a:ln>
+          <a:effectLst/>
+        </p:spPr>
+        <p:style>
+          <a:lnRef idx="1">
+            <a:schemeClr val="accent1"/>
+          </a:lnRef>
+          <a:fillRef idx="3">
+            <a:schemeClr val="accent1"/>
+          </a:fillRef>
+          <a:effectRef idx="2">
+            <a:schemeClr val="accent1"/>
+          </a:effectRef>
+          <a:fontRef idx="minor">
+            <a:schemeClr val="lt1"/>
+          </a:fontRef>
+        </p:style>
+        <p:txBody>
+          <a:bodyPr rtlCol="0" anchor="ctr"/>
+          <a:lstStyle/>
+          <a:p>
+            <a:pPr algn="ctr"/>
+          </a:p>
+        </p:txBody>
+      </p:sp>
+      <p:sp>
+        <p:nvSpPr>
+          <p:cNvPr id="8" name="Rounded Rectangle 7"/>
+          <p:cNvSpPr/>
+          <p:nvPr/>
+        </p:nvSpPr>
+        <p:spPr>
+          <a:xfrm>
+            <a:off x="566928" y="1874519"/>
+            <a:ext cx="2697480" cy="530352"/>
+          </a:xfrm>
+          <a:prstGeom prst="roundRect">
+            <a:avLst>
+              <a:gd name="adj" fmla="val 17241"/>
+            </a:avLst>
+          </a:prstGeom>
+          <a:solidFill>
+            <a:srgbClr val="1A5276"/>
+          </a:solidFill>
+          <a:ln>
+            <a:noFill/>
+          </a:ln>
+          <a:effectLst/>
+        </p:spPr>
+        <p:style>
+          <a:lnRef idx="1">
+            <a:schemeClr val="accent1"/>
+          </a:lnRef>
+          <a:fillRef idx="3">
+            <a:schemeClr val="accent1"/>
+          </a:fillRef>
+          <a:effectRef idx="2">
+            <a:schemeClr val="accent1"/>
+          </a:effectRef>
+          <a:fontRef idx="minor">
+            <a:schemeClr val="lt1"/>
+          </a:fontRef>
+        </p:style>
+        <p:txBody>
+          <a:bodyPr rtlCol="0" anchor="ctr"/>
+          <a:lstStyle/>
+          <a:p>
+            <a:pPr algn="ctr"/>
+          </a:p>
+        </p:txBody>
+      </p:sp>
+      <p:sp>
+        <p:nvSpPr>
+          <p:cNvPr id="9" name="TextBox 8"/>
+          <p:cNvSpPr txBox="1"/>
+          <p:nvPr/>
+        </p:nvSpPr>
+        <p:spPr>
+          <a:xfrm>
+            <a:off x="566928" y="1874519"/>
+            <a:ext cx="2697480" cy="530352"/>
+          </a:xfrm>
+          <a:prstGeom prst="rect">
+            <a:avLst/>
+          </a:prstGeom>
+          <a:noFill/>
+        </p:spPr>
+        <p:txBody>
+          <a:bodyPr wrap="square" anchor="ctr" lIns="0" rIns="0" tIns="0" bIns="0">
+            <a:spAutoFit/>
+          </a:bodyPr>
+          <a:lstStyle/>
+          <a:p>
+            <a:pPr algn="ctr">
+              <a:lnSpc>
+                <a:spcPct val="115000"/>
+              </a:lnSpc>
+            </a:pPr>
+            <a:r>
+              <a:rPr sz="1700" b="1">
+                <a:solidFill>
+                  <a:srgbClr val="FFFFFF"/>
+                </a:solidFill>
+                <a:latin typeface="Meiryo"/>
+              </a:rPr>
+              <a:t>抱き上げ移動</a:t>
+            </a:r>
+          </a:p>
+        </p:txBody>
+      </p:sp>
+      <p:sp>
+        <p:nvSpPr>
+          <p:cNvPr id="10" name="TextBox 9"/>
+          <p:cNvSpPr txBox="1"/>
+          <p:nvPr/>
+        </p:nvSpPr>
+        <p:spPr>
+          <a:xfrm>
+            <a:off x="749808" y="2532887"/>
+            <a:ext cx="2331720" cy="219456"/>
+          </a:xfrm>
+          <a:prstGeom prst="rect">
+            <a:avLst/>
+          </a:prstGeom>
+          <a:noFill/>
+        </p:spPr>
+        <p:txBody>
+          <a:bodyPr wrap="square" anchor="t" lIns="0" rIns="0" tIns="0" bIns="0">
+            <a:spAutoFit/>
+          </a:bodyPr>
+          <a:lstStyle/>
+          <a:p>
+            <a:pPr algn="l">
+              <a:lnSpc>
+                <a:spcPct val="115000"/>
+              </a:lnSpc>
+            </a:pPr>
+            <a:r>
+              <a:rPr sz="1050" b="1">
+                <a:solidFill>
+                  <a:srgbClr val="1D9E75"/>
+                </a:solidFill>
+                <a:latin typeface="Meiryo"/>
+              </a:rPr>
+              <a:t>こんな方に</a:t>
+            </a:r>
+          </a:p>
+        </p:txBody>
+      </p:sp>
+      <p:sp>
+        <p:nvSpPr>
+          <p:cNvPr id="11" name="TextBox 10"/>
+          <p:cNvSpPr txBox="1"/>
+          <p:nvPr/>
+        </p:nvSpPr>
+        <p:spPr>
+          <a:xfrm>
+            <a:off x="749808" y="2788920"/>
+            <a:ext cx="2331720" cy="713232"/>
+          </a:xfrm>
+          <a:prstGeom prst="rect">
+            <a:avLst/>
+          </a:prstGeom>
+          <a:noFill/>
+        </p:spPr>
+        <p:txBody>
+          <a:bodyPr wrap="square" anchor="t" lIns="0" rIns="0" tIns="0" bIns="0">
+            <a:spAutoFit/>
+          </a:bodyPr>
+          <a:lstStyle/>
+          <a:p>
+            <a:pPr algn="l">
+              <a:lnSpc>
+                <a:spcPct val="115000"/>
+              </a:lnSpc>
+            </a:pPr>
+            <a:r>
+              <a:rPr sz="1250" b="0">
+                <a:solidFill>
+                  <a:srgbClr val="1C2833"/>
+                </a:solidFill>
+                <a:latin typeface="Meiryo"/>
+              </a:rPr>
+              <a:t>体格が小さく、拘縮の少ない方</a:t>
+            </a:r>
+          </a:p>
+        </p:txBody>
+      </p:sp>
+      <p:sp>
+        <p:nvSpPr>
+          <p:cNvPr id="12" name="TextBox 11"/>
+          <p:cNvSpPr txBox="1"/>
+          <p:nvPr/>
+        </p:nvSpPr>
+        <p:spPr>
+          <a:xfrm>
+            <a:off x="749808" y="3575304"/>
+            <a:ext cx="2331720" cy="219456"/>
+          </a:xfrm>
+          <a:prstGeom prst="rect">
+            <a:avLst/>
+          </a:prstGeom>
+          <a:noFill/>
+        </p:spPr>
+        <p:txBody>
+          <a:bodyPr wrap="square" anchor="t" lIns="0" rIns="0" tIns="0" bIns="0">
+            <a:spAutoFit/>
+          </a:bodyPr>
+          <a:lstStyle/>
+          <a:p>
+            <a:pPr algn="l">
+              <a:lnSpc>
+                <a:spcPct val="115000"/>
+              </a:lnSpc>
+            </a:pPr>
+            <a:r>
+              <a:rPr sz="1050" b="1">
+                <a:solidFill>
+                  <a:srgbClr val="1A5276"/>
+                </a:solidFill>
+                <a:latin typeface="Meiryo"/>
+              </a:rPr>
+              <a:t>選ばないのは</a:t>
+            </a:r>
+          </a:p>
+        </p:txBody>
+      </p:sp>
+      <p:sp>
+        <p:nvSpPr>
+          <p:cNvPr id="13" name="TextBox 12"/>
+          <p:cNvSpPr txBox="1"/>
+          <p:nvPr/>
+        </p:nvSpPr>
+        <p:spPr>
+          <a:xfrm>
+            <a:off x="749808" y="3831335"/>
+            <a:ext cx="2331720" cy="713232"/>
+          </a:xfrm>
+          <a:prstGeom prst="rect">
+            <a:avLst/>
+          </a:prstGeom>
+          <a:noFill/>
+        </p:spPr>
+        <p:txBody>
+          <a:bodyPr wrap="square" anchor="t" lIns="0" rIns="0" tIns="0" bIns="0">
+            <a:spAutoFit/>
+          </a:bodyPr>
+          <a:lstStyle/>
+          <a:p>
+            <a:pPr algn="l">
+              <a:lnSpc>
+                <a:spcPct val="115000"/>
+              </a:lnSpc>
+            </a:pPr>
+            <a:r>
+              <a:rPr sz="1200" b="0">
+                <a:solidFill>
+                  <a:srgbClr val="566573"/>
+                </a:solidFill>
+                <a:latin typeface="Meiryo"/>
+              </a:rPr>
+              <a:t>体重の重い方</a:t>
+            </a:r>
+          </a:p>
+        </p:txBody>
+      </p:sp>
+      <p:sp>
+        <p:nvSpPr>
+          <p:cNvPr id="14" name="Rounded Rectangle 13"/>
+          <p:cNvSpPr/>
+          <p:nvPr/>
+        </p:nvSpPr>
+        <p:spPr>
+          <a:xfrm>
+            <a:off x="749808" y="4544568"/>
+            <a:ext cx="2331720" cy="402336"/>
+          </a:xfrm>
+          <a:prstGeom prst="roundRect">
+            <a:avLst>
+              <a:gd name="adj" fmla="val 22727"/>
+            </a:avLst>
+          </a:prstGeom>
+          <a:solidFill>
+            <a:srgbClr val="EAF7F1"/>
+          </a:solidFill>
+          <a:ln>
+            <a:noFill/>
+          </a:ln>
+          <a:effectLst/>
+        </p:spPr>
+        <p:style>
+          <a:lnRef idx="1">
+            <a:schemeClr val="accent1"/>
+          </a:lnRef>
+          <a:fillRef idx="3">
+            <a:schemeClr val="accent1"/>
+          </a:fillRef>
+          <a:effectRef idx="2">
+            <a:schemeClr val="accent1"/>
+          </a:effectRef>
+          <a:fontRef idx="minor">
+            <a:schemeClr val="lt1"/>
+          </a:fontRef>
+        </p:style>
+        <p:txBody>
+          <a:bodyPr rtlCol="0" anchor="ctr"/>
+          <a:lstStyle/>
+          <a:p>
+            <a:pPr algn="ctr"/>
+          </a:p>
+        </p:txBody>
+      </p:sp>
+      <p:sp>
+        <p:nvSpPr>
+          <p:cNvPr id="15" name="TextBox 14"/>
+          <p:cNvSpPr txBox="1"/>
+          <p:nvPr/>
+        </p:nvSpPr>
+        <p:spPr>
+          <a:xfrm>
+            <a:off x="749808" y="4544568"/>
+            <a:ext cx="2331720" cy="402336"/>
+          </a:xfrm>
+          <a:prstGeom prst="rect">
+            <a:avLst/>
+          </a:prstGeom>
+          <a:noFill/>
+        </p:spPr>
+        <p:txBody>
+          <a:bodyPr wrap="square" anchor="ctr" lIns="0" rIns="0" tIns="0" bIns="0">
+            <a:spAutoFit/>
+          </a:bodyPr>
+          <a:lstStyle/>
+          <a:p>
+            <a:pPr algn="ctr">
+              <a:lnSpc>
+                <a:spcPct val="115000"/>
+              </a:lnSpc>
+            </a:pPr>
+            <a:r>
+              <a:rPr sz="1250" b="1">
+                <a:solidFill>
+                  <a:srgbClr val="1D9E75"/>
+                </a:solidFill>
+                <a:latin typeface="Meiryo"/>
+              </a:rPr>
+              <a:t>いちばん短時間</a:t>
+            </a:r>
+          </a:p>
+        </p:txBody>
+      </p:sp>
+      <p:sp>
+        <p:nvSpPr>
+          <p:cNvPr id="16" name="Rounded Rectangle 15"/>
+          <p:cNvSpPr/>
+          <p:nvPr/>
+        </p:nvSpPr>
+        <p:spPr>
+          <a:xfrm>
+            <a:off x="3355848" y="1874519"/>
+            <a:ext cx="2697480" cy="3154680"/>
+          </a:xfrm>
+          <a:prstGeom prst="roundRect">
+            <a:avLst>
+              <a:gd name="adj" fmla="val 3389"/>
+            </a:avLst>
+          </a:prstGeom>
+          <a:solidFill>
+            <a:srgbClr val="F4F8FA"/>
+          </a:solidFill>
+          <a:ln>
+            <a:noFill/>
+          </a:ln>
+          <a:effectLst/>
+        </p:spPr>
+        <p:style>
+          <a:lnRef idx="1">
+            <a:schemeClr val="accent1"/>
+          </a:lnRef>
+          <a:fillRef idx="3">
+            <a:schemeClr val="accent1"/>
+          </a:fillRef>
+          <a:effectRef idx="2">
+            <a:schemeClr val="accent1"/>
+          </a:effectRef>
+          <a:fontRef idx="minor">
+            <a:schemeClr val="lt1"/>
+          </a:fontRef>
+        </p:style>
+        <p:txBody>
+          <a:bodyPr rtlCol="0" anchor="ctr"/>
+          <a:lstStyle/>
+          <a:p>
+            <a:pPr algn="ctr"/>
+          </a:p>
+        </p:txBody>
+      </p:sp>
+      <p:sp>
+        <p:nvSpPr>
+          <p:cNvPr id="17" name="Rounded Rectangle 16"/>
+          <p:cNvSpPr/>
+          <p:nvPr/>
+        </p:nvSpPr>
+        <p:spPr>
+          <a:xfrm>
+            <a:off x="3355848" y="1874519"/>
+            <a:ext cx="2697480" cy="530352"/>
+          </a:xfrm>
+          <a:prstGeom prst="roundRect">
+            <a:avLst>
+              <a:gd name="adj" fmla="val 17241"/>
+            </a:avLst>
+          </a:prstGeom>
+          <a:solidFill>
+            <a:srgbClr val="1A5276"/>
+          </a:solidFill>
+          <a:ln>
+            <a:noFill/>
+          </a:ln>
+          <a:effectLst/>
+        </p:spPr>
+        <p:style>
+          <a:lnRef idx="1">
+            <a:schemeClr val="accent1"/>
+          </a:lnRef>
+          <a:fillRef idx="3">
+            <a:schemeClr val="accent1"/>
+          </a:fillRef>
+          <a:effectRef idx="2">
+            <a:schemeClr val="accent1"/>
+          </a:effectRef>
+          <a:fontRef idx="minor">
+            <a:schemeClr val="lt1"/>
+          </a:fontRef>
+        </p:style>
+        <p:txBody>
+          <a:bodyPr rtlCol="0" anchor="ctr"/>
+          <a:lstStyle/>
+          <a:p>
+            <a:pPr algn="ctr"/>
+          </a:p>
+        </p:txBody>
+      </p:sp>
+      <p:sp>
+        <p:nvSpPr>
+          <p:cNvPr id="18" name="TextBox 17"/>
+          <p:cNvSpPr txBox="1"/>
+          <p:nvPr/>
+        </p:nvSpPr>
+        <p:spPr>
+          <a:xfrm>
+            <a:off x="3355848" y="1874519"/>
+            <a:ext cx="2697480" cy="530352"/>
+          </a:xfrm>
+          <a:prstGeom prst="rect">
+            <a:avLst/>
+          </a:prstGeom>
+          <a:noFill/>
+        </p:spPr>
+        <p:txBody>
+          <a:bodyPr wrap="square" anchor="ctr" lIns="0" rIns="0" tIns="0" bIns="0">
+            <a:spAutoFit/>
+          </a:bodyPr>
+          <a:lstStyle/>
+          <a:p>
+            <a:pPr algn="ctr">
+              <a:lnSpc>
+                <a:spcPct val="115000"/>
+              </a:lnSpc>
+            </a:pPr>
+            <a:r>
+              <a:rPr sz="1700" b="1">
+                <a:solidFill>
+                  <a:srgbClr val="FFFFFF"/>
+                </a:solidFill>
+                <a:latin typeface="Meiryo"/>
+              </a:rPr>
+              <a:t>担架移動</a:t>
+            </a:r>
+          </a:p>
+        </p:txBody>
+      </p:sp>
+      <p:sp>
+        <p:nvSpPr>
+          <p:cNvPr id="19" name="TextBox 18"/>
+          <p:cNvSpPr txBox="1"/>
+          <p:nvPr/>
+        </p:nvSpPr>
+        <p:spPr>
+          <a:xfrm>
+            <a:off x="3538728" y="2532887"/>
+            <a:ext cx="2331720" cy="219456"/>
+          </a:xfrm>
+          <a:prstGeom prst="rect">
+            <a:avLst/>
+          </a:prstGeom>
+          <a:noFill/>
+        </p:spPr>
+        <p:txBody>
+          <a:bodyPr wrap="square" anchor="t" lIns="0" rIns="0" tIns="0" bIns="0">
+            <a:spAutoFit/>
+          </a:bodyPr>
+          <a:lstStyle/>
+          <a:p>
+            <a:pPr algn="l">
+              <a:lnSpc>
+                <a:spcPct val="115000"/>
+              </a:lnSpc>
+            </a:pPr>
+            <a:r>
+              <a:rPr sz="1050" b="1">
+                <a:solidFill>
+                  <a:srgbClr val="1D9E75"/>
+                </a:solidFill>
+                <a:latin typeface="Meiryo"/>
+              </a:rPr>
+              <a:t>こんな方に</a:t>
+            </a:r>
+          </a:p>
+        </p:txBody>
+      </p:sp>
+      <p:sp>
+        <p:nvSpPr>
+          <p:cNvPr id="20" name="TextBox 19"/>
+          <p:cNvSpPr txBox="1"/>
+          <p:nvPr/>
+        </p:nvSpPr>
+        <p:spPr>
+          <a:xfrm>
+            <a:off x="3538728" y="2788920"/>
+            <a:ext cx="2331720" cy="713232"/>
+          </a:xfrm>
+          <a:prstGeom prst="rect">
+            <a:avLst/>
+          </a:prstGeom>
+          <a:noFill/>
+        </p:spPr>
+        <p:txBody>
+          <a:bodyPr wrap="square" anchor="t" lIns="0" rIns="0" tIns="0" bIns="0">
+            <a:spAutoFit/>
+          </a:bodyPr>
+          <a:lstStyle/>
+          <a:p>
+            <a:pPr algn="l">
+              <a:lnSpc>
+                <a:spcPct val="115000"/>
+              </a:lnSpc>
+            </a:pPr>
+            <a:r>
+              <a:rPr sz="1250" b="0">
+                <a:solidFill>
+                  <a:srgbClr val="1C2833"/>
+                </a:solidFill>
+                <a:latin typeface="Meiryo"/>
+              </a:rPr>
+              <a:t>体の大きい方、気管切開の方、全介助の方</a:t>
+            </a:r>
+          </a:p>
+        </p:txBody>
+      </p:sp>
+      <p:sp>
+        <p:nvSpPr>
+          <p:cNvPr id="21" name="TextBox 20"/>
+          <p:cNvSpPr txBox="1"/>
+          <p:nvPr/>
+        </p:nvSpPr>
+        <p:spPr>
+          <a:xfrm>
+            <a:off x="3538728" y="3575304"/>
+            <a:ext cx="2331720" cy="219456"/>
+          </a:xfrm>
+          <a:prstGeom prst="rect">
+            <a:avLst/>
+          </a:prstGeom>
+          <a:noFill/>
+        </p:spPr>
+        <p:txBody>
+          <a:bodyPr wrap="square" anchor="t" lIns="0" rIns="0" tIns="0" bIns="0">
+            <a:spAutoFit/>
+          </a:bodyPr>
+          <a:lstStyle/>
+          <a:p>
+            <a:pPr algn="l">
+              <a:lnSpc>
+                <a:spcPct val="115000"/>
+              </a:lnSpc>
+            </a:pPr>
+            <a:r>
+              <a:rPr sz="1050" b="1">
+                <a:solidFill>
+                  <a:srgbClr val="1A5276"/>
+                </a:solidFill>
+                <a:latin typeface="Meiryo"/>
+              </a:rPr>
+              <a:t>必ずこの方法</a:t>
+            </a:r>
+          </a:p>
+        </p:txBody>
+      </p:sp>
+      <p:sp>
+        <p:nvSpPr>
+          <p:cNvPr id="22" name="TextBox 21"/>
+          <p:cNvSpPr txBox="1"/>
+          <p:nvPr/>
+        </p:nvSpPr>
+        <p:spPr>
+          <a:xfrm>
+            <a:off x="3538728" y="3831335"/>
+            <a:ext cx="2331720" cy="713232"/>
+          </a:xfrm>
+          <a:prstGeom prst="rect">
+            <a:avLst/>
+          </a:prstGeom>
+          <a:noFill/>
+        </p:spPr>
+        <p:txBody>
+          <a:bodyPr wrap="square" anchor="t" lIns="0" rIns="0" tIns="0" bIns="0">
+            <a:spAutoFit/>
+          </a:bodyPr>
+          <a:lstStyle/>
+          <a:p>
+            <a:pPr algn="l">
+              <a:lnSpc>
+                <a:spcPct val="115000"/>
+              </a:lnSpc>
+            </a:pPr>
+            <a:r>
+              <a:rPr sz="1200" b="0">
+                <a:solidFill>
+                  <a:srgbClr val="566573"/>
+                </a:solidFill>
+                <a:latin typeface="Meiryo"/>
+              </a:rPr>
+              <a:t>人工呼吸器を外せない方。回路が引っ張られないように</a:t>
+            </a:r>
+          </a:p>
+        </p:txBody>
+      </p:sp>
+      <p:sp>
+        <p:nvSpPr>
+          <p:cNvPr id="23" name="Rounded Rectangle 22"/>
+          <p:cNvSpPr/>
+          <p:nvPr/>
+        </p:nvSpPr>
+        <p:spPr>
+          <a:xfrm>
+            <a:off x="3538728" y="4544568"/>
+            <a:ext cx="2331720" cy="402336"/>
+          </a:xfrm>
+          <a:prstGeom prst="roundRect">
+            <a:avLst>
+              <a:gd name="adj" fmla="val 22727"/>
+            </a:avLst>
+          </a:prstGeom>
+          <a:solidFill>
+            <a:srgbClr val="EAF7F1"/>
+          </a:solidFill>
+          <a:ln>
+            <a:noFill/>
+          </a:ln>
+          <a:effectLst/>
+        </p:spPr>
+        <p:style>
+          <a:lnRef idx="1">
+            <a:schemeClr val="accent1"/>
+          </a:lnRef>
+          <a:fillRef idx="3">
+            <a:schemeClr val="accent1"/>
+          </a:fillRef>
+          <a:effectRef idx="2">
+            <a:schemeClr val="accent1"/>
+          </a:effectRef>
+          <a:fontRef idx="minor">
+            <a:schemeClr val="lt1"/>
+          </a:fontRef>
+        </p:style>
+        <p:txBody>
+          <a:bodyPr rtlCol="0" anchor="ctr"/>
+          <a:lstStyle/>
+          <a:p>
+            <a:pPr algn="ctr"/>
+          </a:p>
+        </p:txBody>
+      </p:sp>
+      <p:sp>
+        <p:nvSpPr>
+          <p:cNvPr id="24" name="TextBox 23"/>
+          <p:cNvSpPr txBox="1"/>
+          <p:nvPr/>
+        </p:nvSpPr>
+        <p:spPr>
+          <a:xfrm>
+            <a:off x="3538728" y="4544568"/>
+            <a:ext cx="2331720" cy="402336"/>
+          </a:xfrm>
+          <a:prstGeom prst="rect">
+            <a:avLst/>
+          </a:prstGeom>
+          <a:noFill/>
+        </p:spPr>
+        <p:txBody>
+          <a:bodyPr wrap="square" anchor="ctr" lIns="0" rIns="0" tIns="0" bIns="0">
+            <a:spAutoFit/>
+          </a:bodyPr>
+          <a:lstStyle/>
+          <a:p>
+            <a:pPr algn="ctr">
+              <a:lnSpc>
+                <a:spcPct val="115000"/>
+              </a:lnSpc>
+            </a:pPr>
+            <a:r>
+              <a:rPr sz="1250" b="1">
+                <a:solidFill>
+                  <a:srgbClr val="1D9E75"/>
+                </a:solidFill>
+                <a:latin typeface="Meiryo"/>
+              </a:rPr>
+              <a:t>いちばん安全</a:t>
+            </a:r>
+          </a:p>
+        </p:txBody>
+      </p:sp>
+      <p:sp>
+        <p:nvSpPr>
+          <p:cNvPr id="25" name="Rounded Rectangle 24"/>
+          <p:cNvSpPr/>
+          <p:nvPr/>
+        </p:nvSpPr>
+        <p:spPr>
+          <a:xfrm>
+            <a:off x="6144768" y="1874519"/>
+            <a:ext cx="2697480" cy="3154680"/>
+          </a:xfrm>
+          <a:prstGeom prst="roundRect">
+            <a:avLst>
+              <a:gd name="adj" fmla="val 3389"/>
+            </a:avLst>
+          </a:prstGeom>
+          <a:solidFill>
+            <a:srgbClr val="F4F8FA"/>
+          </a:solidFill>
+          <a:ln>
+            <a:noFill/>
+          </a:ln>
+          <a:effectLst/>
+        </p:spPr>
+        <p:style>
+          <a:lnRef idx="1">
+            <a:schemeClr val="accent1"/>
+          </a:lnRef>
+          <a:fillRef idx="3">
+            <a:schemeClr val="accent1"/>
+          </a:fillRef>
+          <a:effectRef idx="2">
+            <a:schemeClr val="accent1"/>
+          </a:effectRef>
+          <a:fontRef idx="minor">
+            <a:schemeClr val="lt1"/>
+          </a:fontRef>
+        </p:style>
+        <p:txBody>
+          <a:bodyPr rtlCol="0" anchor="ctr"/>
+          <a:lstStyle/>
+          <a:p>
+            <a:pPr algn="ctr"/>
+          </a:p>
+        </p:txBody>
+      </p:sp>
+      <p:sp>
+        <p:nvSpPr>
+          <p:cNvPr id="26" name="Rounded Rectangle 25"/>
+          <p:cNvSpPr/>
+          <p:nvPr/>
+        </p:nvSpPr>
+        <p:spPr>
+          <a:xfrm>
+            <a:off x="6144768" y="1874519"/>
+            <a:ext cx="2697480" cy="530352"/>
+          </a:xfrm>
+          <a:prstGeom prst="roundRect">
+            <a:avLst>
+              <a:gd name="adj" fmla="val 17241"/>
+            </a:avLst>
+          </a:prstGeom>
+          <a:solidFill>
+            <a:srgbClr val="1A5276"/>
+          </a:solidFill>
+          <a:ln>
+            <a:noFill/>
+          </a:ln>
+          <a:effectLst/>
+        </p:spPr>
+        <p:style>
+          <a:lnRef idx="1">
+            <a:schemeClr val="accent1"/>
+          </a:lnRef>
+          <a:fillRef idx="3">
+            <a:schemeClr val="accent1"/>
+          </a:fillRef>
+          <a:effectRef idx="2">
+            <a:schemeClr val="accent1"/>
+          </a:effectRef>
+          <a:fontRef idx="minor">
+            <a:schemeClr val="lt1"/>
+          </a:fontRef>
+        </p:style>
+        <p:txBody>
+          <a:bodyPr rtlCol="0" anchor="ctr"/>
+          <a:lstStyle/>
+          <a:p>
+            <a:pPr algn="ctr"/>
+          </a:p>
+        </p:txBody>
+      </p:sp>
+      <p:sp>
+        <p:nvSpPr>
+          <p:cNvPr id="27" name="TextBox 26"/>
+          <p:cNvSpPr txBox="1"/>
+          <p:nvPr/>
+        </p:nvSpPr>
+        <p:spPr>
+          <a:xfrm>
+            <a:off x="6144768" y="1874519"/>
+            <a:ext cx="2697480" cy="530352"/>
+          </a:xfrm>
+          <a:prstGeom prst="rect">
+            <a:avLst/>
+          </a:prstGeom>
+          <a:noFill/>
+        </p:spPr>
+        <p:txBody>
+          <a:bodyPr wrap="square" anchor="ctr" lIns="0" rIns="0" tIns="0" bIns="0">
+            <a:spAutoFit/>
+          </a:bodyPr>
+          <a:lstStyle/>
+          <a:p>
+            <a:pPr algn="ctr">
+              <a:lnSpc>
+                <a:spcPct val="115000"/>
+              </a:lnSpc>
+            </a:pPr>
+            <a:r>
+              <a:rPr sz="1700" b="1">
+                <a:solidFill>
+                  <a:srgbClr val="FFFFFF"/>
+                </a:solidFill>
+                <a:latin typeface="Meiryo"/>
+              </a:rPr>
+              <a:t>上下移動</a:t>
+            </a:r>
+          </a:p>
+        </p:txBody>
+      </p:sp>
+      <p:sp>
+        <p:nvSpPr>
+          <p:cNvPr id="28" name="TextBox 27"/>
+          <p:cNvSpPr txBox="1"/>
+          <p:nvPr/>
+        </p:nvSpPr>
+        <p:spPr>
+          <a:xfrm>
+            <a:off x="6327648" y="2532887"/>
+            <a:ext cx="2331720" cy="219456"/>
+          </a:xfrm>
+          <a:prstGeom prst="rect">
+            <a:avLst/>
+          </a:prstGeom>
+          <a:noFill/>
+        </p:spPr>
+        <p:txBody>
+          <a:bodyPr wrap="square" anchor="t" lIns="0" rIns="0" tIns="0" bIns="0">
+            <a:spAutoFit/>
+          </a:bodyPr>
+          <a:lstStyle/>
+          <a:p>
+            <a:pPr algn="l">
+              <a:lnSpc>
+                <a:spcPct val="115000"/>
+              </a:lnSpc>
+            </a:pPr>
+            <a:r>
+              <a:rPr sz="1050" b="1">
+                <a:solidFill>
+                  <a:srgbClr val="1D9E75"/>
+                </a:solidFill>
+                <a:latin typeface="Meiryo"/>
+              </a:rPr>
+              <a:t>こんな方に</a:t>
+            </a:r>
+          </a:p>
+        </p:txBody>
+      </p:sp>
+      <p:sp>
+        <p:nvSpPr>
+          <p:cNvPr id="29" name="TextBox 28"/>
+          <p:cNvSpPr txBox="1"/>
+          <p:nvPr/>
+        </p:nvSpPr>
+        <p:spPr>
+          <a:xfrm>
+            <a:off x="6327648" y="2788920"/>
+            <a:ext cx="2331720" cy="713232"/>
+          </a:xfrm>
+          <a:prstGeom prst="rect">
+            <a:avLst/>
+          </a:prstGeom>
+          <a:noFill/>
+        </p:spPr>
+        <p:txBody>
+          <a:bodyPr wrap="square" anchor="t" lIns="0" rIns="0" tIns="0" bIns="0">
+            <a:spAutoFit/>
+          </a:bodyPr>
+          <a:lstStyle/>
+          <a:p>
+            <a:pPr algn="l">
+              <a:lnSpc>
+                <a:spcPct val="115000"/>
+              </a:lnSpc>
+            </a:pPr>
+            <a:r>
+              <a:rPr sz="1250" b="0">
+                <a:solidFill>
+                  <a:srgbClr val="1C2833"/>
+                </a:solidFill>
+                <a:latin typeface="Meiryo"/>
+              </a:rPr>
+              <a:t>車椅子で生活されている方</a:t>
+            </a:r>
+          </a:p>
+        </p:txBody>
+      </p:sp>
+      <p:sp>
+        <p:nvSpPr>
+          <p:cNvPr id="30" name="TextBox 29"/>
+          <p:cNvSpPr txBox="1"/>
+          <p:nvPr/>
+        </p:nvSpPr>
+        <p:spPr>
+          <a:xfrm>
+            <a:off x="6327648" y="3575304"/>
+            <a:ext cx="2331720" cy="219456"/>
+          </a:xfrm>
+          <a:prstGeom prst="rect">
+            <a:avLst/>
+          </a:prstGeom>
+          <a:noFill/>
+        </p:spPr>
+        <p:txBody>
+          <a:bodyPr wrap="square" anchor="t" lIns="0" rIns="0" tIns="0" bIns="0">
+            <a:spAutoFit/>
+          </a:bodyPr>
+          <a:lstStyle/>
+          <a:p>
+            <a:pPr algn="l">
+              <a:lnSpc>
+                <a:spcPct val="115000"/>
+              </a:lnSpc>
+            </a:pPr>
+            <a:r>
+              <a:rPr sz="1050" b="1">
+                <a:solidFill>
+                  <a:srgbClr val="1A5276"/>
+                </a:solidFill>
+                <a:latin typeface="Meiryo"/>
+              </a:rPr>
+              <a:t>支え方</a:t>
+            </a:r>
+          </a:p>
+        </p:txBody>
+      </p:sp>
+      <p:sp>
+        <p:nvSpPr>
+          <p:cNvPr id="31" name="TextBox 30"/>
+          <p:cNvSpPr txBox="1"/>
+          <p:nvPr/>
+        </p:nvSpPr>
+        <p:spPr>
+          <a:xfrm>
+            <a:off x="6327648" y="3831335"/>
+            <a:ext cx="2331720" cy="713232"/>
+          </a:xfrm>
+          <a:prstGeom prst="rect">
+            <a:avLst/>
+          </a:prstGeom>
+          <a:noFill/>
+        </p:spPr>
+        <p:txBody>
+          <a:bodyPr wrap="square" anchor="t" lIns="0" rIns="0" tIns="0" bIns="0">
+            <a:spAutoFit/>
+          </a:bodyPr>
+          <a:lstStyle/>
+          <a:p>
+            <a:pPr algn="l">
+              <a:lnSpc>
+                <a:spcPct val="115000"/>
+              </a:lnSpc>
+            </a:pPr>
+            <a:r>
+              <a:rPr sz="1200" b="0">
+                <a:solidFill>
+                  <a:srgbClr val="566573"/>
+                </a:solidFill>
+                <a:latin typeface="Meiryo"/>
+              </a:rPr>
+              <a:t>上半身・臀部・下肢を3名で支え、高さを合わせます</a:t>
+            </a:r>
+          </a:p>
+        </p:txBody>
+      </p:sp>
+      <p:sp>
+        <p:nvSpPr>
+          <p:cNvPr id="32" name="Rounded Rectangle 31"/>
+          <p:cNvSpPr/>
+          <p:nvPr/>
+        </p:nvSpPr>
+        <p:spPr>
+          <a:xfrm>
+            <a:off x="6327648" y="4544568"/>
+            <a:ext cx="2331720" cy="402336"/>
+          </a:xfrm>
+          <a:prstGeom prst="roundRect">
+            <a:avLst>
+              <a:gd name="adj" fmla="val 22727"/>
+            </a:avLst>
+          </a:prstGeom>
+          <a:solidFill>
+            <a:srgbClr val="EAF7F1"/>
+          </a:solidFill>
+          <a:ln>
+            <a:noFill/>
+          </a:ln>
+          <a:effectLst/>
+        </p:spPr>
+        <p:style>
+          <a:lnRef idx="1">
+            <a:schemeClr val="accent1"/>
+          </a:lnRef>
+          <a:fillRef idx="3">
+            <a:schemeClr val="accent1"/>
+          </a:fillRef>
+          <a:effectRef idx="2">
+            <a:schemeClr val="accent1"/>
+          </a:effectRef>
+          <a:fontRef idx="minor">
+            <a:schemeClr val="lt1"/>
+          </a:fontRef>
+        </p:style>
+        <p:txBody>
+          <a:bodyPr rtlCol="0" anchor="ctr"/>
+          <a:lstStyle/>
+          <a:p>
+            <a:pPr algn="ctr"/>
+          </a:p>
+        </p:txBody>
+      </p:sp>
+      <p:sp>
+        <p:nvSpPr>
+          <p:cNvPr id="33" name="TextBox 32"/>
+          <p:cNvSpPr txBox="1"/>
+          <p:nvPr/>
+        </p:nvSpPr>
+        <p:spPr>
+          <a:xfrm>
+            <a:off x="6327648" y="4544568"/>
+            <a:ext cx="2331720" cy="402336"/>
+          </a:xfrm>
+          <a:prstGeom prst="rect">
+            <a:avLst/>
+          </a:prstGeom>
+          <a:noFill/>
+        </p:spPr>
+        <p:txBody>
+          <a:bodyPr wrap="square" anchor="ctr" lIns="0" rIns="0" tIns="0" bIns="0">
+            <a:spAutoFit/>
+          </a:bodyPr>
+          <a:lstStyle/>
+          <a:p>
+            <a:pPr algn="ctr">
+              <a:lnSpc>
+                <a:spcPct val="115000"/>
+              </a:lnSpc>
+            </a:pPr>
+            <a:r>
+              <a:rPr sz="1250" b="1">
+                <a:solidFill>
+                  <a:srgbClr val="1D9E75"/>
+                </a:solidFill>
+                <a:latin typeface="Meiryo"/>
+              </a:rPr>
+              <a:t>車椅子から直接</a:t>
+            </a:r>
+          </a:p>
+        </p:txBody>
+      </p:sp>
+      <p:sp>
+        <p:nvSpPr>
+          <p:cNvPr id="34" name="Rounded Rectangle 33"/>
+          <p:cNvSpPr/>
+          <p:nvPr/>
+        </p:nvSpPr>
+        <p:spPr>
+          <a:xfrm>
+            <a:off x="8933688" y="1874519"/>
+            <a:ext cx="2697480" cy="3154680"/>
+          </a:xfrm>
+          <a:prstGeom prst="roundRect">
+            <a:avLst>
+              <a:gd name="adj" fmla="val 3389"/>
+            </a:avLst>
+          </a:prstGeom>
+          <a:solidFill>
+            <a:srgbClr val="F4F8FA"/>
+          </a:solidFill>
+          <a:ln>
+            <a:noFill/>
+          </a:ln>
+          <a:effectLst/>
+        </p:spPr>
+        <p:style>
+          <a:lnRef idx="1">
+            <a:schemeClr val="accent1"/>
+          </a:lnRef>
+          <a:fillRef idx="3">
+            <a:schemeClr val="accent1"/>
+          </a:fillRef>
+          <a:effectRef idx="2">
+            <a:schemeClr val="accent1"/>
+          </a:effectRef>
+          <a:fontRef idx="minor">
+            <a:schemeClr val="lt1"/>
+          </a:fontRef>
+        </p:style>
+        <p:txBody>
+          <a:bodyPr rtlCol="0" anchor="ctr"/>
+          <a:lstStyle/>
+          <a:p>
+            <a:pPr algn="ctr"/>
+          </a:p>
+        </p:txBody>
+      </p:sp>
+      <p:sp>
+        <p:nvSpPr>
+          <p:cNvPr id="35" name="Rounded Rectangle 34"/>
+          <p:cNvSpPr/>
+          <p:nvPr/>
+        </p:nvSpPr>
+        <p:spPr>
+          <a:xfrm>
+            <a:off x="8933688" y="1874519"/>
+            <a:ext cx="2697480" cy="530352"/>
+          </a:xfrm>
+          <a:prstGeom prst="roundRect">
+            <a:avLst>
+              <a:gd name="adj" fmla="val 17241"/>
+            </a:avLst>
+          </a:prstGeom>
+          <a:solidFill>
+            <a:srgbClr val="1A5276"/>
+          </a:solidFill>
+          <a:ln>
+            <a:noFill/>
+          </a:ln>
+          <a:effectLst/>
+        </p:spPr>
+        <p:style>
+          <a:lnRef idx="1">
+            <a:schemeClr val="accent1"/>
+          </a:lnRef>
+          <a:fillRef idx="3">
+            <a:schemeClr val="accent1"/>
+          </a:fillRef>
+          <a:effectRef idx="2">
+            <a:schemeClr val="accent1"/>
+          </a:effectRef>
+          <a:fontRef idx="minor">
+            <a:schemeClr val="lt1"/>
+          </a:fontRef>
+        </p:style>
+        <p:txBody>
+          <a:bodyPr rtlCol="0" anchor="ctr"/>
+          <a:lstStyle/>
+          <a:p>
+            <a:pPr algn="ctr"/>
+          </a:p>
+        </p:txBody>
+      </p:sp>
+      <p:sp>
+        <p:nvSpPr>
+          <p:cNvPr id="36" name="TextBox 35"/>
+          <p:cNvSpPr txBox="1"/>
+          <p:nvPr/>
+        </p:nvSpPr>
+        <p:spPr>
+          <a:xfrm>
+            <a:off x="8933688" y="1874519"/>
+            <a:ext cx="2697480" cy="530352"/>
+          </a:xfrm>
+          <a:prstGeom prst="rect">
+            <a:avLst/>
+          </a:prstGeom>
+          <a:noFill/>
+        </p:spPr>
+        <p:txBody>
+          <a:bodyPr wrap="square" anchor="ctr" lIns="0" rIns="0" tIns="0" bIns="0">
+            <a:spAutoFit/>
+          </a:bodyPr>
+          <a:lstStyle/>
+          <a:p>
+            <a:pPr algn="ctr">
+              <a:lnSpc>
+                <a:spcPct val="115000"/>
+              </a:lnSpc>
+            </a:pPr>
+            <a:r>
+              <a:rPr sz="1700" b="1">
+                <a:solidFill>
+                  <a:srgbClr val="FFFFFF"/>
+                </a:solidFill>
+                <a:latin typeface="Meiryo"/>
+              </a:rPr>
+              <a:t>座位回転</a:t>
+            </a:r>
+          </a:p>
+        </p:txBody>
+      </p:sp>
+      <p:sp>
+        <p:nvSpPr>
+          <p:cNvPr id="37" name="TextBox 36"/>
+          <p:cNvSpPr txBox="1"/>
+          <p:nvPr/>
+        </p:nvSpPr>
+        <p:spPr>
+          <a:xfrm>
+            <a:off x="9116567" y="2532887"/>
+            <a:ext cx="2331720" cy="219456"/>
+          </a:xfrm>
+          <a:prstGeom prst="rect">
+            <a:avLst/>
+          </a:prstGeom>
+          <a:noFill/>
+        </p:spPr>
+        <p:txBody>
+          <a:bodyPr wrap="square" anchor="t" lIns="0" rIns="0" tIns="0" bIns="0">
+            <a:spAutoFit/>
+          </a:bodyPr>
+          <a:lstStyle/>
+          <a:p>
+            <a:pPr algn="l">
+              <a:lnSpc>
+                <a:spcPct val="115000"/>
+              </a:lnSpc>
+            </a:pPr>
+            <a:r>
+              <a:rPr sz="1050" b="1">
+                <a:solidFill>
+                  <a:srgbClr val="1D9E75"/>
+                </a:solidFill>
+                <a:latin typeface="Meiryo"/>
+              </a:rPr>
+              <a:t>こんな方に</a:t>
+            </a:r>
+          </a:p>
+        </p:txBody>
+      </p:sp>
+      <p:sp>
+        <p:nvSpPr>
+          <p:cNvPr id="38" name="TextBox 37"/>
+          <p:cNvSpPr txBox="1"/>
+          <p:nvPr/>
+        </p:nvSpPr>
+        <p:spPr>
+          <a:xfrm>
+            <a:off x="9116567" y="2788920"/>
+            <a:ext cx="2331720" cy="713232"/>
+          </a:xfrm>
+          <a:prstGeom prst="rect">
+            <a:avLst/>
+          </a:prstGeom>
+          <a:noFill/>
+        </p:spPr>
+        <p:txBody>
+          <a:bodyPr wrap="square" anchor="t" lIns="0" rIns="0" tIns="0" bIns="0">
+            <a:spAutoFit/>
+          </a:bodyPr>
+          <a:lstStyle/>
+          <a:p>
+            <a:pPr algn="l">
+              <a:lnSpc>
+                <a:spcPct val="115000"/>
+              </a:lnSpc>
+            </a:pPr>
+            <a:r>
+              <a:rPr sz="1250" b="0">
+                <a:solidFill>
+                  <a:srgbClr val="1C2833"/>
+                </a:solidFill>
+                <a:latin typeface="Meiryo"/>
+              </a:rPr>
+              <a:t>介助で立位がとれ、少し歩ける方</a:t>
+            </a:r>
+          </a:p>
+        </p:txBody>
+      </p:sp>
+      <p:sp>
+        <p:nvSpPr>
+          <p:cNvPr id="39" name="TextBox 38"/>
+          <p:cNvSpPr txBox="1"/>
+          <p:nvPr/>
+        </p:nvSpPr>
+        <p:spPr>
+          <a:xfrm>
+            <a:off x="9116567" y="3575304"/>
+            <a:ext cx="2331720" cy="219456"/>
+          </a:xfrm>
+          <a:prstGeom prst="rect">
+            <a:avLst/>
+          </a:prstGeom>
+          <a:noFill/>
+        </p:spPr>
+        <p:txBody>
+          <a:bodyPr wrap="square" anchor="t" lIns="0" rIns="0" tIns="0" bIns="0">
+            <a:spAutoFit/>
+          </a:bodyPr>
+          <a:lstStyle/>
+          <a:p>
+            <a:pPr algn="l">
+              <a:lnSpc>
+                <a:spcPct val="115000"/>
+              </a:lnSpc>
+            </a:pPr>
+            <a:r>
+              <a:rPr sz="1050" b="1">
+                <a:solidFill>
+                  <a:srgbClr val="1A5276"/>
+                </a:solidFill>
+                <a:latin typeface="Meiryo"/>
+              </a:rPr>
+              <a:t>選ばないのは</a:t>
+            </a:r>
+          </a:p>
+        </p:txBody>
+      </p:sp>
+      <p:sp>
+        <p:nvSpPr>
+          <p:cNvPr id="40" name="TextBox 39"/>
+          <p:cNvSpPr txBox="1"/>
+          <p:nvPr/>
+        </p:nvSpPr>
+        <p:spPr>
+          <a:xfrm>
+            <a:off x="9116567" y="3831335"/>
+            <a:ext cx="2331720" cy="713232"/>
+          </a:xfrm>
+          <a:prstGeom prst="rect">
+            <a:avLst/>
+          </a:prstGeom>
+          <a:noFill/>
+        </p:spPr>
+        <p:txBody>
+          <a:bodyPr wrap="square" anchor="t" lIns="0" rIns="0" tIns="0" bIns="0">
+            <a:spAutoFit/>
+          </a:bodyPr>
+          <a:lstStyle/>
+          <a:p>
+            <a:pPr algn="l">
+              <a:lnSpc>
+                <a:spcPct val="115000"/>
+              </a:lnSpc>
+            </a:pPr>
+            <a:r>
+              <a:rPr sz="1200" b="0">
+                <a:solidFill>
+                  <a:srgbClr val="566573"/>
+                </a:solidFill>
+                <a:latin typeface="Meiryo"/>
+              </a:rPr>
+              <a:t>立位がとれない方</a:t>
+            </a:r>
+          </a:p>
+        </p:txBody>
+      </p:sp>
+      <p:sp>
+        <p:nvSpPr>
+          <p:cNvPr id="41" name="Rounded Rectangle 40"/>
+          <p:cNvSpPr/>
+          <p:nvPr/>
+        </p:nvSpPr>
+        <p:spPr>
+          <a:xfrm>
+            <a:off x="9116567" y="4544568"/>
+            <a:ext cx="2331720" cy="402336"/>
+          </a:xfrm>
+          <a:prstGeom prst="roundRect">
+            <a:avLst>
+              <a:gd name="adj" fmla="val 22727"/>
+            </a:avLst>
+          </a:prstGeom>
+          <a:solidFill>
+            <a:srgbClr val="EAF7F1"/>
+          </a:solidFill>
+          <a:ln>
+            <a:noFill/>
+          </a:ln>
+          <a:effectLst/>
+        </p:spPr>
+        <p:style>
+          <a:lnRef idx="1">
+            <a:schemeClr val="accent1"/>
+          </a:lnRef>
+          <a:fillRef idx="3">
+            <a:schemeClr val="accent1"/>
+          </a:fillRef>
+          <a:effectRef idx="2">
+            <a:schemeClr val="accent1"/>
+          </a:effectRef>
+          <a:fontRef idx="minor">
+            <a:schemeClr val="lt1"/>
+          </a:fontRef>
+        </p:style>
+        <p:txBody>
+          <a:bodyPr rtlCol="0" anchor="ctr"/>
+          <a:lstStyle/>
+          <a:p>
+            <a:pPr algn="ctr"/>
+          </a:p>
+        </p:txBody>
+      </p:sp>
+      <p:sp>
+        <p:nvSpPr>
+          <p:cNvPr id="42" name="TextBox 41"/>
+          <p:cNvSpPr txBox="1"/>
+          <p:nvPr/>
+        </p:nvSpPr>
+        <p:spPr>
+          <a:xfrm>
+            <a:off x="9116567" y="4544568"/>
+            <a:ext cx="2331720" cy="402336"/>
+          </a:xfrm>
+          <a:prstGeom prst="rect">
+            <a:avLst/>
+          </a:prstGeom>
+          <a:noFill/>
+        </p:spPr>
+        <p:txBody>
+          <a:bodyPr wrap="square" anchor="ctr" lIns="0" rIns="0" tIns="0" bIns="0">
+            <a:spAutoFit/>
+          </a:bodyPr>
+          <a:lstStyle/>
+          <a:p>
+            <a:pPr algn="ctr">
+              <a:lnSpc>
+                <a:spcPct val="115000"/>
+              </a:lnSpc>
+            </a:pPr>
+            <a:r>
+              <a:rPr sz="1250" b="1">
+                <a:solidFill>
+                  <a:srgbClr val="1D9E75"/>
+                </a:solidFill>
+                <a:latin typeface="Meiryo"/>
+              </a:rPr>
+              <a:t>ご本人の力を残す</a:t>
+            </a:r>
+          </a:p>
+        </p:txBody>
+      </p:sp>
+      <p:sp>
+        <p:nvSpPr>
+          <p:cNvPr id="43" name="Rounded Rectangle 42"/>
+          <p:cNvSpPr/>
+          <p:nvPr/>
+        </p:nvSpPr>
+        <p:spPr>
+          <a:xfrm>
+            <a:off x="566928" y="5230368"/>
+            <a:ext cx="11055096" cy="914400"/>
+          </a:xfrm>
+          <a:prstGeom prst="roundRect">
+            <a:avLst>
+              <a:gd name="adj" fmla="val 10000"/>
+            </a:avLst>
+          </a:prstGeom>
+          <a:solidFill>
+            <a:srgbClr val="1D9E75"/>
+          </a:solidFill>
+          <a:ln>
+            <a:noFill/>
+          </a:ln>
+          <a:effectLst/>
+        </p:spPr>
+        <p:style>
+          <a:lnRef idx="1">
+            <a:schemeClr val="accent1"/>
+          </a:lnRef>
+          <a:fillRef idx="3">
+            <a:schemeClr val="accent1"/>
+          </a:fillRef>
+          <a:effectRef idx="2">
+            <a:schemeClr val="accent1"/>
+          </a:effectRef>
+          <a:fontRef idx="minor">
+            <a:schemeClr val="lt1"/>
+          </a:fontRef>
+        </p:style>
+        <p:txBody>
+          <a:bodyPr rtlCol="0" anchor="ctr"/>
+          <a:lstStyle/>
+          <a:p>
+            <a:pPr algn="ctr"/>
+          </a:p>
+        </p:txBody>
+      </p:sp>
+      <p:sp>
+        <p:nvSpPr>
+          <p:cNvPr id="44" name="TextBox 43"/>
+          <p:cNvSpPr txBox="1"/>
+          <p:nvPr/>
+        </p:nvSpPr>
+        <p:spPr>
+          <a:xfrm>
+            <a:off x="841248" y="5230368"/>
+            <a:ext cx="10506456" cy="914400"/>
+          </a:xfrm>
+          <a:prstGeom prst="rect">
+            <a:avLst/>
+          </a:prstGeom>
+          <a:noFill/>
+        </p:spPr>
+        <p:txBody>
+          <a:bodyPr wrap="square" anchor="ctr" lIns="0" rIns="0" tIns="0" bIns="0">
+            <a:spAutoFit/>
+          </a:bodyPr>
+          <a:lstStyle/>
+          <a:p>
+            <a:pPr algn="l">
+              <a:lnSpc>
+                <a:spcPct val="115000"/>
+              </a:lnSpc>
+            </a:pPr>
+            <a:r>
+              <a:rPr sz="1700" b="1">
+                <a:solidFill>
+                  <a:srgbClr val="FFFFFF"/>
+                </a:solidFill>
+                <a:latin typeface="Meiryo"/>
+              </a:rPr>
+              <a:t>方法は固定ではありません。</a:t>
+            </a:r>
+          </a:p>
+          <a:p>
+            <a:pPr algn="l">
+              <a:lnSpc>
+                <a:spcPct val="115000"/>
+              </a:lnSpc>
+              <a:spcBef>
+                <a:spcPts val="500"/>
+              </a:spcBef>
+            </a:pPr>
+            <a:r>
+              <a:rPr sz="1350" b="0">
+                <a:solidFill>
+                  <a:srgbClr val="FFFFFF"/>
+                </a:solidFill>
+                <a:latin typeface="Meiryo"/>
+              </a:rPr>
+              <a:t>事前訪問で決め、やってみてより安全・安楽な方へ変えます。ADLが上がれば座位回転へ。変更のつど、ご本人とご家族に確認しています。</a:t>
+            </a:r>
+          </a:p>
+        </p:txBody>
+      </p:sp>
+    </p:spTree>
+  </p:cSld>
+  <p:clrMapOvr>
+    <a:masterClrMapping/>
+  </p:clrMapOvr>
+</p:sld>
+</file>
+
+<file path=ppt/slides/slide15.xml><?xml version="1.0" encoding="utf-8"?>
 <p:sld xmlns:a="http://schemas.openxmlformats.org/drawingml/2006/main" xmlns:r="http://schemas.openxmlformats.org/officeDocument/2006/relationships" xmlns:p="http://schemas.openxmlformats.org/presentationml/2006/main">
   <p:cSld name="Slide 14">
     <p:spTree>
@@ -8224,7 +10080,7 @@
 </p:sld>
 </file>
 
-<file path=ppt/slides/slide15.xml><?xml version="1.0" encoding="utf-8"?>
+<file path=ppt/slides/slide16.xml><?xml version="1.0" encoding="utf-8"?>
 <p:sld xmlns:a="http://schemas.openxmlformats.org/drawingml/2006/main" xmlns:r="http://schemas.openxmlformats.org/officeDocument/2006/relationships" xmlns:p="http://schemas.openxmlformats.org/presentationml/2006/main">
   <p:cSld name="Slide 15">
     <p:bg>
@@ -8709,1451 +10565,6 @@
               <a:t>初回アセスメントは無料でお伺いします。導入の可否判断からお手伝いします。</a:t>
             </a:r>
             <a:endParaRPr lang="en-US" sz="1200" dirty="0"/>
-          </a:p>
-        </p:txBody>
-      </p:sp>
-    </p:spTree>
-  </p:cSld>
-  <p:clrMapOvr>
-    <a:masterClrMapping/>
-  </p:clrMapOvr>
-</p:sld>
-</file>
-
-<file path=ppt/slides/slide16.xml><?xml version="1.0" encoding="utf-8"?>
-<p:sld xmlns:a="http://schemas.openxmlformats.org/drawingml/2006/main" xmlns:p="http://schemas.openxmlformats.org/presentationml/2006/main" xmlns:r="http://schemas.openxmlformats.org/officeDocument/2006/relationships">
-  <p:cSld>
-    <p:spTree>
-      <p:nvGrpSpPr>
-        <p:cNvPr id="1" name=""/>
-        <p:cNvGrpSpPr/>
-        <p:nvPr/>
-      </p:nvGrpSpPr>
-      <p:grpSpPr/>
-      <p:sp>
-        <p:nvSpPr>
-          <p:cNvPr id="2" name="Rounded Rectangle 1"/>
-          <p:cNvSpPr/>
-          <p:nvPr/>
-        </p:nvSpPr>
-        <p:spPr>
-          <a:xfrm>
-            <a:off x="566928" y="329184"/>
-            <a:ext cx="1481328" cy="310896"/>
-          </a:xfrm>
-          <a:prstGeom prst="roundRect">
-            <a:avLst>
-              <a:gd name="adj" fmla="val 14705"/>
-            </a:avLst>
-          </a:prstGeom>
-          <a:solidFill>
-            <a:srgbClr val="1D9E75"/>
-          </a:solidFill>
-          <a:ln>
-            <a:noFill/>
-          </a:ln>
-          <a:effectLst/>
-        </p:spPr>
-        <p:style>
-          <a:lnRef idx="1">
-            <a:schemeClr val="accent1"/>
-          </a:lnRef>
-          <a:fillRef idx="3">
-            <a:schemeClr val="accent1"/>
-          </a:fillRef>
-          <a:effectRef idx="2">
-            <a:schemeClr val="accent1"/>
-          </a:effectRef>
-          <a:fontRef idx="minor">
-            <a:schemeClr val="lt1"/>
-          </a:fontRef>
-        </p:style>
-        <p:txBody>
-          <a:bodyPr rtlCol="0" anchor="ctr"/>
-          <a:lstStyle/>
-          <a:p>
-            <a:pPr algn="ctr"/>
-          </a:p>
-        </p:txBody>
-      </p:sp>
-      <p:sp>
-        <p:nvSpPr>
-          <p:cNvPr id="3" name="TextBox 2"/>
-          <p:cNvSpPr txBox="1"/>
-          <p:nvPr/>
-        </p:nvSpPr>
-        <p:spPr>
-          <a:xfrm>
-            <a:off x="566928" y="329184"/>
-            <a:ext cx="1481328" cy="310896"/>
-          </a:xfrm>
-          <a:prstGeom prst="rect">
-            <a:avLst/>
-          </a:prstGeom>
-          <a:noFill/>
-        </p:spPr>
-        <p:txBody>
-          <a:bodyPr wrap="square" anchor="ctr" lIns="0" rIns="0" tIns="0" bIns="0">
-            <a:spAutoFit/>
-          </a:bodyPr>
-          <a:lstStyle/>
-          <a:p>
-            <a:pPr algn="ctr"/>
-            <a:r>
-              <a:rPr sz="1200" b="1">
-                <a:solidFill>
-                  <a:srgbClr val="FFFFFF"/>
-                </a:solidFill>
-                <a:latin typeface="Meiryo"/>
-              </a:rPr>
-              <a:t>DEMO</a:t>
-            </a:r>
-          </a:p>
-        </p:txBody>
-      </p:sp>
-      <p:sp>
-        <p:nvSpPr>
-          <p:cNvPr id="4" name="TextBox 3"/>
-          <p:cNvSpPr txBox="1"/>
-          <p:nvPr/>
-        </p:nvSpPr>
-        <p:spPr>
-          <a:xfrm>
-            <a:off x="2194560" y="329184"/>
-            <a:ext cx="5486400" cy="310896"/>
-          </a:xfrm>
-          <a:prstGeom prst="rect">
-            <a:avLst/>
-          </a:prstGeom>
-          <a:noFill/>
-        </p:spPr>
-        <p:txBody>
-          <a:bodyPr wrap="square" anchor="ctr" lIns="0" rIns="0" tIns="0" bIns="0">
-            <a:spAutoFit/>
-          </a:bodyPr>
-          <a:lstStyle/>
-          <a:p>
-            <a:pPr algn="l"/>
-            <a:r>
-              <a:rPr sz="1300" b="0">
-                <a:solidFill>
-                  <a:srgbClr val="566573"/>
-                </a:solidFill>
-                <a:latin typeface="Meiryo"/>
-              </a:rPr>
-              <a:t>移乗の実演</a:t>
-            </a:r>
-          </a:p>
-        </p:txBody>
-      </p:sp>
-      <p:sp>
-        <p:nvSpPr>
-          <p:cNvPr id="5" name="TextBox 4"/>
-          <p:cNvSpPr txBox="1"/>
-          <p:nvPr/>
-        </p:nvSpPr>
-        <p:spPr>
-          <a:xfrm>
-            <a:off x="566928" y="749808"/>
-            <a:ext cx="11055096" cy="566928"/>
-          </a:xfrm>
-          <a:prstGeom prst="rect">
-            <a:avLst/>
-          </a:prstGeom>
-          <a:noFill/>
-        </p:spPr>
-        <p:txBody>
-          <a:bodyPr wrap="square" anchor="t" lIns="0" rIns="0" tIns="0" bIns="0">
-            <a:spAutoFit/>
-          </a:bodyPr>
-          <a:lstStyle/>
-          <a:p>
-            <a:pPr algn="l"/>
-            <a:r>
-              <a:rPr sz="3400" b="1">
-                <a:solidFill>
-                  <a:srgbClr val="1A5276"/>
-                </a:solidFill>
-                <a:latin typeface="Meiryo"/>
-              </a:rPr>
-              <a:t>お体を、どうお運びするか</a:t>
-            </a:r>
-          </a:p>
-        </p:txBody>
-      </p:sp>
-      <p:sp>
-        <p:nvSpPr>
-          <p:cNvPr id="6" name="TextBox 5"/>
-          <p:cNvSpPr txBox="1"/>
-          <p:nvPr/>
-        </p:nvSpPr>
-        <p:spPr>
-          <a:xfrm>
-            <a:off x="566928" y="1463040"/>
-            <a:ext cx="11055096" cy="310896"/>
-          </a:xfrm>
-          <a:prstGeom prst="rect">
-            <a:avLst/>
-          </a:prstGeom>
-          <a:noFill/>
-        </p:spPr>
-        <p:txBody>
-          <a:bodyPr wrap="square" anchor="t" lIns="0" rIns="0" tIns="0" bIns="0">
-            <a:spAutoFit/>
-          </a:bodyPr>
-          <a:lstStyle/>
-          <a:p>
-            <a:pPr algn="l"/>
-            <a:r>
-              <a:rPr sz="1400" b="0">
-                <a:solidFill>
-                  <a:srgbClr val="566573"/>
-                </a:solidFill>
-                <a:latin typeface="Meiryo"/>
-              </a:rPr>
-              <a:t>浴槽へお移しする方法は4つ。その方の状態に合わせて選びます。</a:t>
-            </a:r>
-          </a:p>
-        </p:txBody>
-      </p:sp>
-      <p:sp>
-        <p:nvSpPr>
-          <p:cNvPr id="7" name="Rounded Rectangle 6"/>
-          <p:cNvSpPr/>
-          <p:nvPr/>
-        </p:nvSpPr>
-        <p:spPr>
-          <a:xfrm>
-            <a:off x="566928" y="2011680"/>
-            <a:ext cx="2697480" cy="2788920"/>
-          </a:xfrm>
-          <a:prstGeom prst="roundRect">
-            <a:avLst>
-              <a:gd name="adj" fmla="val 3389"/>
-            </a:avLst>
-          </a:prstGeom>
-          <a:solidFill>
-            <a:srgbClr val="F4F8FA"/>
-          </a:solidFill>
-          <a:ln>
-            <a:noFill/>
-          </a:ln>
-          <a:effectLst/>
-        </p:spPr>
-        <p:style>
-          <a:lnRef idx="1">
-            <a:schemeClr val="accent1"/>
-          </a:lnRef>
-          <a:fillRef idx="3">
-            <a:schemeClr val="accent1"/>
-          </a:fillRef>
-          <a:effectRef idx="2">
-            <a:schemeClr val="accent1"/>
-          </a:effectRef>
-          <a:fontRef idx="minor">
-            <a:schemeClr val="lt1"/>
-          </a:fontRef>
-        </p:style>
-        <p:txBody>
-          <a:bodyPr rtlCol="0" anchor="ctr"/>
-          <a:lstStyle/>
-          <a:p>
-            <a:pPr algn="ctr"/>
-          </a:p>
-        </p:txBody>
-      </p:sp>
-      <p:sp>
-        <p:nvSpPr>
-          <p:cNvPr id="8" name="Rounded Rectangle 7"/>
-          <p:cNvSpPr/>
-          <p:nvPr/>
-        </p:nvSpPr>
-        <p:spPr>
-          <a:xfrm>
-            <a:off x="566928" y="2011680"/>
-            <a:ext cx="2697480" cy="566928"/>
-          </a:xfrm>
-          <a:prstGeom prst="roundRect">
-            <a:avLst>
-              <a:gd name="adj" fmla="val 16129"/>
-            </a:avLst>
-          </a:prstGeom>
-          <a:solidFill>
-            <a:srgbClr val="1A5276"/>
-          </a:solidFill>
-          <a:ln>
-            <a:noFill/>
-          </a:ln>
-          <a:effectLst/>
-        </p:spPr>
-        <p:style>
-          <a:lnRef idx="1">
-            <a:schemeClr val="accent1"/>
-          </a:lnRef>
-          <a:fillRef idx="3">
-            <a:schemeClr val="accent1"/>
-          </a:fillRef>
-          <a:effectRef idx="2">
-            <a:schemeClr val="accent1"/>
-          </a:effectRef>
-          <a:fontRef idx="minor">
-            <a:schemeClr val="lt1"/>
-          </a:fontRef>
-        </p:style>
-        <p:txBody>
-          <a:bodyPr rtlCol="0" anchor="ctr"/>
-          <a:lstStyle/>
-          <a:p>
-            <a:pPr algn="ctr"/>
-          </a:p>
-        </p:txBody>
-      </p:sp>
-      <p:sp>
-        <p:nvSpPr>
-          <p:cNvPr id="9" name="TextBox 8"/>
-          <p:cNvSpPr txBox="1"/>
-          <p:nvPr/>
-        </p:nvSpPr>
-        <p:spPr>
-          <a:xfrm>
-            <a:off x="566928" y="2011680"/>
-            <a:ext cx="2697480" cy="566928"/>
-          </a:xfrm>
-          <a:prstGeom prst="rect">
-            <a:avLst/>
-          </a:prstGeom>
-          <a:noFill/>
-        </p:spPr>
-        <p:txBody>
-          <a:bodyPr wrap="square" anchor="ctr" lIns="0" rIns="0" tIns="0" bIns="0">
-            <a:spAutoFit/>
-          </a:bodyPr>
-          <a:lstStyle/>
-          <a:p>
-            <a:pPr algn="ctr"/>
-            <a:r>
-              <a:rPr sz="1700" b="1">
-                <a:solidFill>
-                  <a:srgbClr val="FFFFFF"/>
-                </a:solidFill>
-                <a:latin typeface="Meiryo"/>
-              </a:rPr>
-              <a:t>抱き上げ移動</a:t>
-            </a:r>
-          </a:p>
-        </p:txBody>
-      </p:sp>
-      <p:sp>
-        <p:nvSpPr>
-          <p:cNvPr id="10" name="TextBox 9"/>
-          <p:cNvSpPr txBox="1"/>
-          <p:nvPr/>
-        </p:nvSpPr>
-        <p:spPr>
-          <a:xfrm>
-            <a:off x="768096" y="2743200"/>
-            <a:ext cx="2295144" cy="237744"/>
-          </a:xfrm>
-          <a:prstGeom prst="rect">
-            <a:avLst/>
-          </a:prstGeom>
-          <a:noFill/>
-        </p:spPr>
-        <p:txBody>
-          <a:bodyPr wrap="square" anchor="t" lIns="0" rIns="0" tIns="0" bIns="0">
-            <a:spAutoFit/>
-          </a:bodyPr>
-          <a:lstStyle/>
-          <a:p>
-            <a:pPr algn="l"/>
-            <a:r>
-              <a:rPr sz="1100" b="1">
-                <a:solidFill>
-                  <a:srgbClr val="1D9E75"/>
-                </a:solidFill>
-                <a:latin typeface="Meiryo"/>
-              </a:rPr>
-              <a:t>こんな方に</a:t>
-            </a:r>
-          </a:p>
-        </p:txBody>
-      </p:sp>
-      <p:sp>
-        <p:nvSpPr>
-          <p:cNvPr id="11" name="TextBox 10"/>
-          <p:cNvSpPr txBox="1"/>
-          <p:nvPr/>
-        </p:nvSpPr>
-        <p:spPr>
-          <a:xfrm>
-            <a:off x="768096" y="3035808"/>
-            <a:ext cx="2295144" cy="1005840"/>
-          </a:xfrm>
-          <a:prstGeom prst="rect">
-            <a:avLst/>
-          </a:prstGeom>
-          <a:noFill/>
-        </p:spPr>
-        <p:txBody>
-          <a:bodyPr wrap="square" anchor="t" lIns="0" rIns="0" tIns="0" bIns="0">
-            <a:spAutoFit/>
-          </a:bodyPr>
-          <a:lstStyle/>
-          <a:p>
-            <a:pPr algn="l"/>
-            <a:r>
-              <a:rPr sz="1350" b="0">
-                <a:solidFill>
-                  <a:srgbClr val="1C2833"/>
-                </a:solidFill>
-                <a:latin typeface="Meiryo"/>
-              </a:rPr>
-              <a:t>体格が小さく、拘縮の</a:t>
-            </a:r>
-          </a:p>
-          <a:p>
-            <a:pPr algn="l">
-              <a:spcBef>
-                <a:spcPts val="400"/>
-              </a:spcBef>
-            </a:pPr>
-            <a:r>
-              <a:rPr sz="1350" b="0">
-                <a:solidFill>
-                  <a:srgbClr val="1C2833"/>
-                </a:solidFill>
-                <a:latin typeface="Meiryo"/>
-              </a:rPr>
-              <a:t>少ない方</a:t>
-            </a:r>
-          </a:p>
-        </p:txBody>
-      </p:sp>
-      <p:sp>
-        <p:nvSpPr>
-          <p:cNvPr id="12" name="Rounded Rectangle 11"/>
-          <p:cNvSpPr/>
-          <p:nvPr/>
-        </p:nvSpPr>
-        <p:spPr>
-          <a:xfrm>
-            <a:off x="768096" y="4096512"/>
-            <a:ext cx="2295144" cy="457200"/>
-          </a:xfrm>
-          <a:prstGeom prst="roundRect">
-            <a:avLst>
-              <a:gd name="adj" fmla="val 20000"/>
-            </a:avLst>
-          </a:prstGeom>
-          <a:solidFill>
-            <a:srgbClr val="EAF7F1"/>
-          </a:solidFill>
-          <a:ln>
-            <a:noFill/>
-          </a:ln>
-          <a:effectLst/>
-        </p:spPr>
-        <p:style>
-          <a:lnRef idx="1">
-            <a:schemeClr val="accent1"/>
-          </a:lnRef>
-          <a:fillRef idx="3">
-            <a:schemeClr val="accent1"/>
-          </a:fillRef>
-          <a:effectRef idx="2">
-            <a:schemeClr val="accent1"/>
-          </a:effectRef>
-          <a:fontRef idx="minor">
-            <a:schemeClr val="lt1"/>
-          </a:fontRef>
-        </p:style>
-        <p:txBody>
-          <a:bodyPr rtlCol="0" anchor="ctr"/>
-          <a:lstStyle/>
-          <a:p>
-            <a:pPr algn="ctr"/>
-          </a:p>
-        </p:txBody>
-      </p:sp>
-      <p:sp>
-        <p:nvSpPr>
-          <p:cNvPr id="13" name="TextBox 12"/>
-          <p:cNvSpPr txBox="1"/>
-          <p:nvPr/>
-        </p:nvSpPr>
-        <p:spPr>
-          <a:xfrm>
-            <a:off x="768096" y="4096512"/>
-            <a:ext cx="2295144" cy="457200"/>
-          </a:xfrm>
-          <a:prstGeom prst="rect">
-            <a:avLst/>
-          </a:prstGeom>
-          <a:noFill/>
-        </p:spPr>
-        <p:txBody>
-          <a:bodyPr wrap="square" anchor="ctr" lIns="0" rIns="0" tIns="0" bIns="0">
-            <a:spAutoFit/>
-          </a:bodyPr>
-          <a:lstStyle/>
-          <a:p>
-            <a:pPr algn="ctr"/>
-            <a:r>
-              <a:rPr sz="1300" b="1">
-                <a:solidFill>
-                  <a:srgbClr val="1D9E75"/>
-                </a:solidFill>
-                <a:latin typeface="Meiryo"/>
-              </a:rPr>
-              <a:t>いちばん短時間</a:t>
-            </a:r>
-          </a:p>
-        </p:txBody>
-      </p:sp>
-      <p:sp>
-        <p:nvSpPr>
-          <p:cNvPr id="14" name="Rounded Rectangle 13"/>
-          <p:cNvSpPr/>
-          <p:nvPr/>
-        </p:nvSpPr>
-        <p:spPr>
-          <a:xfrm>
-            <a:off x="3355848" y="2011680"/>
-            <a:ext cx="2697480" cy="2788920"/>
-          </a:xfrm>
-          <a:prstGeom prst="roundRect">
-            <a:avLst>
-              <a:gd name="adj" fmla="val 3389"/>
-            </a:avLst>
-          </a:prstGeom>
-          <a:solidFill>
-            <a:srgbClr val="F4F8FA"/>
-          </a:solidFill>
-          <a:ln>
-            <a:noFill/>
-          </a:ln>
-          <a:effectLst/>
-        </p:spPr>
-        <p:style>
-          <a:lnRef idx="1">
-            <a:schemeClr val="accent1"/>
-          </a:lnRef>
-          <a:fillRef idx="3">
-            <a:schemeClr val="accent1"/>
-          </a:fillRef>
-          <a:effectRef idx="2">
-            <a:schemeClr val="accent1"/>
-          </a:effectRef>
-          <a:fontRef idx="minor">
-            <a:schemeClr val="lt1"/>
-          </a:fontRef>
-        </p:style>
-        <p:txBody>
-          <a:bodyPr rtlCol="0" anchor="ctr"/>
-          <a:lstStyle/>
-          <a:p>
-            <a:pPr algn="ctr"/>
-          </a:p>
-        </p:txBody>
-      </p:sp>
-      <p:sp>
-        <p:nvSpPr>
-          <p:cNvPr id="15" name="Rounded Rectangle 14"/>
-          <p:cNvSpPr/>
-          <p:nvPr/>
-        </p:nvSpPr>
-        <p:spPr>
-          <a:xfrm>
-            <a:off x="3355848" y="2011680"/>
-            <a:ext cx="2697480" cy="566928"/>
-          </a:xfrm>
-          <a:prstGeom prst="roundRect">
-            <a:avLst>
-              <a:gd name="adj" fmla="val 16129"/>
-            </a:avLst>
-          </a:prstGeom>
-          <a:solidFill>
-            <a:srgbClr val="1A5276"/>
-          </a:solidFill>
-          <a:ln>
-            <a:noFill/>
-          </a:ln>
-          <a:effectLst/>
-        </p:spPr>
-        <p:style>
-          <a:lnRef idx="1">
-            <a:schemeClr val="accent1"/>
-          </a:lnRef>
-          <a:fillRef idx="3">
-            <a:schemeClr val="accent1"/>
-          </a:fillRef>
-          <a:effectRef idx="2">
-            <a:schemeClr val="accent1"/>
-          </a:effectRef>
-          <a:fontRef idx="minor">
-            <a:schemeClr val="lt1"/>
-          </a:fontRef>
-        </p:style>
-        <p:txBody>
-          <a:bodyPr rtlCol="0" anchor="ctr"/>
-          <a:lstStyle/>
-          <a:p>
-            <a:pPr algn="ctr"/>
-          </a:p>
-        </p:txBody>
-      </p:sp>
-      <p:sp>
-        <p:nvSpPr>
-          <p:cNvPr id="16" name="TextBox 15"/>
-          <p:cNvSpPr txBox="1"/>
-          <p:nvPr/>
-        </p:nvSpPr>
-        <p:spPr>
-          <a:xfrm>
-            <a:off x="3355848" y="2011680"/>
-            <a:ext cx="2697480" cy="566928"/>
-          </a:xfrm>
-          <a:prstGeom prst="rect">
-            <a:avLst/>
-          </a:prstGeom>
-          <a:noFill/>
-        </p:spPr>
-        <p:txBody>
-          <a:bodyPr wrap="square" anchor="ctr" lIns="0" rIns="0" tIns="0" bIns="0">
-            <a:spAutoFit/>
-          </a:bodyPr>
-          <a:lstStyle/>
-          <a:p>
-            <a:pPr algn="ctr"/>
-            <a:r>
-              <a:rPr sz="1700" b="1">
-                <a:solidFill>
-                  <a:srgbClr val="FFFFFF"/>
-                </a:solidFill>
-                <a:latin typeface="Meiryo"/>
-              </a:rPr>
-              <a:t>担架移動</a:t>
-            </a:r>
-          </a:p>
-        </p:txBody>
-      </p:sp>
-      <p:sp>
-        <p:nvSpPr>
-          <p:cNvPr id="17" name="TextBox 16"/>
-          <p:cNvSpPr txBox="1"/>
-          <p:nvPr/>
-        </p:nvSpPr>
-        <p:spPr>
-          <a:xfrm>
-            <a:off x="3557016" y="2743200"/>
-            <a:ext cx="2295144" cy="237744"/>
-          </a:xfrm>
-          <a:prstGeom prst="rect">
-            <a:avLst/>
-          </a:prstGeom>
-          <a:noFill/>
-        </p:spPr>
-        <p:txBody>
-          <a:bodyPr wrap="square" anchor="t" lIns="0" rIns="0" tIns="0" bIns="0">
-            <a:spAutoFit/>
-          </a:bodyPr>
-          <a:lstStyle/>
-          <a:p>
-            <a:pPr algn="l"/>
-            <a:r>
-              <a:rPr sz="1100" b="1">
-                <a:solidFill>
-                  <a:srgbClr val="1D9E75"/>
-                </a:solidFill>
-                <a:latin typeface="Meiryo"/>
-              </a:rPr>
-              <a:t>こんな方に</a:t>
-            </a:r>
-          </a:p>
-        </p:txBody>
-      </p:sp>
-      <p:sp>
-        <p:nvSpPr>
-          <p:cNvPr id="18" name="TextBox 17"/>
-          <p:cNvSpPr txBox="1"/>
-          <p:nvPr/>
-        </p:nvSpPr>
-        <p:spPr>
-          <a:xfrm>
-            <a:off x="3557016" y="3035808"/>
-            <a:ext cx="2295144" cy="1005840"/>
-          </a:xfrm>
-          <a:prstGeom prst="rect">
-            <a:avLst/>
-          </a:prstGeom>
-          <a:noFill/>
-        </p:spPr>
-        <p:txBody>
-          <a:bodyPr wrap="square" anchor="t" lIns="0" rIns="0" tIns="0" bIns="0">
-            <a:spAutoFit/>
-          </a:bodyPr>
-          <a:lstStyle/>
-          <a:p>
-            <a:pPr algn="l"/>
-            <a:r>
-              <a:rPr sz="1350" b="0">
-                <a:solidFill>
-                  <a:srgbClr val="1C2833"/>
-                </a:solidFill>
-                <a:latin typeface="Meiryo"/>
-              </a:rPr>
-              <a:t>体の大きい方、</a:t>
-            </a:r>
-          </a:p>
-          <a:p>
-            <a:pPr algn="l">
-              <a:spcBef>
-                <a:spcPts val="400"/>
-              </a:spcBef>
-            </a:pPr>
-            <a:r>
-              <a:rPr sz="1350" b="0">
-                <a:solidFill>
-                  <a:srgbClr val="1C2833"/>
-                </a:solidFill>
-                <a:latin typeface="Meiryo"/>
-              </a:rPr>
-              <a:t>全介助の方</a:t>
-            </a:r>
-          </a:p>
-        </p:txBody>
-      </p:sp>
-      <p:sp>
-        <p:nvSpPr>
-          <p:cNvPr id="19" name="Rounded Rectangle 18"/>
-          <p:cNvSpPr/>
-          <p:nvPr/>
-        </p:nvSpPr>
-        <p:spPr>
-          <a:xfrm>
-            <a:off x="3557016" y="4096512"/>
-            <a:ext cx="2295144" cy="457200"/>
-          </a:xfrm>
-          <a:prstGeom prst="roundRect">
-            <a:avLst>
-              <a:gd name="adj" fmla="val 20000"/>
-            </a:avLst>
-          </a:prstGeom>
-          <a:solidFill>
-            <a:srgbClr val="EAF7F1"/>
-          </a:solidFill>
-          <a:ln>
-            <a:noFill/>
-          </a:ln>
-          <a:effectLst/>
-        </p:spPr>
-        <p:style>
-          <a:lnRef idx="1">
-            <a:schemeClr val="accent1"/>
-          </a:lnRef>
-          <a:fillRef idx="3">
-            <a:schemeClr val="accent1"/>
-          </a:fillRef>
-          <a:effectRef idx="2">
-            <a:schemeClr val="accent1"/>
-          </a:effectRef>
-          <a:fontRef idx="minor">
-            <a:schemeClr val="lt1"/>
-          </a:fontRef>
-        </p:style>
-        <p:txBody>
-          <a:bodyPr rtlCol="0" anchor="ctr"/>
-          <a:lstStyle/>
-          <a:p>
-            <a:pPr algn="ctr"/>
-          </a:p>
-        </p:txBody>
-      </p:sp>
-      <p:sp>
-        <p:nvSpPr>
-          <p:cNvPr id="20" name="TextBox 19"/>
-          <p:cNvSpPr txBox="1"/>
-          <p:nvPr/>
-        </p:nvSpPr>
-        <p:spPr>
-          <a:xfrm>
-            <a:off x="3557016" y="4096512"/>
-            <a:ext cx="2295144" cy="457200"/>
-          </a:xfrm>
-          <a:prstGeom prst="rect">
-            <a:avLst/>
-          </a:prstGeom>
-          <a:noFill/>
-        </p:spPr>
-        <p:txBody>
-          <a:bodyPr wrap="square" anchor="ctr" lIns="0" rIns="0" tIns="0" bIns="0">
-            <a:spAutoFit/>
-          </a:bodyPr>
-          <a:lstStyle/>
-          <a:p>
-            <a:pPr algn="ctr"/>
-            <a:r>
-              <a:rPr sz="1300" b="1">
-                <a:solidFill>
-                  <a:srgbClr val="1D9E75"/>
-                </a:solidFill>
-                <a:latin typeface="Meiryo"/>
-              </a:rPr>
-              <a:t>いちばん安全</a:t>
-            </a:r>
-          </a:p>
-        </p:txBody>
-      </p:sp>
-      <p:sp>
-        <p:nvSpPr>
-          <p:cNvPr id="21" name="Rounded Rectangle 20"/>
-          <p:cNvSpPr/>
-          <p:nvPr/>
-        </p:nvSpPr>
-        <p:spPr>
-          <a:xfrm>
-            <a:off x="6144768" y="2011680"/>
-            <a:ext cx="2697480" cy="2788920"/>
-          </a:xfrm>
-          <a:prstGeom prst="roundRect">
-            <a:avLst>
-              <a:gd name="adj" fmla="val 3389"/>
-            </a:avLst>
-          </a:prstGeom>
-          <a:solidFill>
-            <a:srgbClr val="F4F8FA"/>
-          </a:solidFill>
-          <a:ln>
-            <a:noFill/>
-          </a:ln>
-          <a:effectLst/>
-        </p:spPr>
-        <p:style>
-          <a:lnRef idx="1">
-            <a:schemeClr val="accent1"/>
-          </a:lnRef>
-          <a:fillRef idx="3">
-            <a:schemeClr val="accent1"/>
-          </a:fillRef>
-          <a:effectRef idx="2">
-            <a:schemeClr val="accent1"/>
-          </a:effectRef>
-          <a:fontRef idx="minor">
-            <a:schemeClr val="lt1"/>
-          </a:fontRef>
-        </p:style>
-        <p:txBody>
-          <a:bodyPr rtlCol="0" anchor="ctr"/>
-          <a:lstStyle/>
-          <a:p>
-            <a:pPr algn="ctr"/>
-          </a:p>
-        </p:txBody>
-      </p:sp>
-      <p:sp>
-        <p:nvSpPr>
-          <p:cNvPr id="22" name="Rounded Rectangle 21"/>
-          <p:cNvSpPr/>
-          <p:nvPr/>
-        </p:nvSpPr>
-        <p:spPr>
-          <a:xfrm>
-            <a:off x="6144768" y="2011680"/>
-            <a:ext cx="2697480" cy="566928"/>
-          </a:xfrm>
-          <a:prstGeom prst="roundRect">
-            <a:avLst>
-              <a:gd name="adj" fmla="val 16129"/>
-            </a:avLst>
-          </a:prstGeom>
-          <a:solidFill>
-            <a:srgbClr val="1A5276"/>
-          </a:solidFill>
-          <a:ln>
-            <a:noFill/>
-          </a:ln>
-          <a:effectLst/>
-        </p:spPr>
-        <p:style>
-          <a:lnRef idx="1">
-            <a:schemeClr val="accent1"/>
-          </a:lnRef>
-          <a:fillRef idx="3">
-            <a:schemeClr val="accent1"/>
-          </a:fillRef>
-          <a:effectRef idx="2">
-            <a:schemeClr val="accent1"/>
-          </a:effectRef>
-          <a:fontRef idx="minor">
-            <a:schemeClr val="lt1"/>
-          </a:fontRef>
-        </p:style>
-        <p:txBody>
-          <a:bodyPr rtlCol="0" anchor="ctr"/>
-          <a:lstStyle/>
-          <a:p>
-            <a:pPr algn="ctr"/>
-          </a:p>
-        </p:txBody>
-      </p:sp>
-      <p:sp>
-        <p:nvSpPr>
-          <p:cNvPr id="23" name="TextBox 22"/>
-          <p:cNvSpPr txBox="1"/>
-          <p:nvPr/>
-        </p:nvSpPr>
-        <p:spPr>
-          <a:xfrm>
-            <a:off x="6144768" y="2011680"/>
-            <a:ext cx="2697480" cy="566928"/>
-          </a:xfrm>
-          <a:prstGeom prst="rect">
-            <a:avLst/>
-          </a:prstGeom>
-          <a:noFill/>
-        </p:spPr>
-        <p:txBody>
-          <a:bodyPr wrap="square" anchor="ctr" lIns="0" rIns="0" tIns="0" bIns="0">
-            <a:spAutoFit/>
-          </a:bodyPr>
-          <a:lstStyle/>
-          <a:p>
-            <a:pPr algn="ctr"/>
-            <a:r>
-              <a:rPr sz="1700" b="1">
-                <a:solidFill>
-                  <a:srgbClr val="FFFFFF"/>
-                </a:solidFill>
-                <a:latin typeface="Meiryo"/>
-              </a:rPr>
-              <a:t>上下移動</a:t>
-            </a:r>
-          </a:p>
-        </p:txBody>
-      </p:sp>
-      <p:sp>
-        <p:nvSpPr>
-          <p:cNvPr id="24" name="TextBox 23"/>
-          <p:cNvSpPr txBox="1"/>
-          <p:nvPr/>
-        </p:nvSpPr>
-        <p:spPr>
-          <a:xfrm>
-            <a:off x="6345936" y="2743200"/>
-            <a:ext cx="2295144" cy="237744"/>
-          </a:xfrm>
-          <a:prstGeom prst="rect">
-            <a:avLst/>
-          </a:prstGeom>
-          <a:noFill/>
-        </p:spPr>
-        <p:txBody>
-          <a:bodyPr wrap="square" anchor="t" lIns="0" rIns="0" tIns="0" bIns="0">
-            <a:spAutoFit/>
-          </a:bodyPr>
-          <a:lstStyle/>
-          <a:p>
-            <a:pPr algn="l"/>
-            <a:r>
-              <a:rPr sz="1100" b="1">
-                <a:solidFill>
-                  <a:srgbClr val="1D9E75"/>
-                </a:solidFill>
-                <a:latin typeface="Meiryo"/>
-              </a:rPr>
-              <a:t>こんな方に</a:t>
-            </a:r>
-          </a:p>
-        </p:txBody>
-      </p:sp>
-      <p:sp>
-        <p:nvSpPr>
-          <p:cNvPr id="25" name="TextBox 24"/>
-          <p:cNvSpPr txBox="1"/>
-          <p:nvPr/>
-        </p:nvSpPr>
-        <p:spPr>
-          <a:xfrm>
-            <a:off x="6345936" y="3035808"/>
-            <a:ext cx="2295144" cy="1005840"/>
-          </a:xfrm>
-          <a:prstGeom prst="rect">
-            <a:avLst/>
-          </a:prstGeom>
-          <a:noFill/>
-        </p:spPr>
-        <p:txBody>
-          <a:bodyPr wrap="square" anchor="t" lIns="0" rIns="0" tIns="0" bIns="0">
-            <a:spAutoFit/>
-          </a:bodyPr>
-          <a:lstStyle/>
-          <a:p>
-            <a:pPr algn="l"/>
-            <a:r>
-              <a:rPr sz="1350" b="0">
-                <a:solidFill>
-                  <a:srgbClr val="1C2833"/>
-                </a:solidFill>
-                <a:latin typeface="Meiryo"/>
-              </a:rPr>
-              <a:t>ベッドと浴槽の高さを</a:t>
-            </a:r>
-          </a:p>
-          <a:p>
-            <a:pPr algn="l">
-              <a:spcBef>
-                <a:spcPts val="400"/>
-              </a:spcBef>
-            </a:pPr>
-            <a:r>
-              <a:rPr sz="1350" b="0">
-                <a:solidFill>
-                  <a:srgbClr val="1C2833"/>
-                </a:solidFill>
-                <a:latin typeface="Meiryo"/>
-              </a:rPr>
-              <a:t>合わせ、水平に</a:t>
-            </a:r>
-          </a:p>
-        </p:txBody>
-      </p:sp>
-      <p:sp>
-        <p:nvSpPr>
-          <p:cNvPr id="26" name="Rounded Rectangle 25"/>
-          <p:cNvSpPr/>
-          <p:nvPr/>
-        </p:nvSpPr>
-        <p:spPr>
-          <a:xfrm>
-            <a:off x="6345936" y="4096512"/>
-            <a:ext cx="2295144" cy="457200"/>
-          </a:xfrm>
-          <a:prstGeom prst="roundRect">
-            <a:avLst>
-              <a:gd name="adj" fmla="val 20000"/>
-            </a:avLst>
-          </a:prstGeom>
-          <a:solidFill>
-            <a:srgbClr val="EAF7F1"/>
-          </a:solidFill>
-          <a:ln>
-            <a:noFill/>
-          </a:ln>
-          <a:effectLst/>
-        </p:spPr>
-        <p:style>
-          <a:lnRef idx="1">
-            <a:schemeClr val="accent1"/>
-          </a:lnRef>
-          <a:fillRef idx="3">
-            <a:schemeClr val="accent1"/>
-          </a:fillRef>
-          <a:effectRef idx="2">
-            <a:schemeClr val="accent1"/>
-          </a:effectRef>
-          <a:fontRef idx="minor">
-            <a:schemeClr val="lt1"/>
-          </a:fontRef>
-        </p:style>
-        <p:txBody>
-          <a:bodyPr rtlCol="0" anchor="ctr"/>
-          <a:lstStyle/>
-          <a:p>
-            <a:pPr algn="ctr"/>
-          </a:p>
-        </p:txBody>
-      </p:sp>
-      <p:sp>
-        <p:nvSpPr>
-          <p:cNvPr id="27" name="TextBox 26"/>
-          <p:cNvSpPr txBox="1"/>
-          <p:nvPr/>
-        </p:nvSpPr>
-        <p:spPr>
-          <a:xfrm>
-            <a:off x="6345936" y="4096512"/>
-            <a:ext cx="2295144" cy="457200"/>
-          </a:xfrm>
-          <a:prstGeom prst="rect">
-            <a:avLst/>
-          </a:prstGeom>
-          <a:noFill/>
-        </p:spPr>
-        <p:txBody>
-          <a:bodyPr wrap="square" anchor="ctr" lIns="0" rIns="0" tIns="0" bIns="0">
-            <a:spAutoFit/>
-          </a:bodyPr>
-          <a:lstStyle/>
-          <a:p>
-            <a:pPr algn="ctr"/>
-            <a:r>
-              <a:rPr sz="1300" b="1">
-                <a:solidFill>
-                  <a:srgbClr val="1D9E75"/>
-                </a:solidFill>
-                <a:latin typeface="Meiryo"/>
-              </a:rPr>
-              <a:t>体への負担が少ない</a:t>
-            </a:r>
-          </a:p>
-        </p:txBody>
-      </p:sp>
-      <p:sp>
-        <p:nvSpPr>
-          <p:cNvPr id="28" name="Rounded Rectangle 27"/>
-          <p:cNvSpPr/>
-          <p:nvPr/>
-        </p:nvSpPr>
-        <p:spPr>
-          <a:xfrm>
-            <a:off x="8933688" y="2011680"/>
-            <a:ext cx="2697480" cy="2788920"/>
-          </a:xfrm>
-          <a:prstGeom prst="roundRect">
-            <a:avLst>
-              <a:gd name="adj" fmla="val 3389"/>
-            </a:avLst>
-          </a:prstGeom>
-          <a:solidFill>
-            <a:srgbClr val="F4F8FA"/>
-          </a:solidFill>
-          <a:ln>
-            <a:noFill/>
-          </a:ln>
-          <a:effectLst/>
-        </p:spPr>
-        <p:style>
-          <a:lnRef idx="1">
-            <a:schemeClr val="accent1"/>
-          </a:lnRef>
-          <a:fillRef idx="3">
-            <a:schemeClr val="accent1"/>
-          </a:fillRef>
-          <a:effectRef idx="2">
-            <a:schemeClr val="accent1"/>
-          </a:effectRef>
-          <a:fontRef idx="minor">
-            <a:schemeClr val="lt1"/>
-          </a:fontRef>
-        </p:style>
-        <p:txBody>
-          <a:bodyPr rtlCol="0" anchor="ctr"/>
-          <a:lstStyle/>
-          <a:p>
-            <a:pPr algn="ctr"/>
-          </a:p>
-        </p:txBody>
-      </p:sp>
-      <p:sp>
-        <p:nvSpPr>
-          <p:cNvPr id="29" name="Rounded Rectangle 28"/>
-          <p:cNvSpPr/>
-          <p:nvPr/>
-        </p:nvSpPr>
-        <p:spPr>
-          <a:xfrm>
-            <a:off x="8933688" y="2011680"/>
-            <a:ext cx="2697480" cy="566928"/>
-          </a:xfrm>
-          <a:prstGeom prst="roundRect">
-            <a:avLst>
-              <a:gd name="adj" fmla="val 16129"/>
-            </a:avLst>
-          </a:prstGeom>
-          <a:solidFill>
-            <a:srgbClr val="1A5276"/>
-          </a:solidFill>
-          <a:ln>
-            <a:noFill/>
-          </a:ln>
-          <a:effectLst/>
-        </p:spPr>
-        <p:style>
-          <a:lnRef idx="1">
-            <a:schemeClr val="accent1"/>
-          </a:lnRef>
-          <a:fillRef idx="3">
-            <a:schemeClr val="accent1"/>
-          </a:fillRef>
-          <a:effectRef idx="2">
-            <a:schemeClr val="accent1"/>
-          </a:effectRef>
-          <a:fontRef idx="minor">
-            <a:schemeClr val="lt1"/>
-          </a:fontRef>
-        </p:style>
-        <p:txBody>
-          <a:bodyPr rtlCol="0" anchor="ctr"/>
-          <a:lstStyle/>
-          <a:p>
-            <a:pPr algn="ctr"/>
-          </a:p>
-        </p:txBody>
-      </p:sp>
-      <p:sp>
-        <p:nvSpPr>
-          <p:cNvPr id="30" name="TextBox 29"/>
-          <p:cNvSpPr txBox="1"/>
-          <p:nvPr/>
-        </p:nvSpPr>
-        <p:spPr>
-          <a:xfrm>
-            <a:off x="8933688" y="2011680"/>
-            <a:ext cx="2697480" cy="566928"/>
-          </a:xfrm>
-          <a:prstGeom prst="rect">
-            <a:avLst/>
-          </a:prstGeom>
-          <a:noFill/>
-        </p:spPr>
-        <p:txBody>
-          <a:bodyPr wrap="square" anchor="ctr" lIns="0" rIns="0" tIns="0" bIns="0">
-            <a:spAutoFit/>
-          </a:bodyPr>
-          <a:lstStyle/>
-          <a:p>
-            <a:pPr algn="ctr"/>
-            <a:r>
-              <a:rPr sz="1700" b="1">
-                <a:solidFill>
-                  <a:srgbClr val="FFFFFF"/>
-                </a:solidFill>
-                <a:latin typeface="Meiryo"/>
-              </a:rPr>
-              <a:t>座位回転</a:t>
-            </a:r>
-          </a:p>
-        </p:txBody>
-      </p:sp>
-      <p:sp>
-        <p:nvSpPr>
-          <p:cNvPr id="31" name="TextBox 30"/>
-          <p:cNvSpPr txBox="1"/>
-          <p:nvPr/>
-        </p:nvSpPr>
-        <p:spPr>
-          <a:xfrm>
-            <a:off x="9134856" y="2743200"/>
-            <a:ext cx="2295144" cy="237744"/>
-          </a:xfrm>
-          <a:prstGeom prst="rect">
-            <a:avLst/>
-          </a:prstGeom>
-          <a:noFill/>
-        </p:spPr>
-        <p:txBody>
-          <a:bodyPr wrap="square" anchor="t" lIns="0" rIns="0" tIns="0" bIns="0">
-            <a:spAutoFit/>
-          </a:bodyPr>
-          <a:lstStyle/>
-          <a:p>
-            <a:pPr algn="l"/>
-            <a:r>
-              <a:rPr sz="1100" b="1">
-                <a:solidFill>
-                  <a:srgbClr val="1D9E75"/>
-                </a:solidFill>
-                <a:latin typeface="Meiryo"/>
-              </a:rPr>
-              <a:t>こんな方に</a:t>
-            </a:r>
-          </a:p>
-        </p:txBody>
-      </p:sp>
-      <p:sp>
-        <p:nvSpPr>
-          <p:cNvPr id="32" name="TextBox 31"/>
-          <p:cNvSpPr txBox="1"/>
-          <p:nvPr/>
-        </p:nvSpPr>
-        <p:spPr>
-          <a:xfrm>
-            <a:off x="9134856" y="3035808"/>
-            <a:ext cx="2295144" cy="1005840"/>
-          </a:xfrm>
-          <a:prstGeom prst="rect">
-            <a:avLst/>
-          </a:prstGeom>
-          <a:noFill/>
-        </p:spPr>
-        <p:txBody>
-          <a:bodyPr wrap="square" anchor="t" lIns="0" rIns="0" tIns="0" bIns="0">
-            <a:spAutoFit/>
-          </a:bodyPr>
-          <a:lstStyle/>
-          <a:p>
-            <a:pPr algn="l"/>
-            <a:r>
-              <a:rPr sz="1350" b="0">
-                <a:solidFill>
-                  <a:srgbClr val="1C2833"/>
-                </a:solidFill>
-                <a:latin typeface="Meiryo"/>
-              </a:rPr>
-              <a:t>座位が保てる方</a:t>
-            </a:r>
-          </a:p>
-        </p:txBody>
-      </p:sp>
-      <p:sp>
-        <p:nvSpPr>
-          <p:cNvPr id="33" name="Rounded Rectangle 32"/>
-          <p:cNvSpPr/>
-          <p:nvPr/>
-        </p:nvSpPr>
-        <p:spPr>
-          <a:xfrm>
-            <a:off x="9134856" y="4096512"/>
-            <a:ext cx="2295144" cy="457200"/>
-          </a:xfrm>
-          <a:prstGeom prst="roundRect">
-            <a:avLst>
-              <a:gd name="adj" fmla="val 20000"/>
-            </a:avLst>
-          </a:prstGeom>
-          <a:solidFill>
-            <a:srgbClr val="EAF7F1"/>
-          </a:solidFill>
-          <a:ln>
-            <a:noFill/>
-          </a:ln>
-          <a:effectLst/>
-        </p:spPr>
-        <p:style>
-          <a:lnRef idx="1">
-            <a:schemeClr val="accent1"/>
-          </a:lnRef>
-          <a:fillRef idx="3">
-            <a:schemeClr val="accent1"/>
-          </a:fillRef>
-          <a:effectRef idx="2">
-            <a:schemeClr val="accent1"/>
-          </a:effectRef>
-          <a:fontRef idx="minor">
-            <a:schemeClr val="lt1"/>
-          </a:fontRef>
-        </p:style>
-        <p:txBody>
-          <a:bodyPr rtlCol="0" anchor="ctr"/>
-          <a:lstStyle/>
-          <a:p>
-            <a:pPr algn="ctr"/>
-          </a:p>
-        </p:txBody>
-      </p:sp>
-      <p:sp>
-        <p:nvSpPr>
-          <p:cNvPr id="34" name="TextBox 33"/>
-          <p:cNvSpPr txBox="1"/>
-          <p:nvPr/>
-        </p:nvSpPr>
-        <p:spPr>
-          <a:xfrm>
-            <a:off x="9134856" y="4096512"/>
-            <a:ext cx="2295144" cy="457200"/>
-          </a:xfrm>
-          <a:prstGeom prst="rect">
-            <a:avLst/>
-          </a:prstGeom>
-          <a:noFill/>
-        </p:spPr>
-        <p:txBody>
-          <a:bodyPr wrap="square" anchor="ctr" lIns="0" rIns="0" tIns="0" bIns="0">
-            <a:spAutoFit/>
-          </a:bodyPr>
-          <a:lstStyle/>
-          <a:p>
-            <a:pPr algn="ctr"/>
-            <a:r>
-              <a:rPr sz="1300" b="1">
-                <a:solidFill>
-                  <a:srgbClr val="1D9E75"/>
-                </a:solidFill>
-                <a:latin typeface="Meiryo"/>
-              </a:rPr>
-              <a:t>ご本人の力を残す</a:t>
-            </a:r>
-          </a:p>
-        </p:txBody>
-      </p:sp>
-      <p:sp>
-        <p:nvSpPr>
-          <p:cNvPr id="35" name="Rounded Rectangle 34"/>
-          <p:cNvSpPr/>
-          <p:nvPr/>
-        </p:nvSpPr>
-        <p:spPr>
-          <a:xfrm>
-            <a:off x="566928" y="5120640"/>
-            <a:ext cx="11055096" cy="658368"/>
-          </a:xfrm>
-          <a:prstGeom prst="roundRect">
-            <a:avLst>
-              <a:gd name="adj" fmla="val 13888"/>
-            </a:avLst>
-          </a:prstGeom>
-          <a:solidFill>
-            <a:srgbClr val="1D9E75"/>
-          </a:solidFill>
-          <a:ln>
-            <a:noFill/>
-          </a:ln>
-          <a:effectLst/>
-        </p:spPr>
-        <p:style>
-          <a:lnRef idx="1">
-            <a:schemeClr val="accent1"/>
-          </a:lnRef>
-          <a:fillRef idx="3">
-            <a:schemeClr val="accent1"/>
-          </a:fillRef>
-          <a:effectRef idx="2">
-            <a:schemeClr val="accent1"/>
-          </a:effectRef>
-          <a:fontRef idx="minor">
-            <a:schemeClr val="lt1"/>
-          </a:fontRef>
-        </p:style>
-        <p:txBody>
-          <a:bodyPr rtlCol="0" anchor="ctr"/>
-          <a:lstStyle/>
-          <a:p>
-            <a:pPr algn="ctr"/>
-          </a:p>
-        </p:txBody>
-      </p:sp>
-      <p:sp>
-        <p:nvSpPr>
-          <p:cNvPr id="36" name="TextBox 35"/>
-          <p:cNvSpPr txBox="1"/>
-          <p:nvPr/>
-        </p:nvSpPr>
-        <p:spPr>
-          <a:xfrm>
-            <a:off x="566928" y="5120640"/>
-            <a:ext cx="11055096" cy="658368"/>
-          </a:xfrm>
-          <a:prstGeom prst="rect">
-            <a:avLst/>
-          </a:prstGeom>
-          <a:noFill/>
-        </p:spPr>
-        <p:txBody>
-          <a:bodyPr wrap="square" anchor="ctr" lIns="0" rIns="0" tIns="0" bIns="0">
-            <a:spAutoFit/>
-          </a:bodyPr>
-          <a:lstStyle/>
-          <a:p>
-            <a:pPr algn="ctr"/>
-            <a:r>
-              <a:rPr sz="1800" b="1">
-                <a:solidFill>
-                  <a:srgbClr val="FFFFFF"/>
-                </a:solidFill>
-                <a:latin typeface="Meiryo"/>
-              </a:rPr>
-              <a:t>どの方法でお運びするかを、お一人おひとり決めています。安全に、楽に。</a:t>
-            </a:r>
           </a:p>
         </p:txBody>
       </p:sp>

</xml_diff>

<commit_message>
Carry the role-division rewrite onto the slide and the handout
The script was reworded earlier but slide 9 and handout section 05 still
read "医療行為は行えません" and listed 薬剤の塗布 as the nurse's job — the
screen would have contradicted the speaker. Both now say the two services
differ in scope, list the ointment (outside pressure-ulcer care) and
emergency suction on the home-bathing side, and ask visiting nursing for
the continuing treatment. Section 05 is re-tightened to four lines a
column so page 1 still holds it; verified by rendering.

Co-Authored-By: Claude Opus 5 <noreply@anthropic.com>
Claude-Session: https://claude.ai/code/session_01EuVvTjbyv3WUxHVeG4YeGS
</commit_message>
<xml_diff>
--- a/houmon-nyuyoku-slides.pptx
+++ b/houmon-nyuyoku-slides.pptx
@@ -20517,29 +20517,7 @@
                 <a:ea typeface="Meiryo" pitchFamily="34" charset="-122"/>
                 <a:cs typeface="Meiryo" pitchFamily="34" charset="-120"/>
               </a:rPr>
-              <a:t>訪問入浴は介護保険サービスであり、</a:t>
-            </a:r>
-            <a:r>
-              <a:rPr lang="en-US" sz="1500" b="1" dirty="0">
-                <a:solidFill>
-                  <a:srgbClr val="1D9E75"/>
-                </a:solidFill>
-                <a:latin typeface="Meiryo" pitchFamily="34" charset="0"/>
-                <a:ea typeface="Meiryo" pitchFamily="34" charset="-122"/>
-                <a:cs typeface="Meiryo" pitchFamily="34" charset="-120"/>
-              </a:rPr>
-              <a:t>医療行為は行えません</a:t>
-            </a:r>
-            <a:r>
-              <a:rPr lang="en-US" sz="1500" dirty="0">
-                <a:solidFill>
-                  <a:srgbClr val="1A5276"/>
-                </a:solidFill>
-                <a:latin typeface="Meiryo" pitchFamily="34" charset="0"/>
-                <a:ea typeface="Meiryo" pitchFamily="34" charset="-122"/>
-                <a:cs typeface="Meiryo" pitchFamily="34" charset="-120"/>
-              </a:rPr>
-              <a:t>。だからこそ訪問看護との連携が欠かせません。</a:t>
+              <a:t>訪問入浴は介護保険のサービスです。医療保険で動く訪問看護とは、担う範囲が違います。</a:t>
             </a:r>
             <a:endParaRPr lang="en-US" sz="1500" dirty="0"/>
           </a:p>
@@ -20655,127 +20633,69 @@
                 <a:ea typeface="Meiryo" pitchFamily="34" charset="-122"/>
                 <a:cs typeface="Meiryo" pitchFamily="34" charset="-120"/>
               </a:rPr>
-              <a:t>バイタル測定と</a:t>
-            </a:r>
-            <a:r>
-              <a:rPr lang="en-US" b="1" dirty="0">
-                <a:solidFill>
-                  <a:srgbClr val="1D9E75"/>
-                </a:solidFill>
-                <a:latin typeface="Meiryo" pitchFamily="34" charset="0"/>
-                <a:ea typeface="Meiryo" pitchFamily="34" charset="-122"/>
-                <a:cs typeface="Meiryo" pitchFamily="34" charset="-120"/>
-              </a:rPr>
-              <a:t>入浴可否の判断</a:t>
+              <a:t>バイタル測定と入浴可否の判断</a:t>
             </a:r>
             <a:endParaRPr lang="en-US" dirty="0"/>
           </a:p>
           <a:p>
-            <a:pPr marL="342900" indent="-342900">
-              <a:spcAft>
-                <a:spcPts val="600"/>
-              </a:spcAft>
-              <a:buSzPct val="100000"/>
-              <a:buChar char="●"/>
-            </a:pPr>
-            <a:r>
-              <a:rPr lang="en-US" dirty="0">
+            <a:pPr/>
+            <a:r>
+              <a:rPr>
                 <a:solidFill>
                   <a:srgbClr val="1C2833"/>
                 </a:solidFill>
-                <a:latin typeface="Meiryo" pitchFamily="34" charset="0"/>
-                <a:ea typeface="Meiryo" pitchFamily="34" charset="-122"/>
-                <a:cs typeface="Meiryo" pitchFamily="34" charset="-120"/>
-              </a:rPr>
-              <a:t>入浴時の</a:t>
-            </a:r>
-            <a:r>
-              <a:rPr lang="en-US" b="1" dirty="0">
-                <a:solidFill>
-                  <a:srgbClr val="1D9E75"/>
-                </a:solidFill>
-                <a:latin typeface="Meiryo" pitchFamily="34" charset="0"/>
-                <a:ea typeface="Meiryo" pitchFamily="34" charset="-122"/>
-                <a:cs typeface="Meiryo" pitchFamily="34" charset="-120"/>
-              </a:rPr>
-              <a:t>全身観察</a:t>
-            </a:r>
-            <a:r>
-              <a:rPr lang="en-US" dirty="0">
+                <a:latin typeface="Meiryo"/>
+              </a:rPr>
+              <a:t>入浴時の全身観察（褥瘡・浮腫・皮膚）</a:t>
+            </a:r>
+          </a:p>
+          <a:p>
+            <a:pPr/>
+            <a:r>
+              <a:rPr>
                 <a:solidFill>
                   <a:srgbClr val="1C2833"/>
                 </a:solidFill>
-                <a:latin typeface="Meiryo" pitchFamily="34" charset="0"/>
-                <a:ea typeface="Meiryo" pitchFamily="34" charset="-122"/>
-                <a:cs typeface="Meiryo" pitchFamily="34" charset="-120"/>
-              </a:rPr>
-              <a:t>（褥瘡・浮腫・皮膚）</a:t>
-            </a:r>
-            <a:endParaRPr lang="en-US" dirty="0"/>
-          </a:p>
-          <a:p>
-            <a:pPr marL="342900" indent="-342900">
-              <a:spcAft>
-                <a:spcPts val="600"/>
-              </a:spcAft>
-              <a:buSzPct val="100000"/>
-              <a:buChar char="●"/>
-            </a:pPr>
-            <a:r>
-              <a:rPr lang="en-US" dirty="0">
+                <a:latin typeface="Meiryo"/>
+              </a:rPr>
+              <a:t>洗身・洗髪と日常的な保湿ケア</a:t>
+            </a:r>
+          </a:p>
+          <a:p>
+            <a:pPr/>
+            <a:r>
+              <a:rPr>
                 <a:solidFill>
                   <a:srgbClr val="1C2833"/>
                 </a:solidFill>
-                <a:latin typeface="Meiryo" pitchFamily="34" charset="0"/>
-                <a:ea typeface="Meiryo" pitchFamily="34" charset="-122"/>
-                <a:cs typeface="Meiryo" pitchFamily="34" charset="-120"/>
-              </a:rPr>
-              <a:t>洗身・洗髪と</a:t>
-            </a:r>
-            <a:r>
-              <a:rPr lang="en-US" b="1" dirty="0">
-                <a:solidFill>
-                  <a:srgbClr val="1D9E75"/>
-                </a:solidFill>
-                <a:latin typeface="Meiryo" pitchFamily="34" charset="0"/>
-                <a:ea typeface="Meiryo" pitchFamily="34" charset="-122"/>
-                <a:cs typeface="Meiryo" pitchFamily="34" charset="-120"/>
-              </a:rPr>
-              <a:t>日常的な保湿ケア</a:t>
-            </a:r>
-            <a:endParaRPr lang="en-US" dirty="0"/>
-          </a:p>
-          <a:p>
-            <a:pPr marL="342900" indent="-342900">
-              <a:spcAft>
-                <a:spcPts val="600"/>
-              </a:spcAft>
-              <a:buSzPct val="100000"/>
-              <a:buChar char="●"/>
-            </a:pPr>
-            <a:r>
-              <a:rPr lang="en-US" dirty="0">
+                <a:latin typeface="Meiryo"/>
+              </a:rPr>
+              <a:t>処方された軟膏の塗布（褥瘡の処置を除く）</a:t>
+            </a:r>
+          </a:p>
+          <a:p>
+            <a:pPr/>
+            <a:r>
+              <a:rPr>
                 <a:solidFill>
                   <a:srgbClr val="1C2833"/>
                 </a:solidFill>
-                <a:latin typeface="Meiryo" pitchFamily="34" charset="0"/>
-                <a:ea typeface="Meiryo" pitchFamily="34" charset="-122"/>
-                <a:cs typeface="Meiryo" pitchFamily="34" charset="-120"/>
-              </a:rPr>
-              <a:t>観察所見の</a:t>
-            </a:r>
-            <a:r>
-              <a:rPr lang="en-US" b="1" dirty="0">
-                <a:solidFill>
-                  <a:srgbClr val="1D9E75"/>
-                </a:solidFill>
-                <a:latin typeface="Meiryo" pitchFamily="34" charset="0"/>
-                <a:ea typeface="Meiryo" pitchFamily="34" charset="-122"/>
-                <a:cs typeface="Meiryo" pitchFamily="34" charset="-120"/>
-              </a:rPr>
-              <a:t>記録と当日中の報告</a:t>
-            </a:r>
-            <a:endParaRPr lang="en-US" dirty="0"/>
+                <a:latin typeface="Meiryo"/>
+              </a:rPr>
+              <a:t>急変時の応急対応・吸引</a:t>
+            </a:r>
+          </a:p>
+          <a:p>
+            <a:pPr/>
+            <a:r>
+              <a:rPr>
+                <a:solidFill>
+                  <a:srgbClr val="1C2833"/>
+                </a:solidFill>
+                <a:latin typeface="Meiryo"/>
+              </a:rPr>
+              <a:t>観察所見の記録と当日中の報告</a:t>
+            </a:r>
           </a:p>
         </p:txBody>
       </p:sp>
@@ -20846,7 +20766,7 @@
                 <a:ea typeface="Meiryo" pitchFamily="34" charset="-122"/>
                 <a:cs typeface="Meiryo" pitchFamily="34" charset="-120"/>
               </a:rPr>
-              <a:t>訪問看護におつなぎすること</a:t>
+              <a:t>訪問看護にお願いしたいこと</a:t>
             </a:r>
             <a:endParaRPr lang="en-US" sz="1500" dirty="0"/>
           </a:p>
@@ -20889,126 +20809,57 @@
                 <a:ea typeface="Meiryo" pitchFamily="34" charset="-122"/>
                 <a:cs typeface="Meiryo" pitchFamily="34" charset="-120"/>
               </a:rPr>
-              <a:t>褥瘡・創傷の</a:t>
-            </a:r>
-            <a:r>
-              <a:rPr lang="en-US" sz="1600" b="1" dirty="0">
-                <a:solidFill>
-                  <a:srgbClr val="1D9E75"/>
-                </a:solidFill>
-                <a:latin typeface="Meiryo" pitchFamily="34" charset="0"/>
-                <a:ea typeface="Meiryo" pitchFamily="34" charset="-122"/>
-                <a:cs typeface="Meiryo" pitchFamily="34" charset="-120"/>
-              </a:rPr>
-              <a:t>処置</a:t>
-            </a:r>
-            <a:r>
-              <a:rPr lang="en-US" sz="1600" dirty="0">
+              <a:t>褥瘡・創傷の継続的な処置</a:t>
+            </a:r>
+            <a:endParaRPr lang="en-US" sz="1600" dirty="0"/>
+          </a:p>
+          <a:p>
+            <a:pPr/>
+            <a:r>
+              <a:rPr sz="1600">
                 <a:solidFill>
                   <a:srgbClr val="1C2833"/>
                 </a:solidFill>
-                <a:latin typeface="Meiryo" pitchFamily="34" charset="0"/>
-                <a:ea typeface="Meiryo" pitchFamily="34" charset="-122"/>
-                <a:cs typeface="Meiryo" pitchFamily="34" charset="-120"/>
-              </a:rPr>
-              <a:t>、薬剤の塗布</a:t>
-            </a:r>
-            <a:endParaRPr lang="en-US" sz="1600" dirty="0"/>
-          </a:p>
-          <a:p>
-            <a:pPr marL="342900" indent="-342900">
-              <a:spcAft>
-                <a:spcPts val="600"/>
-              </a:spcAft>
-              <a:buSzPct val="100000"/>
-              <a:buChar char="●"/>
-            </a:pPr>
-            <a:r>
-              <a:rPr lang="en-US" sz="1600" dirty="0">
+                <a:latin typeface="Meiryo"/>
+              </a:rPr>
+              <a:t>点滴・注射・採血</a:t>
+            </a:r>
+          </a:p>
+          <a:p>
+            <a:pPr/>
+            <a:r>
+              <a:rPr sz="1600">
                 <a:solidFill>
                   <a:srgbClr val="1C2833"/>
                 </a:solidFill>
-                <a:latin typeface="Meiryo" pitchFamily="34" charset="0"/>
-                <a:ea typeface="Meiryo" pitchFamily="34" charset="-122"/>
-                <a:cs typeface="Meiryo" pitchFamily="34" charset="-120"/>
-              </a:rPr>
-              <a:t>点滴・注射・採血</a:t>
-            </a:r>
-            <a:endParaRPr lang="en-US" sz="1600" dirty="0"/>
-          </a:p>
-          <a:p>
-            <a:pPr marL="342900" indent="-342900">
-              <a:spcAft>
-                <a:spcPts val="600"/>
-              </a:spcAft>
-              <a:buSzPct val="100000"/>
-              <a:buChar char="●"/>
-            </a:pPr>
-            <a:r>
-              <a:rPr lang="en-US" sz="1600" dirty="0">
+                <a:latin typeface="Meiryo"/>
+              </a:rPr>
+              <a:t>カテーテル・ストーマの管理</a:t>
+            </a:r>
+          </a:p>
+          <a:p>
+            <a:pPr/>
+            <a:r>
+              <a:rPr sz="1600">
                 <a:solidFill>
                   <a:srgbClr val="1C2833"/>
                 </a:solidFill>
-                <a:latin typeface="Meiryo" pitchFamily="34" charset="0"/>
-                <a:ea typeface="Meiryo" pitchFamily="34" charset="-122"/>
-                <a:cs typeface="Meiryo" pitchFamily="34" charset="-120"/>
-              </a:rPr>
-              <a:t>カテーテル・ストーマの管理</a:t>
-            </a:r>
-            <a:endParaRPr lang="en-US" sz="1600" dirty="0"/>
-          </a:p>
-          <a:p>
-            <a:pPr marL="342900" indent="-342900">
-              <a:spcAft>
-                <a:spcPts val="600"/>
-              </a:spcAft>
-              <a:buSzPct val="100000"/>
-              <a:buChar char="●"/>
-            </a:pPr>
-            <a:r>
-              <a:rPr lang="en-US" sz="1600" dirty="0">
+                <a:latin typeface="Meiryo"/>
+              </a:rPr>
+              <a:t>計画的な喀痰吸引・経管栄養の管理</a:t>
+            </a:r>
+          </a:p>
+          <a:p>
+            <a:pPr/>
+            <a:r>
+              <a:rPr sz="1600">
                 <a:solidFill>
                   <a:srgbClr val="1C2833"/>
                 </a:solidFill>
-                <a:latin typeface="Meiryo" pitchFamily="34" charset="0"/>
-                <a:ea typeface="Meiryo" pitchFamily="34" charset="-122"/>
-                <a:cs typeface="Meiryo" pitchFamily="34" charset="-120"/>
-              </a:rPr>
-              <a:t>喀痰吸引・経管栄養の管理</a:t>
-            </a:r>
-            <a:endParaRPr lang="en-US" sz="1600" dirty="0"/>
-          </a:p>
-          <a:p>
-            <a:pPr marL="342900" indent="-342900">
-              <a:spcAft>
-                <a:spcPts val="600"/>
-              </a:spcAft>
-              <a:buSzPct val="100000"/>
-              <a:buChar char="●"/>
-            </a:pPr>
-            <a:r>
-              <a:rPr lang="en-US" sz="1600" dirty="0">
-                <a:solidFill>
-                  <a:srgbClr val="1C2833"/>
-                </a:solidFill>
-                <a:latin typeface="Meiryo" pitchFamily="34" charset="0"/>
-                <a:ea typeface="Meiryo" pitchFamily="34" charset="-122"/>
-                <a:cs typeface="Meiryo" pitchFamily="34" charset="-120"/>
-              </a:rPr>
-              <a:t>医師の指示に基づく</a:t>
-            </a:r>
-            <a:r>
-              <a:rPr lang="en-US" sz="1600" b="1" dirty="0">
-                <a:solidFill>
-                  <a:srgbClr val="1D9E75"/>
-                </a:solidFill>
-                <a:latin typeface="Meiryo" pitchFamily="34" charset="0"/>
-                <a:ea typeface="Meiryo" pitchFamily="34" charset="-122"/>
-                <a:cs typeface="Meiryo" pitchFamily="34" charset="-120"/>
-              </a:rPr>
-              <a:t>医療的ケア全般</a:t>
-            </a:r>
-            <a:endParaRPr lang="en-US" sz="1600" dirty="0"/>
+                <a:latin typeface="Meiryo"/>
+              </a:rPr>
+              <a:t>医師の指示に基づく計画的な医療的ケア</a:t>
+            </a:r>
           </a:p>
         </p:txBody>
       </p:sp>
@@ -21082,29 +20933,7 @@
                 <a:ea typeface="Meiryo" pitchFamily="34" charset="-122"/>
                 <a:cs typeface="Meiryo" pitchFamily="34" charset="-120"/>
               </a:rPr>
-              <a:t>私たちの役割は</a:t>
-            </a:r>
-            <a:r>
-              <a:rPr lang="en-US" b="1" dirty="0" err="1">
-                <a:solidFill>
-                  <a:srgbClr val="1D9E75"/>
-                </a:solidFill>
-                <a:latin typeface="Meiryo" pitchFamily="34" charset="0"/>
-                <a:ea typeface="Meiryo" pitchFamily="34" charset="-122"/>
-                <a:cs typeface="Meiryo" pitchFamily="34" charset="-120"/>
-              </a:rPr>
-              <a:t>「見つけて、つなぐ」</a:t>
-            </a:r>
-            <a:r>
-              <a:rPr lang="en-US" dirty="0" err="1">
-                <a:solidFill>
-                  <a:srgbClr val="1C2833"/>
-                </a:solidFill>
-                <a:latin typeface="Meiryo" pitchFamily="34" charset="0"/>
-                <a:ea typeface="Meiryo" pitchFamily="34" charset="-122"/>
-                <a:cs typeface="Meiryo" pitchFamily="34" charset="-120"/>
-              </a:rPr>
-              <a:t>こと。処置は訪問看護へ</a:t>
+              <a:t>「できない」のではなく、継続的に担うのが私たちの役割ではない、ということです。</a:t>
             </a:r>
             <a:endParaRPr lang="en-US" dirty="0">
               <a:solidFill>
@@ -21116,35 +20945,20 @@
             </a:endParaRPr>
           </a:p>
           <a:p>
-            <a:pPr marL="0" indent="0">
+            <a:pPr>
               <a:lnSpc>
                 <a:spcPct val="130000"/>
               </a:lnSpc>
-              <a:buNone/>
             </a:pPr>
             <a:r>
-              <a:rPr lang="en-US" dirty="0" err="1">
+              <a:rPr>
                 <a:solidFill>
                   <a:srgbClr val="1C2833"/>
                 </a:solidFill>
-                <a:latin typeface="Meiryo" pitchFamily="34" charset="0"/>
-                <a:ea typeface="Meiryo" pitchFamily="34" charset="-122"/>
-                <a:cs typeface="Meiryo" pitchFamily="34" charset="-120"/>
-              </a:rPr>
-              <a:t>この線引きを明確にすることが、安全な在宅ケアにつながります</a:t>
-            </a:r>
-            <a:r>
-              <a:rPr lang="en-US" dirty="0">
-                <a:solidFill>
-                  <a:srgbClr val="1C2833"/>
-                </a:solidFill>
-                <a:latin typeface="Meiryo" pitchFamily="34" charset="0"/>
-                <a:ea typeface="Meiryo" pitchFamily="34" charset="-122"/>
-                <a:cs typeface="Meiryo" pitchFamily="34" charset="-120"/>
-              </a:rPr>
-              <a:t>。</a:t>
-            </a:r>
-            <a:endParaRPr lang="en-US" dirty="0"/>
+                <a:latin typeface="Meiryo"/>
+              </a:rPr>
+              <a:t>見つけて、つなぐ。そのうえで、その場でできることはする。</a:t>
+            </a:r>
           </a:p>
         </p:txBody>
       </p:sp>

</xml_diff>

<commit_message>
Record that the team relieves pressure and protects on the spot
The nurse does act on a reddened sacrum — offloading, protecting — and
the script, slide 9, the summary slide and the handout now say so rather
than stopping at "we record and report". The summary's fourth point no
longer claims the service performs no medical acts. Section 01 of the
handout drops a sentence that 04 and 05 already carry, which buys the
line the longer list needs.

Also removes two stale blocks left in プレゼン台本.txt by a bad section
replacement: the old slide 9 body and a duplicate of the demo section.

Co-Authored-By: Claude Opus 5 <noreply@anthropic.com>
Claude-Session: https://claude.ai/code/session_01EuVvTjbyv3WUxHVeG4YeGS
</commit_message>
<xml_diff>
--- a/houmon-nyuyoku-slides.pptx
+++ b/houmon-nyuyoku-slides.pptx
@@ -9920,7 +9920,7 @@
                 <a:ea typeface="Meiryo" pitchFamily="34" charset="-122"/>
                 <a:cs typeface="Meiryo" pitchFamily="34" charset="-120"/>
               </a:rPr>
-              <a:t>医療行為は行わず「見つけて、つなぐ」</a:t>
+              <a:t>訪問看護とは役割が違う</a:t>
             </a:r>
             <a:r>
               <a:rPr lang="en-US" sz="1500" dirty="0">
@@ -9931,7 +9931,7 @@
                 <a:ea typeface="Meiryo" pitchFamily="34" charset="-122"/>
                 <a:cs typeface="Meiryo" pitchFamily="34" charset="-120"/>
               </a:rPr>
-              <a:t>——訪問看護と役割を分け合い、その日のうちに情報を共有。</a:t>
+              <a:t>——見つけて、その場でできることはして、つなぐ。継続的な処置は訪問看護へ。</a:t>
             </a:r>
             <a:endParaRPr lang="en-US" sz="1500" dirty="0"/>
           </a:p>
@@ -20682,7 +20682,7 @@
                 </a:solidFill>
                 <a:latin typeface="Meiryo"/>
               </a:rPr>
-              <a:t>急変時の応急対応・吸引</a:t>
+              <a:t>発赤時の除圧・保護、急変時の応急対応・吸引</a:t>
             </a:r>
           </a:p>
           <a:p>

</xml_diff>

<commit_message>
Explain the tub beside the bed during the stretcher demonstration
The stretcher's advantage is not only that three people carry the
weight: the tub stands right beside the bed, so the transfer is level
and parallel with no distance to carry, which is what makes it work in
a cramped house. Added to the script and the slide's speaker notes.

Co-Authored-By: Claude Opus 5 <noreply@anthropic.com>
Claude-Session: https://claude.ai/code/session_01EuVvTjbyv3WUxHVeG4YeGS
</commit_message>
<xml_diff>
--- a/houmon-nyuyoku-slides.pptx
+++ b/houmon-nyuyoku-slides.pptx
@@ -1796,7 +1796,28 @@
           <a:p/>
           <a:p>
             <a:r>
-              <a:t>【担架のときに必ず言う】</a:t>
+              <a:t>【担架のときに必ず言う①＝浴槽の置き方】</a:t>
+            </a:r>
+          </a:p>
+          <a:p>
+            <a:r>
+              <a:t> 浴槽はベッドの真横に設置します。持ち上げて運ぶ距離がありません。</a:t>
+            </a:r>
+          </a:p>
+          <a:p>
+            <a:r>
+              <a:t> ベッドから浴槽へ、平行に、水平に移すだけ。狭いお宅でもこの形がとれます。</a:t>
+            </a:r>
+          </a:p>
+          <a:p>
+            <a:r>
+              <a:t> 移動する距離が短いほど安全。安全に、楽に。</a:t>
+            </a:r>
+          </a:p>
+          <a:p/>
+          <a:p>
+            <a:r>
+              <a:t>【担架のときに必ず言う②】</a:t>
             </a:r>
           </a:p>
           <a:p>

</xml_diff>

<commit_message>
Join the stretcher reasons into one spoken passage
The tub placement, the narrow gap between bed and tub, the tracheostomy
and the ventilator were three separate blocks; they are now one piece of
speech that builds from where the tub stands to why the circuit must not
be pulled. Speaker notes follow.

Co-Authored-By: Claude Opus 5 <noreply@anthropic.com>
Claude-Session: https://claude.ai/code/session_01EuVvTjbyv3WUxHVeG4YeGS
</commit_message>
<xml_diff>
--- a/houmon-nyuyoku-slides.pptx
+++ b/houmon-nyuyoku-slides.pptx
@@ -1796,43 +1796,37 @@
           <a:p/>
           <a:p>
             <a:r>
-              <a:t>【担架のときに必ず言う①＝浴槽の置き方】</a:t>
-            </a:r>
-          </a:p>
-          <a:p>
-            <a:r>
-              <a:t> 浴槽はベッドの真横に設置します。持ち上げて運ぶ距離がありません。</a:t>
-            </a:r>
-          </a:p>
-          <a:p>
-            <a:r>
-              <a:t> ベッドから浴槽へ、平行に、水平に移すだけ。狭いお宅でもこの形がとれます。</a:t>
-            </a:r>
-          </a:p>
-          <a:p>
-            <a:r>
-              <a:t> 移動する距離が短いほど安全。安全に、楽に。</a:t>
-            </a:r>
-          </a:p>
-          <a:p/>
-          <a:p>
-            <a:r>
-              <a:t>【担架のときに必ず言う②】</a:t>
-            </a:r>
-          </a:p>
-          <a:p>
-            <a:r>
-              <a:t> 人工呼吸器を外せない方は、必ず担架です。</a:t>
-            </a:r>
-          </a:p>
-          <a:p>
-            <a:r>
-              <a:t> ほかの方法だと回路が引っ張られて、外れる恐れがあるので。</a:t>
-            </a:r>
-          </a:p>
-          <a:p>
-            <a:r>
-              <a:t> 気管切開の方も、頸部を安定させたいので担架を選びます。</a:t>
+              <a:t>【担架のときに言うこと（ひと続きで）】</a:t>
+            </a:r>
+          </a:p>
+          <a:p>
+            <a:r>
+              <a:t> 体の大きい方、全介助の方。いちばん安全。</a:t>
+            </a:r>
+          </a:p>
+          <a:p>
+            <a:r>
+              <a:t> 浴槽はベッドの真横に設置 → 持ち上げて運ぶ距離がない。平行に、水平に移すだけ。</a:t>
+            </a:r>
+          </a:p>
+          <a:p>
+            <a:r>
+              <a:t> ベッドと浴槽の隙間が狭い部屋でもこの平行移動ならできる。狭いお宅ほど担架。</a:t>
+            </a:r>
+          </a:p>
+          <a:p>
+            <a:r>
+              <a:t> 気管切開の方も担架。頸部を安定させたまま水平に移せる。</a:t>
+            </a:r>
+          </a:p>
+          <a:p>
+            <a:r>
+              <a:t> 人工呼吸器を外せない方は必ず担架。回路が引っ張られて外れる恐れがあるので。</a:t>
+            </a:r>
+          </a:p>
+          <a:p>
+            <a:r>
+              <a:t> 締め「平行に、距離を動かさずに移す。これが担架を選ぶいちばんの理由です」</a:t>
             </a:r>
           </a:p>
           <a:p/>

</xml_diff>